<commit_message>
PRESNTATION UPDATE AND DIAGRAM
</commit_message>
<xml_diff>
--- a/EGT307 PRESENTATION.pptx
+++ b/EGT307 PRESENTATION.pptx
@@ -5,24 +5,30 @@
     <p:sldMasterId id="2147483917" r:id="rId4"/>
   </p:sldMasterIdLst>
   <p:notesMasterIdLst>
-    <p:notesMasterId r:id="rId17"/>
+    <p:notesMasterId r:id="rId23"/>
   </p:notesMasterIdLst>
   <p:handoutMasterIdLst>
-    <p:handoutMasterId r:id="rId18"/>
+    <p:handoutMasterId r:id="rId24"/>
   </p:handoutMasterIdLst>
   <p:sldIdLst>
     <p:sldId id="264" r:id="rId5"/>
-    <p:sldId id="265" r:id="rId6"/>
-    <p:sldId id="272" r:id="rId7"/>
-    <p:sldId id="266" r:id="rId8"/>
-    <p:sldId id="275" r:id="rId9"/>
-    <p:sldId id="276" r:id="rId10"/>
-    <p:sldId id="267" r:id="rId11"/>
-    <p:sldId id="268" r:id="rId12"/>
-    <p:sldId id="269" r:id="rId13"/>
-    <p:sldId id="270" r:id="rId14"/>
-    <p:sldId id="271" r:id="rId15"/>
-    <p:sldId id="274" r:id="rId16"/>
+    <p:sldId id="272" r:id="rId6"/>
+    <p:sldId id="278" r:id="rId7"/>
+    <p:sldId id="279" r:id="rId8"/>
+    <p:sldId id="280" r:id="rId9"/>
+    <p:sldId id="275" r:id="rId10"/>
+    <p:sldId id="276" r:id="rId11"/>
+    <p:sldId id="277" r:id="rId12"/>
+    <p:sldId id="281" r:id="rId13"/>
+    <p:sldId id="282" r:id="rId14"/>
+    <p:sldId id="283" r:id="rId15"/>
+    <p:sldId id="284" r:id="rId16"/>
+    <p:sldId id="267" r:id="rId17"/>
+    <p:sldId id="268" r:id="rId18"/>
+    <p:sldId id="269" r:id="rId19"/>
+    <p:sldId id="270" r:id="rId20"/>
+    <p:sldId id="271" r:id="rId21"/>
+    <p:sldId id="274" r:id="rId22"/>
   </p:sldIdLst>
   <p:sldSz cx="12192000" cy="6858000"/>
   <p:notesSz cx="6858000" cy="9144000"/>
@@ -235,7 +241,7 @@
           <a:p>
             <a:fld id="{D5D1EC30-5B0B-48D0-A1A8-66A96720DF24}" type="datetimeFigureOut">
               <a:rPr lang="en-US" smtClean="0"/>
-              <a:t>7/16/2026</a:t>
+              <a:t>7/19/2026</a:t>
             </a:fld>
             <a:endParaRPr lang="en-US" dirty="0"/>
           </a:p>
@@ -412,7 +418,7 @@
           <a:p>
             <a:fld id="{69F68A4D-42A7-45F7-9930-00E8DCB48D7E}" type="datetimeFigureOut">
               <a:rPr lang="en-US" smtClean="0"/>
-              <a:t>7/16/2026</a:t>
+              <a:t>7/19/2026</a:t>
             </a:fld>
             <a:endParaRPr lang="en-US" dirty="0"/>
           </a:p>
@@ -679,6 +685,90 @@
 </p:notesMaster>
 </file>
 
+<file path=ppt/notesSlides/notesSlide1.xml><?xml version="1.0" encoding="utf-8"?>
+<p:notes xmlns:a="http://schemas.openxmlformats.org/drawingml/2006/main" xmlns:r="http://schemas.openxmlformats.org/officeDocument/2006/relationships" xmlns:p="http://schemas.openxmlformats.org/presentationml/2006/main">
+  <p:cSld>
+    <p:spTree>
+      <p:nvGrpSpPr>
+        <p:cNvPr id="1" name=""/>
+        <p:cNvGrpSpPr/>
+        <p:nvPr/>
+      </p:nvGrpSpPr>
+      <p:grpSpPr>
+        <a:xfrm>
+          <a:off x="0" y="0"/>
+          <a:ext cx="0" cy="0"/>
+          <a:chOff x="0" y="0"/>
+          <a:chExt cx="0" cy="0"/>
+        </a:xfrm>
+      </p:grpSpPr>
+      <p:sp>
+        <p:nvSpPr>
+          <p:cNvPr id="2" name="Slide Image Placeholder 1"/>
+          <p:cNvSpPr>
+            <a:spLocks noGrp="1" noRot="1" noChangeAspect="1"/>
+          </p:cNvSpPr>
+          <p:nvPr>
+            <p:ph type="sldImg"/>
+          </p:nvPr>
+        </p:nvSpPr>
+        <p:spPr/>
+      </p:sp>
+      <p:sp>
+        <p:nvSpPr>
+          <p:cNvPr id="3" name="Notes Placeholder 2"/>
+          <p:cNvSpPr>
+            <a:spLocks noGrp="1"/>
+          </p:cNvSpPr>
+          <p:nvPr>
+            <p:ph type="body" idx="1"/>
+          </p:nvPr>
+        </p:nvSpPr>
+        <p:spPr/>
+        <p:txBody>
+          <a:bodyPr/>
+          <a:lstStyle/>
+          <a:p>
+            <a:endParaRPr lang="en-SG" dirty="0"/>
+          </a:p>
+        </p:txBody>
+      </p:sp>
+      <p:sp>
+        <p:nvSpPr>
+          <p:cNvPr id="4" name="Slide Number Placeholder 3"/>
+          <p:cNvSpPr>
+            <a:spLocks noGrp="1"/>
+          </p:cNvSpPr>
+          <p:nvPr>
+            <p:ph type="sldNum" sz="quarter" idx="5"/>
+          </p:nvPr>
+        </p:nvSpPr>
+        <p:spPr/>
+        <p:txBody>
+          <a:bodyPr/>
+          <a:lstStyle/>
+          <a:p>
+            <a:fld id="{BFDD6F49-EBB7-4CCF-97A8-E526BB28BB69}" type="slidenum">
+              <a:rPr lang="en-US" smtClean="0"/>
+              <a:t>4</a:t>
+            </a:fld>
+            <a:endParaRPr lang="en-US" dirty="0"/>
+          </a:p>
+        </p:txBody>
+      </p:sp>
+    </p:spTree>
+    <p:extLst>
+      <p:ext uri="{BB962C8B-B14F-4D97-AF65-F5344CB8AC3E}">
+        <p14:creationId xmlns:p14="http://schemas.microsoft.com/office/powerpoint/2010/main" val="2402005802"/>
+      </p:ext>
+    </p:extLst>
+  </p:cSld>
+  <p:clrMapOvr>
+    <a:masterClrMapping/>
+  </p:clrMapOvr>
+</p:notes>
+</file>
+
 <file path=ppt/slideLayouts/slideLayout1.xml><?xml version="1.0" encoding="utf-8"?>
 <p:sldLayout xmlns:a="http://schemas.openxmlformats.org/drawingml/2006/main" xmlns:r="http://schemas.openxmlformats.org/officeDocument/2006/relationships" xmlns:p="http://schemas.openxmlformats.org/presentationml/2006/main" preserve="1" userDrawn="1">
   <p:cSld name="Title">
@@ -1889,7 +1979,7 @@
           <a:p>
             <a:fld id="{EBC9FF77-C2BC-3842-9757-C2EBADB34099}" type="datetime1">
               <a:rPr lang="en-US" smtClean="0"/>
-              <a:t>7/16/2026</a:t>
+              <a:t>7/19/2026</a:t>
             </a:fld>
             <a:endParaRPr lang="en-US" dirty="0"/>
           </a:p>
@@ -2253,7 +2343,7 @@
           <a:p>
             <a:fld id="{010D0AB2-23BC-3043-AC30-5928E542C0CE}" type="datetime1">
               <a:rPr lang="en-US" smtClean="0"/>
-              <a:t>7/16/2026</a:t>
+              <a:t>7/19/2026</a:t>
             </a:fld>
             <a:endParaRPr lang="en-US" dirty="0"/>
           </a:p>
@@ -2779,7 +2869,7 @@
           <a:p>
             <a:fld id="{3EE24C61-4277-DA47-BF4A-DCEFD7F4C6B4}" type="datetime1">
               <a:rPr lang="en-US" smtClean="0"/>
-              <a:t>7/16/2026</a:t>
+              <a:t>7/19/2026</a:t>
             </a:fld>
             <a:endParaRPr lang="en-US" dirty="0"/>
           </a:p>
@@ -3305,7 +3395,7 @@
           <a:p>
             <a:fld id="{53D1C53B-D534-AA48-85B3-4F5B03DDCBA8}" type="datetime1">
               <a:rPr lang="en-US" smtClean="0"/>
-              <a:t>7/16/2026</a:t>
+              <a:t>7/19/2026</a:t>
             </a:fld>
             <a:endParaRPr lang="en-US" dirty="0"/>
           </a:p>
@@ -3951,7 +4041,7 @@
           <a:p>
             <a:fld id="{B2A7CB4E-BD8C-8E4D-91FF-B1939559C134}" type="datetime1">
               <a:rPr lang="en-US" smtClean="0"/>
-              <a:t>7/16/2026</a:t>
+              <a:t>7/19/2026</a:t>
             </a:fld>
             <a:endParaRPr lang="en-US" dirty="0"/>
           </a:p>
@@ -4560,7 +4650,7 @@
           <a:p>
             <a:fld id="{4142E188-D61A-9842-B8A2-1559B3399613}" type="datetime1">
               <a:rPr lang="en-US" smtClean="0"/>
-              <a:t>7/16/2026</a:t>
+              <a:t>7/19/2026</a:t>
             </a:fld>
             <a:endParaRPr lang="en-US" dirty="0"/>
           </a:p>
@@ -5131,7 +5221,7 @@
           <a:p>
             <a:fld id="{0D0C1909-8EA0-3E44-B1AC-A9EA56584238}" type="datetime1">
               <a:rPr lang="en-US" smtClean="0"/>
-              <a:t>7/16/2026</a:t>
+              <a:t>7/19/2026</a:t>
             </a:fld>
             <a:endParaRPr lang="en-US" dirty="0"/>
           </a:p>
@@ -5670,7 +5760,7 @@
           <a:p>
             <a:fld id="{C752DD5A-B150-8340-8E59-4C8F3F7E3A59}" type="datetime1">
               <a:rPr lang="en-US" smtClean="0"/>
-              <a:t>7/16/2026</a:t>
+              <a:t>7/19/2026</a:t>
             </a:fld>
             <a:endParaRPr lang="en-US" dirty="0"/>
           </a:p>
@@ -6179,7 +6269,7 @@
           <a:p>
             <a:fld id="{0FD936B8-E398-1A41-8DE9-58DDB113FEEA}" type="datetime1">
               <a:rPr lang="en-US" smtClean="0"/>
-              <a:t>7/16/2026</a:t>
+              <a:t>7/19/2026</a:t>
             </a:fld>
             <a:endParaRPr lang="en-US" dirty="0"/>
           </a:p>
@@ -6677,7 +6767,7 @@
           <a:p>
             <a:fld id="{927C0DEB-4AE1-EA4D-826D-E3C22802B942}" type="datetime1">
               <a:rPr lang="en-US" smtClean="0"/>
-              <a:t>7/16/2026</a:t>
+              <a:t>7/19/2026</a:t>
             </a:fld>
             <a:endParaRPr lang="en-US" dirty="0"/>
           </a:p>
@@ -7162,7 +7252,7 @@
           <a:p>
             <a:fld id="{BE2752B3-7BF7-614C-A80A-1256FFE41AD1}" type="datetime1">
               <a:rPr lang="en-US" smtClean="0"/>
-              <a:t>7/16/2026</a:t>
+              <a:t>7/19/2026</a:t>
             </a:fld>
             <a:endParaRPr lang="en-US" dirty="0"/>
           </a:p>
@@ -7616,7 +7706,7 @@
           <a:p>
             <a:fld id="{40482BA7-8406-1C47-9A76-988652CA5787}" type="datetime1">
               <a:rPr lang="en-US" smtClean="0"/>
-              <a:t>7/16/2026</a:t>
+              <a:t>7/19/2026</a:t>
             </a:fld>
             <a:endParaRPr lang="en-US" dirty="0"/>
           </a:p>
@@ -8173,7 +8263,7 @@
           <a:p>
             <a:fld id="{79F03E26-E542-1A4D-AC7A-1E4E95BAEC6A}" type="datetime1">
               <a:rPr lang="en-US" smtClean="0"/>
-              <a:t>7/16/2026</a:t>
+              <a:t>7/19/2026</a:t>
             </a:fld>
             <a:endParaRPr lang="en-US" dirty="0"/>
           </a:p>
@@ -8771,7 +8861,7 @@
           <a:p>
             <a:fld id="{115476B0-E2C7-E147-B9CE-3E274E847A52}" type="datetime1">
               <a:rPr lang="en-US" smtClean="0"/>
-              <a:t>7/16/2026</a:t>
+              <a:t>7/19/2026</a:t>
             </a:fld>
             <a:endParaRPr lang="en-US" dirty="0"/>
           </a:p>
@@ -9369,7 +9459,7 @@
           <a:p>
             <a:fld id="{30D7DCC1-5043-7A46-8443-F8426D5EAB75}" type="datetime1">
               <a:rPr lang="en-US" smtClean="0"/>
-              <a:t>7/16/2026</a:t>
+              <a:t>7/19/2026</a:t>
             </a:fld>
             <a:endParaRPr lang="en-US" dirty="0"/>
           </a:p>
@@ -9969,7 +10059,7 @@
           <a:p>
             <a:fld id="{D1A2963D-70FD-3A42-A53A-2480966C033D}" type="datetime1">
               <a:rPr lang="en-US" smtClean="0"/>
-              <a:t>7/16/2026</a:t>
+              <a:t>7/19/2026</a:t>
             </a:fld>
             <a:endParaRPr lang="en-US" dirty="0"/>
           </a:p>
@@ -10569,7 +10659,7 @@
           <a:p>
             <a:fld id="{F1A8FB16-FCFB-DA44-98E9-136CD51670D6}" type="datetime1">
               <a:rPr lang="en-US" smtClean="0"/>
-              <a:t>7/16/2026</a:t>
+              <a:t>7/19/2026</a:t>
             </a:fld>
             <a:endParaRPr lang="en-US" dirty="0"/>
           </a:p>
@@ -11167,7 +11257,7 @@
           <a:p>
             <a:fld id="{58EFB3A8-11B5-7149-8412-15238624EFFD}" type="datetime1">
               <a:rPr lang="en-US" smtClean="0"/>
-              <a:t>7/16/2026</a:t>
+              <a:t>7/19/2026</a:t>
             </a:fld>
             <a:endParaRPr lang="en-US" dirty="0"/>
           </a:p>
@@ -11765,7 +11855,7 @@
           <a:p>
             <a:fld id="{650FCFAB-53E3-A342-A296-D67E0AB8D0CD}" type="datetime1">
               <a:rPr lang="en-US" smtClean="0"/>
-              <a:t>7/16/2026</a:t>
+              <a:t>7/19/2026</a:t>
             </a:fld>
             <a:endParaRPr lang="en-US" dirty="0"/>
           </a:p>
@@ -12361,7 +12451,7 @@
           <a:p>
             <a:fld id="{8DC46901-11EF-4445-8903-DC36784F331E}" type="datetime1">
               <a:rPr lang="en-US" smtClean="0"/>
-              <a:t>7/16/2026</a:t>
+              <a:t>7/19/2026</a:t>
             </a:fld>
             <a:endParaRPr lang="en-US" dirty="0"/>
           </a:p>
@@ -12890,7 +12980,7 @@
           <a:p>
             <a:fld id="{86A42598-CA8F-5141-9F98-7018240FA786}" type="datetime1">
               <a:rPr lang="en-US" smtClean="0"/>
-              <a:t>7/16/2026</a:t>
+              <a:t>7/19/2026</a:t>
             </a:fld>
             <a:endParaRPr lang="en-US" dirty="0"/>
           </a:p>
@@ -13506,7 +13596,7 @@
           <a:p>
             <a:fld id="{BB5C750C-98D3-2541-9DBA-212130458E4E}" type="datetime1">
               <a:rPr lang="en-US" smtClean="0"/>
-              <a:t>7/16/2026</a:t>
+              <a:t>7/19/2026</a:t>
             </a:fld>
             <a:endParaRPr lang="en-US" dirty="0"/>
           </a:p>
@@ -14106,7 +14196,7 @@
           <a:p>
             <a:fld id="{91C99844-6C9E-BB4D-8B47-7C2CC32AAC02}" type="datetime1">
               <a:rPr lang="en-US" smtClean="0"/>
-              <a:t>7/16/2026</a:t>
+              <a:t>7/19/2026</a:t>
             </a:fld>
             <a:endParaRPr lang="en-US" dirty="0"/>
           </a:p>
@@ -14706,7 +14796,7 @@
           <a:p>
             <a:fld id="{97582611-C0A2-BD42-A8F7-C2F9A013F10C}" type="datetime1">
               <a:rPr lang="en-US" smtClean="0"/>
-              <a:t>7/16/2026</a:t>
+              <a:t>7/19/2026</a:t>
             </a:fld>
             <a:endParaRPr lang="en-US" dirty="0"/>
           </a:p>
@@ -15304,7 +15394,7 @@
           <a:p>
             <a:fld id="{1048417B-2BA9-FC42-993A-F5CAB8ABAB3C}" type="datetime1">
               <a:rPr lang="en-US" smtClean="0"/>
-              <a:t>7/16/2026</a:t>
+              <a:t>7/19/2026</a:t>
             </a:fld>
             <a:endParaRPr lang="en-US" dirty="0"/>
           </a:p>
@@ -15907,7 +15997,7 @@
           <a:p>
             <a:fld id="{B9956DE8-31F3-0C48-AD89-A99E39B5E351}" type="datetime1">
               <a:rPr lang="en-US" smtClean="0"/>
-              <a:t>7/16/2026</a:t>
+              <a:t>7/19/2026</a:t>
             </a:fld>
             <a:endParaRPr lang="en-US" dirty="0"/>
           </a:p>
@@ -16467,7 +16557,7 @@
           <a:p>
             <a:fld id="{1247F170-621E-394E-A3F2-D37D14C6B270}" type="datetime1">
               <a:rPr lang="en-US" smtClean="0"/>
-              <a:t>7/16/2026</a:t>
+              <a:t>7/19/2026</a:t>
             </a:fld>
             <a:endParaRPr lang="en-US" dirty="0"/>
           </a:p>
@@ -17029,7 +17119,7 @@
           <a:p>
             <a:fld id="{3BFEB256-000B-7640-A176-A6ED88FB302B}" type="datetime1">
               <a:rPr lang="en-US" smtClean="0"/>
-              <a:t>7/16/2026</a:t>
+              <a:t>7/19/2026</a:t>
             </a:fld>
             <a:endParaRPr lang="en-US" dirty="0"/>
           </a:p>
@@ -17586,7 +17676,7 @@
           <a:p>
             <a:fld id="{AD187FAD-DCB9-3D4B-B066-9000219F05FB}" type="datetime1">
               <a:rPr lang="en-US" smtClean="0"/>
-              <a:t>7/16/2026</a:t>
+              <a:t>7/19/2026</a:t>
             </a:fld>
             <a:endParaRPr lang="en-US" dirty="0"/>
           </a:p>
@@ -18186,7 +18276,7 @@
           <a:p>
             <a:fld id="{189C5B77-1EC5-224E-B44E-9B7868782731}" type="datetime1">
               <a:rPr lang="en-US" smtClean="0"/>
-              <a:t>7/16/2026</a:t>
+              <a:t>7/19/2026</a:t>
             </a:fld>
             <a:endParaRPr lang="en-US" dirty="0"/>
           </a:p>
@@ -18789,7 +18879,7 @@
           <a:p>
             <a:fld id="{C8F601A6-19D3-EB49-B7F2-A9801AE13DA6}" type="datetime1">
               <a:rPr lang="en-US" smtClean="0"/>
-              <a:t>7/16/2026</a:t>
+              <a:t>7/19/2026</a:t>
             </a:fld>
             <a:endParaRPr lang="en-US" dirty="0"/>
           </a:p>
@@ -19271,7 +19361,7 @@
           <a:p>
             <a:fld id="{FF5D23C8-9820-654D-9C1E-FE1FC23DA807}" type="datetime1">
               <a:rPr lang="en-US" smtClean="0"/>
-              <a:t>7/16/2026</a:t>
+              <a:t>7/19/2026</a:t>
             </a:fld>
             <a:endParaRPr lang="en-US" dirty="0"/>
           </a:p>
@@ -19892,7 +19982,7 @@
           <a:p>
             <a:fld id="{B5DCFA2C-3BE3-964B-9AAF-C20CC59CEE43}" type="datetime1">
               <a:rPr lang="en-US" smtClean="0"/>
-              <a:t>7/16/2026</a:t>
+              <a:t>7/19/2026</a:t>
             </a:fld>
             <a:endParaRPr lang="en-US" dirty="0"/>
           </a:p>
@@ -20330,7 +20420,7 @@
           <a:p>
             <a:fld id="{79A3CDA5-1015-3148-A386-36088AF5334C}" type="datetime1">
               <a:rPr lang="en-US" smtClean="0"/>
-              <a:t>7/16/2026</a:t>
+              <a:t>7/19/2026</a:t>
             </a:fld>
             <a:endParaRPr lang="en-US" dirty="0"/>
           </a:p>
@@ -20765,7 +20855,7 @@
           <a:p>
             <a:fld id="{C112E8AA-E35F-CF44-B5A4-3B5EDD4AC3FC}" type="datetime1">
               <a:rPr lang="en-US" smtClean="0"/>
-              <a:t>7/16/2026</a:t>
+              <a:t>7/19/2026</a:t>
             </a:fld>
             <a:endParaRPr lang="en-US" dirty="0"/>
           </a:p>
@@ -21377,7 +21467,7 @@
           <a:p>
             <a:fld id="{E0FF3B4E-61F2-9C45-A7C9-0649FA3F05AD}" type="datetime1">
               <a:rPr lang="en-US" smtClean="0"/>
-              <a:t>7/16/2026</a:t>
+              <a:t>7/19/2026</a:t>
             </a:fld>
             <a:endParaRPr lang="en-US" dirty="0"/>
           </a:p>
@@ -22002,7 +22092,7 @@
           <a:p>
             <a:fld id="{CC4A289B-0B17-4246-8E33-E89C12A90840}" type="datetime1">
               <a:rPr lang="en-US" smtClean="0"/>
-              <a:t>7/16/2026</a:t>
+              <a:t>7/19/2026</a:t>
             </a:fld>
             <a:endParaRPr lang="en-US" dirty="0"/>
           </a:p>
@@ -22622,7 +22712,7 @@
           <a:p>
             <a:fld id="{C8092CDE-5B88-E044-9012-03F4795B046E}" type="datetime1">
               <a:rPr lang="en-US" smtClean="0"/>
-              <a:t>7/16/2026</a:t>
+              <a:t>7/19/2026</a:t>
             </a:fld>
             <a:endParaRPr lang="en-US" dirty="0"/>
           </a:p>
@@ -23276,7 +23366,7 @@
           <a:p>
             <a:fld id="{EC076D1D-DE21-9B42-8106-8CD72DA85F70}" type="datetime1">
               <a:rPr lang="en-US" smtClean="0"/>
-              <a:t>7/16/2026</a:t>
+              <a:t>7/19/2026</a:t>
             </a:fld>
             <a:endParaRPr lang="en-US" dirty="0"/>
           </a:p>
@@ -23930,7 +24020,7 @@
           <a:p>
             <a:fld id="{57807DC2-592A-C24E-8E32-92959310D82C}" type="datetime1">
               <a:rPr lang="en-US" smtClean="0"/>
-              <a:t>7/16/2026</a:t>
+              <a:t>7/19/2026</a:t>
             </a:fld>
             <a:endParaRPr lang="en-US" dirty="0"/>
           </a:p>
@@ -24617,7 +24707,7 @@
             <a:fld id="{2A17FF52-3D92-5045-83B3-191BF759FA8D}" type="datetime1">
               <a:rPr lang="en-US" smtClean="0"/>
               <a:pPr/>
-              <a:t>7/16/2026</a:t>
+              <a:t>7/19/2026</a:t>
             </a:fld>
             <a:endParaRPr lang="en-US" dirty="0"/>
           </a:p>
@@ -25058,7 +25148,7 @@
             <a:fld id="{17C67708-7A94-8245-80C8-4B4702495DB1}" type="datetime1">
               <a:rPr lang="en-US" smtClean="0"/>
               <a:pPr/>
-              <a:t>7/16/2026</a:t>
+              <a:t>7/19/2026</a:t>
             </a:fld>
             <a:endParaRPr lang="en-US" dirty="0"/>
           </a:p>
@@ -25583,7 +25673,7 @@
           <a:p>
             <a:fld id="{763C345D-F56F-0743-AB88-4EB3E35EF63D}" type="datetime1">
               <a:rPr lang="en-US" smtClean="0"/>
-              <a:t>7/16/2026</a:t>
+              <a:t>7/19/2026</a:t>
             </a:fld>
             <a:endParaRPr lang="en-US" dirty="0"/>
           </a:p>
@@ -26081,7 +26171,7 @@
             <a:fld id="{C3A90753-8D45-EB44-AB23-49A6290D6DA6}" type="datetime1">
               <a:rPr lang="en-US" smtClean="0"/>
               <a:pPr/>
-              <a:t>7/16/2026</a:t>
+              <a:t>7/19/2026</a:t>
             </a:fld>
             <a:endParaRPr lang="en-US" dirty="0"/>
           </a:p>
@@ -26667,7 +26757,7 @@
           <a:p>
             <a:fld id="{C5059AB6-B751-F44D-A28C-E19CFA261A8F}" type="datetime1">
               <a:rPr lang="en-US" smtClean="0"/>
-              <a:t>7/16/2026</a:t>
+              <a:t>7/19/2026</a:t>
             </a:fld>
             <a:endParaRPr lang="en-US" dirty="0"/>
           </a:p>
@@ -27370,7 +27460,7 @@
           <a:p>
             <a:fld id="{F4B7459A-9905-1A4B-AB1A-C91FAC752AC6}" type="datetime1">
               <a:rPr lang="en-US" smtClean="0"/>
-              <a:t>7/16/2026</a:t>
+              <a:t>7/19/2026</a:t>
             </a:fld>
             <a:endParaRPr lang="en-US" dirty="0"/>
           </a:p>
@@ -27753,7 +27843,7 @@
           <a:p>
             <a:fld id="{D255AB00-997D-D540-BC20-37B7E62B26C1}" type="datetime1">
               <a:rPr lang="en-US" smtClean="0"/>
-              <a:t>7/16/2026</a:t>
+              <a:t>7/19/2026</a:t>
             </a:fld>
             <a:endParaRPr lang="en-US" dirty="0"/>
           </a:p>
@@ -28094,7 +28184,7 @@
           <a:p>
             <a:fld id="{69F3ECCF-2CCD-CA4B-8712-AE4484B24AE9}" type="datetime1">
               <a:rPr lang="en-US" smtClean="0"/>
-              <a:t>7/16/2026</a:t>
+              <a:t>7/19/2026</a:t>
             </a:fld>
             <a:endParaRPr lang="en-US" dirty="0"/>
           </a:p>
@@ -28679,7 +28769,7 @@
           <a:p>
             <a:fld id="{22942A74-7D23-DC49-91AA-85B24B3B8A00}" type="datetime1">
               <a:rPr lang="en-US" smtClean="0"/>
-              <a:t>7/16/2026</a:t>
+              <a:t>7/19/2026</a:t>
             </a:fld>
             <a:endParaRPr lang="en-US" dirty="0"/>
           </a:p>
@@ -29232,7 +29322,7 @@
           <a:p>
             <a:fld id="{22A0247B-8639-BE4B-9EB6-99BF33B2FE57}" type="datetime1">
               <a:rPr lang="en-US" smtClean="0"/>
-              <a:t>7/16/2026</a:t>
+              <a:t>7/19/2026</a:t>
             </a:fld>
             <a:endParaRPr lang="en-US" dirty="0"/>
           </a:p>
@@ -29762,7 +29852,7 @@
           <a:p>
             <a:fld id="{162FAA25-3923-0740-83DA-275C59DD4599}" type="datetime1">
               <a:rPr lang="en-US" smtClean="0"/>
-              <a:t>7/16/2026</a:t>
+              <a:t>7/19/2026</a:t>
             </a:fld>
             <a:endParaRPr lang="en-US" dirty="0"/>
           </a:p>
@@ -30253,7 +30343,7 @@
           <a:p>
             <a:fld id="{AB1B52C7-37F9-BD40-8BE5-16C7107F6B2A}" type="datetime1">
               <a:rPr lang="en-US" smtClean="0"/>
-              <a:t>7/16/2026</a:t>
+              <a:t>7/19/2026</a:t>
             </a:fld>
             <a:endParaRPr lang="en-US" dirty="0"/>
           </a:p>
@@ -30970,7 +31060,7 @@
           <a:p>
             <a:fld id="{FF5D23C8-9820-654D-9C1E-FE1FC23DA807}" type="datetime1">
               <a:rPr lang="en-US" smtClean="0"/>
-              <a:t>7/16/2026</a:t>
+              <a:t>7/19/2026</a:t>
             </a:fld>
             <a:endParaRPr lang="en-US" dirty="0"/>
           </a:p>
@@ -31216,7 +31306,7 @@
           <a:p>
             <a:fld id="{5594B28A-4C74-C14A-960D-ABD28BCC0EB4}" type="datetime1">
               <a:rPr lang="en-US" smtClean="0"/>
-              <a:t>7/16/2026</a:t>
+              <a:t>7/19/2026</a:t>
             </a:fld>
             <a:endParaRPr lang="en-US" dirty="0"/>
           </a:p>
@@ -31634,7 +31724,7 @@
           <a:p>
             <a:fld id="{D8CCD23C-B1EB-604C-96F1-0CF64015D152}" type="datetime1">
               <a:rPr lang="en-US" smtClean="0"/>
-              <a:t>7/16/2026</a:t>
+              <a:t>7/19/2026</a:t>
             </a:fld>
             <a:endParaRPr lang="en-US" dirty="0"/>
           </a:p>
@@ -32071,7 +32161,7 @@
           <a:p>
             <a:fld id="{4BE11430-0446-F343-817C-D9D2C78891B0}" type="datetime1">
               <a:rPr lang="en-US" smtClean="0"/>
-              <a:t>7/16/2026</a:t>
+              <a:t>7/19/2026</a:t>
             </a:fld>
             <a:endParaRPr lang="en-US" dirty="0"/>
           </a:p>
@@ -32592,7 +32682,7 @@
             <a:fld id="{6739503E-9C75-484A-A764-D9D8121AAE05}" type="datetime1">
               <a:rPr lang="en-US" smtClean="0"/>
               <a:pPr/>
-              <a:t>7/16/2026</a:t>
+              <a:t>7/19/2026</a:t>
             </a:fld>
             <a:endParaRPr lang="en-US" dirty="0"/>
           </a:p>
@@ -33430,15 +33520,15 @@
           <p:cNvPr id="2" name="Title 1">
             <a:extLst>
               <a:ext uri="{FF2B5EF4-FFF2-40B4-BE49-F238E27FC236}">
-                <a16:creationId xmlns:a16="http://schemas.microsoft.com/office/drawing/2014/main" id="{9DEAAF09-CB58-6E0F-3345-27591FA4FF54}"/>
-              </a:ext>
-            </a:extLst>
-          </p:cNvPr>
-          <p:cNvSpPr>
-            <a:spLocks noGrp="1"/>
-          </p:cNvSpPr>
-          <p:nvPr>
-            <p:ph type="ctrTitle"/>
+                <a16:creationId xmlns:a16="http://schemas.microsoft.com/office/drawing/2014/main" id="{E3CD4FA5-0F16-9080-F2C4-2713CDB98D73}"/>
+              </a:ext>
+            </a:extLst>
+          </p:cNvPr>
+          <p:cNvSpPr>
+            <a:spLocks noGrp="1"/>
+          </p:cNvSpPr>
+          <p:nvPr>
+            <p:ph type="title"/>
           </p:nvPr>
         </p:nvSpPr>
         <p:spPr/>
@@ -33448,7 +33538,7 @@
           <a:p>
             <a:r>
               <a:rPr lang="en-SG" dirty="0"/>
-              <a:t>DATA SOURCE</a:t>
+              <a:t>BACKEND API</a:t>
             </a:r>
           </a:p>
         </p:txBody>
@@ -33458,7 +33548,7 @@
           <p:cNvPr id="3" name="Footer Placeholder 2">
             <a:extLst>
               <a:ext uri="{FF2B5EF4-FFF2-40B4-BE49-F238E27FC236}">
-                <a16:creationId xmlns:a16="http://schemas.microsoft.com/office/drawing/2014/main" id="{3F6A2061-CB22-D700-DFFA-693366FF7DAC}"/>
+                <a16:creationId xmlns:a16="http://schemas.microsoft.com/office/drawing/2014/main" id="{87D4288F-EF10-D916-115B-E02EBF709DBE}"/>
               </a:ext>
             </a:extLst>
           </p:cNvPr>
@@ -33484,18 +33574,18 @@
       </p:sp>
       <p:sp>
         <p:nvSpPr>
-          <p:cNvPr id="4" name="Date Placeholder 3">
-            <a:extLst>
-              <a:ext uri="{FF2B5EF4-FFF2-40B4-BE49-F238E27FC236}">
-                <a16:creationId xmlns:a16="http://schemas.microsoft.com/office/drawing/2014/main" id="{FB2649DC-6302-6FE7-EB8D-567208A1C78E}"/>
-              </a:ext>
-            </a:extLst>
-          </p:cNvPr>
-          <p:cNvSpPr>
-            <a:spLocks noGrp="1"/>
-          </p:cNvSpPr>
-          <p:nvPr>
-            <p:ph type="dt" sz="half" idx="10"/>
+          <p:cNvPr id="4" name="Content Placeholder 3">
+            <a:extLst>
+              <a:ext uri="{FF2B5EF4-FFF2-40B4-BE49-F238E27FC236}">
+                <a16:creationId xmlns:a16="http://schemas.microsoft.com/office/drawing/2014/main" id="{8EBC3E0A-B721-E75C-D747-71415EBBE5BB}"/>
+              </a:ext>
+            </a:extLst>
+          </p:cNvPr>
+          <p:cNvSpPr>
+            <a:spLocks noGrp="1"/>
+          </p:cNvSpPr>
+          <p:nvPr>
+            <p:ph sz="quarter" idx="13"/>
           </p:nvPr>
         </p:nvSpPr>
         <p:spPr/>
@@ -33503,9 +33593,34 @@
           <a:bodyPr/>
           <a:lstStyle/>
           <a:p>
-            <a:fld id="{010D0AB2-23BC-3043-AC30-5928E542C0CE}" type="datetime1">
+            <a:endParaRPr lang="en-SG"/>
+          </a:p>
+        </p:txBody>
+      </p:sp>
+      <p:sp>
+        <p:nvSpPr>
+          <p:cNvPr id="5" name="Date Placeholder 4">
+            <a:extLst>
+              <a:ext uri="{FF2B5EF4-FFF2-40B4-BE49-F238E27FC236}">
+                <a16:creationId xmlns:a16="http://schemas.microsoft.com/office/drawing/2014/main" id="{F346DFDA-D36A-641B-1086-9A4690C23E0E}"/>
+              </a:ext>
+            </a:extLst>
+          </p:cNvPr>
+          <p:cNvSpPr>
+            <a:spLocks noGrp="1"/>
+          </p:cNvSpPr>
+          <p:nvPr>
+            <p:ph type="dt" sz="half" idx="10"/>
+          </p:nvPr>
+        </p:nvSpPr>
+        <p:spPr/>
+        <p:txBody>
+          <a:bodyPr/>
+          <a:lstStyle/>
+          <a:p>
+            <a:fld id="{927C0DEB-4AE1-EA4D-826D-E3C22802B942}" type="datetime1">
               <a:rPr lang="en-US" smtClean="0"/>
-              <a:t>7/16/2026</a:t>
+              <a:t>7/20/2026</a:t>
             </a:fld>
             <a:endParaRPr lang="en-US" dirty="0"/>
           </a:p>
@@ -33513,10 +33628,10 @@
       </p:sp>
       <p:sp>
         <p:nvSpPr>
-          <p:cNvPr id="5" name="Slide Number Placeholder 4">
-            <a:extLst>
-              <a:ext uri="{FF2B5EF4-FFF2-40B4-BE49-F238E27FC236}">
-                <a16:creationId xmlns:a16="http://schemas.microsoft.com/office/drawing/2014/main" id="{66FF4A67-54EF-04B0-A7D5-1AED7EE1442F}"/>
+          <p:cNvPr id="6" name="Slide Number Placeholder 5">
+            <a:extLst>
+              <a:ext uri="{FF2B5EF4-FFF2-40B4-BE49-F238E27FC236}">
+                <a16:creationId xmlns:a16="http://schemas.microsoft.com/office/drawing/2014/main" id="{C127D931-F45C-2EE8-A41C-7C4E0A181684}"/>
               </a:ext>
             </a:extLst>
           </p:cNvPr>
@@ -33544,7 +33659,7 @@
     </p:spTree>
     <p:extLst>
       <p:ext uri="{BB962C8B-B14F-4D97-AF65-F5344CB8AC3E}">
-        <p14:creationId xmlns:p14="http://schemas.microsoft.com/office/powerpoint/2010/main" val="1748166942"/>
+        <p14:creationId xmlns:p14="http://schemas.microsoft.com/office/powerpoint/2010/main" val="2127768817"/>
       </p:ext>
     </p:extLst>
   </p:cSld>
@@ -33576,15 +33691,15 @@
           <p:cNvPr id="2" name="Title 1">
             <a:extLst>
               <a:ext uri="{FF2B5EF4-FFF2-40B4-BE49-F238E27FC236}">
-                <a16:creationId xmlns:a16="http://schemas.microsoft.com/office/drawing/2014/main" id="{EE58C531-7A30-5D0B-55FA-6704B085156E}"/>
-              </a:ext>
-            </a:extLst>
-          </p:cNvPr>
-          <p:cNvSpPr>
-            <a:spLocks noGrp="1"/>
-          </p:cNvSpPr>
-          <p:nvPr>
-            <p:ph type="ctrTitle"/>
+                <a16:creationId xmlns:a16="http://schemas.microsoft.com/office/drawing/2014/main" id="{151996FA-5CDB-38EA-C314-20A7D3B73B1E}"/>
+              </a:ext>
+            </a:extLst>
+          </p:cNvPr>
+          <p:cNvSpPr>
+            <a:spLocks noGrp="1"/>
+          </p:cNvSpPr>
+          <p:nvPr>
+            <p:ph type="title"/>
           </p:nvPr>
         </p:nvSpPr>
         <p:spPr/>
@@ -33594,7 +33709,7 @@
           <a:p>
             <a:r>
               <a:rPr lang="en-SG" dirty="0"/>
-              <a:t>ISSUES AND LIMITATIONS</a:t>
+              <a:t>MACHINE LEARNING</a:t>
             </a:r>
           </a:p>
         </p:txBody>
@@ -33604,7 +33719,7 @@
           <p:cNvPr id="3" name="Footer Placeholder 2">
             <a:extLst>
               <a:ext uri="{FF2B5EF4-FFF2-40B4-BE49-F238E27FC236}">
-                <a16:creationId xmlns:a16="http://schemas.microsoft.com/office/drawing/2014/main" id="{935A7A2C-0E66-E74E-6AAA-46749892E93F}"/>
+                <a16:creationId xmlns:a16="http://schemas.microsoft.com/office/drawing/2014/main" id="{32F2DFD3-85FB-CCD8-8239-D2725E65F67A}"/>
               </a:ext>
             </a:extLst>
           </p:cNvPr>
@@ -33630,18 +33745,18 @@
       </p:sp>
       <p:sp>
         <p:nvSpPr>
-          <p:cNvPr id="4" name="Date Placeholder 3">
-            <a:extLst>
-              <a:ext uri="{FF2B5EF4-FFF2-40B4-BE49-F238E27FC236}">
-                <a16:creationId xmlns:a16="http://schemas.microsoft.com/office/drawing/2014/main" id="{406F36CD-8CAF-F2A3-0961-D2C12A048190}"/>
-              </a:ext>
-            </a:extLst>
-          </p:cNvPr>
-          <p:cNvSpPr>
-            <a:spLocks noGrp="1"/>
-          </p:cNvSpPr>
-          <p:nvPr>
-            <p:ph type="dt" sz="half" idx="10"/>
+          <p:cNvPr id="4" name="Content Placeholder 3">
+            <a:extLst>
+              <a:ext uri="{FF2B5EF4-FFF2-40B4-BE49-F238E27FC236}">
+                <a16:creationId xmlns:a16="http://schemas.microsoft.com/office/drawing/2014/main" id="{711FD2D7-80AB-8915-426E-1B7BB86AD5FA}"/>
+              </a:ext>
+            </a:extLst>
+          </p:cNvPr>
+          <p:cNvSpPr>
+            <a:spLocks noGrp="1"/>
+          </p:cNvSpPr>
+          <p:nvPr>
+            <p:ph sz="quarter" idx="13"/>
           </p:nvPr>
         </p:nvSpPr>
         <p:spPr/>
@@ -33649,9 +33764,34 @@
           <a:bodyPr/>
           <a:lstStyle/>
           <a:p>
-            <a:fld id="{010D0AB2-23BC-3043-AC30-5928E542C0CE}" type="datetime1">
+            <a:endParaRPr lang="en-SG"/>
+          </a:p>
+        </p:txBody>
+      </p:sp>
+      <p:sp>
+        <p:nvSpPr>
+          <p:cNvPr id="5" name="Date Placeholder 4">
+            <a:extLst>
+              <a:ext uri="{FF2B5EF4-FFF2-40B4-BE49-F238E27FC236}">
+                <a16:creationId xmlns:a16="http://schemas.microsoft.com/office/drawing/2014/main" id="{8A36F9D2-4C85-2A4E-4F02-F16819F34517}"/>
+              </a:ext>
+            </a:extLst>
+          </p:cNvPr>
+          <p:cNvSpPr>
+            <a:spLocks noGrp="1"/>
+          </p:cNvSpPr>
+          <p:nvPr>
+            <p:ph type="dt" sz="half" idx="10"/>
+          </p:nvPr>
+        </p:nvSpPr>
+        <p:spPr/>
+        <p:txBody>
+          <a:bodyPr/>
+          <a:lstStyle/>
+          <a:p>
+            <a:fld id="{927C0DEB-4AE1-EA4D-826D-E3C22802B942}" type="datetime1">
               <a:rPr lang="en-US" smtClean="0"/>
-              <a:t>7/16/2026</a:t>
+              <a:t>7/20/2026</a:t>
             </a:fld>
             <a:endParaRPr lang="en-US" dirty="0"/>
           </a:p>
@@ -33659,10 +33799,10 @@
       </p:sp>
       <p:sp>
         <p:nvSpPr>
-          <p:cNvPr id="5" name="Slide Number Placeholder 4">
-            <a:extLst>
-              <a:ext uri="{FF2B5EF4-FFF2-40B4-BE49-F238E27FC236}">
-                <a16:creationId xmlns:a16="http://schemas.microsoft.com/office/drawing/2014/main" id="{C01ACBED-585F-43F1-E030-A9F82EDE5DEB}"/>
+          <p:cNvPr id="6" name="Slide Number Placeholder 5">
+            <a:extLst>
+              <a:ext uri="{FF2B5EF4-FFF2-40B4-BE49-F238E27FC236}">
+                <a16:creationId xmlns:a16="http://schemas.microsoft.com/office/drawing/2014/main" id="{F89C23D6-8443-978E-F5FF-276AD0A7C93F}"/>
               </a:ext>
             </a:extLst>
           </p:cNvPr>
@@ -33682,6 +33822,912 @@
               <a:rPr lang="en-US" smtClean="0"/>
               <a:pPr/>
               <a:t>11</a:t>
+            </a:fld>
+            <a:endParaRPr lang="en-US" dirty="0"/>
+          </a:p>
+        </p:txBody>
+      </p:sp>
+    </p:spTree>
+    <p:extLst>
+      <p:ext uri="{BB962C8B-B14F-4D97-AF65-F5344CB8AC3E}">
+        <p14:creationId xmlns:p14="http://schemas.microsoft.com/office/powerpoint/2010/main" val="308232602"/>
+      </p:ext>
+    </p:extLst>
+  </p:cSld>
+  <p:clrMapOvr>
+    <a:masterClrMapping/>
+  </p:clrMapOvr>
+</p:sld>
+</file>
+
+<file path=ppt/slides/slide12.xml><?xml version="1.0" encoding="utf-8"?>
+<p:sld xmlns:a="http://schemas.openxmlformats.org/drawingml/2006/main" xmlns:r="http://schemas.openxmlformats.org/officeDocument/2006/relationships" xmlns:p="http://schemas.openxmlformats.org/presentationml/2006/main">
+  <p:cSld>
+    <p:spTree>
+      <p:nvGrpSpPr>
+        <p:cNvPr id="1" name=""/>
+        <p:cNvGrpSpPr/>
+        <p:nvPr/>
+      </p:nvGrpSpPr>
+      <p:grpSpPr>
+        <a:xfrm>
+          <a:off x="0" y="0"/>
+          <a:ext cx="0" cy="0"/>
+          <a:chOff x="0" y="0"/>
+          <a:chExt cx="0" cy="0"/>
+        </a:xfrm>
+      </p:grpSpPr>
+      <p:sp>
+        <p:nvSpPr>
+          <p:cNvPr id="2" name="Title 1">
+            <a:extLst>
+              <a:ext uri="{FF2B5EF4-FFF2-40B4-BE49-F238E27FC236}">
+                <a16:creationId xmlns:a16="http://schemas.microsoft.com/office/drawing/2014/main" id="{286B1922-876E-5121-A1B1-09421CD101B6}"/>
+              </a:ext>
+            </a:extLst>
+          </p:cNvPr>
+          <p:cNvSpPr>
+            <a:spLocks noGrp="1"/>
+          </p:cNvSpPr>
+          <p:nvPr>
+            <p:ph type="title"/>
+          </p:nvPr>
+        </p:nvSpPr>
+        <p:spPr/>
+        <p:txBody>
+          <a:bodyPr/>
+          <a:lstStyle/>
+          <a:p>
+            <a:r>
+              <a:rPr lang="en-SG" dirty="0"/>
+              <a:t>DATABASE</a:t>
+            </a:r>
+          </a:p>
+        </p:txBody>
+      </p:sp>
+      <p:sp>
+        <p:nvSpPr>
+          <p:cNvPr id="3" name="Footer Placeholder 2">
+            <a:extLst>
+              <a:ext uri="{FF2B5EF4-FFF2-40B4-BE49-F238E27FC236}">
+                <a16:creationId xmlns:a16="http://schemas.microsoft.com/office/drawing/2014/main" id="{130300D0-5A97-A007-8822-C75A86BC135D}"/>
+              </a:ext>
+            </a:extLst>
+          </p:cNvPr>
+          <p:cNvSpPr>
+            <a:spLocks noGrp="1"/>
+          </p:cNvSpPr>
+          <p:nvPr>
+            <p:ph type="ftr" sz="quarter" idx="11"/>
+          </p:nvPr>
+        </p:nvSpPr>
+        <p:spPr/>
+        <p:txBody>
+          <a:bodyPr/>
+          <a:lstStyle/>
+          <a:p>
+            <a:r>
+              <a:rPr lang="en-US"/>
+              <a:t>SAMPLE FOOTER TEXT</a:t>
+            </a:r>
+            <a:endParaRPr lang="en-US" dirty="0"/>
+          </a:p>
+        </p:txBody>
+      </p:sp>
+      <p:sp>
+        <p:nvSpPr>
+          <p:cNvPr id="4" name="Content Placeholder 3">
+            <a:extLst>
+              <a:ext uri="{FF2B5EF4-FFF2-40B4-BE49-F238E27FC236}">
+                <a16:creationId xmlns:a16="http://schemas.microsoft.com/office/drawing/2014/main" id="{AF3B857A-83E3-2D2A-978B-032EBACA2376}"/>
+              </a:ext>
+            </a:extLst>
+          </p:cNvPr>
+          <p:cNvSpPr>
+            <a:spLocks noGrp="1"/>
+          </p:cNvSpPr>
+          <p:nvPr>
+            <p:ph sz="quarter" idx="13"/>
+          </p:nvPr>
+        </p:nvSpPr>
+        <p:spPr/>
+        <p:txBody>
+          <a:bodyPr/>
+          <a:lstStyle/>
+          <a:p>
+            <a:endParaRPr lang="en-SG"/>
+          </a:p>
+        </p:txBody>
+      </p:sp>
+      <p:sp>
+        <p:nvSpPr>
+          <p:cNvPr id="5" name="Date Placeholder 4">
+            <a:extLst>
+              <a:ext uri="{FF2B5EF4-FFF2-40B4-BE49-F238E27FC236}">
+                <a16:creationId xmlns:a16="http://schemas.microsoft.com/office/drawing/2014/main" id="{84920A6B-C20E-B038-D917-D179D6C31213}"/>
+              </a:ext>
+            </a:extLst>
+          </p:cNvPr>
+          <p:cNvSpPr>
+            <a:spLocks noGrp="1"/>
+          </p:cNvSpPr>
+          <p:nvPr>
+            <p:ph type="dt" sz="half" idx="10"/>
+          </p:nvPr>
+        </p:nvSpPr>
+        <p:spPr/>
+        <p:txBody>
+          <a:bodyPr/>
+          <a:lstStyle/>
+          <a:p>
+            <a:fld id="{927C0DEB-4AE1-EA4D-826D-E3C22802B942}" type="datetime1">
+              <a:rPr lang="en-US" smtClean="0"/>
+              <a:t>7/20/2026</a:t>
+            </a:fld>
+            <a:endParaRPr lang="en-US" dirty="0"/>
+          </a:p>
+        </p:txBody>
+      </p:sp>
+      <p:sp>
+        <p:nvSpPr>
+          <p:cNvPr id="6" name="Slide Number Placeholder 5">
+            <a:extLst>
+              <a:ext uri="{FF2B5EF4-FFF2-40B4-BE49-F238E27FC236}">
+                <a16:creationId xmlns:a16="http://schemas.microsoft.com/office/drawing/2014/main" id="{F5D522DE-ABA7-62B2-AAB9-C272B74D3EC1}"/>
+              </a:ext>
+            </a:extLst>
+          </p:cNvPr>
+          <p:cNvSpPr>
+            <a:spLocks noGrp="1"/>
+          </p:cNvSpPr>
+          <p:nvPr>
+            <p:ph type="sldNum" sz="quarter" idx="12"/>
+          </p:nvPr>
+        </p:nvSpPr>
+        <p:spPr/>
+        <p:txBody>
+          <a:bodyPr/>
+          <a:lstStyle/>
+          <a:p>
+            <a:fld id="{CC057153-B650-4DEB-B370-79DDCFDCE934}" type="slidenum">
+              <a:rPr lang="en-US" smtClean="0"/>
+              <a:pPr/>
+              <a:t>12</a:t>
+            </a:fld>
+            <a:endParaRPr lang="en-US" dirty="0"/>
+          </a:p>
+        </p:txBody>
+      </p:sp>
+    </p:spTree>
+    <p:extLst>
+      <p:ext uri="{BB962C8B-B14F-4D97-AF65-F5344CB8AC3E}">
+        <p14:creationId xmlns:p14="http://schemas.microsoft.com/office/powerpoint/2010/main" val="2133928878"/>
+      </p:ext>
+    </p:extLst>
+  </p:cSld>
+  <p:clrMapOvr>
+    <a:masterClrMapping/>
+  </p:clrMapOvr>
+</p:sld>
+</file>
+
+<file path=ppt/slides/slide13.xml><?xml version="1.0" encoding="utf-8"?>
+<p:sld xmlns:a="http://schemas.openxmlformats.org/drawingml/2006/main" xmlns:r="http://schemas.openxmlformats.org/officeDocument/2006/relationships" xmlns:p="http://schemas.openxmlformats.org/presentationml/2006/main">
+  <p:cSld>
+    <p:spTree>
+      <p:nvGrpSpPr>
+        <p:cNvPr id="1" name=""/>
+        <p:cNvGrpSpPr/>
+        <p:nvPr/>
+      </p:nvGrpSpPr>
+      <p:grpSpPr>
+        <a:xfrm>
+          <a:off x="0" y="0"/>
+          <a:ext cx="0" cy="0"/>
+          <a:chOff x="0" y="0"/>
+          <a:chExt cx="0" cy="0"/>
+        </a:xfrm>
+      </p:grpSpPr>
+      <p:sp>
+        <p:nvSpPr>
+          <p:cNvPr id="2" name="Title 1">
+            <a:extLst>
+              <a:ext uri="{FF2B5EF4-FFF2-40B4-BE49-F238E27FC236}">
+                <a16:creationId xmlns:a16="http://schemas.microsoft.com/office/drawing/2014/main" id="{DEFF6106-7A0A-48DF-A54A-1203136FE872}"/>
+              </a:ext>
+            </a:extLst>
+          </p:cNvPr>
+          <p:cNvSpPr>
+            <a:spLocks noGrp="1"/>
+          </p:cNvSpPr>
+          <p:nvPr>
+            <p:ph type="ctrTitle"/>
+          </p:nvPr>
+        </p:nvSpPr>
+        <p:spPr/>
+        <p:txBody>
+          <a:bodyPr/>
+          <a:lstStyle/>
+          <a:p>
+            <a:r>
+              <a:rPr lang="en-SG" dirty="0"/>
+              <a:t>Docker</a:t>
+            </a:r>
+          </a:p>
+        </p:txBody>
+      </p:sp>
+      <p:sp>
+        <p:nvSpPr>
+          <p:cNvPr id="3" name="Footer Placeholder 2">
+            <a:extLst>
+              <a:ext uri="{FF2B5EF4-FFF2-40B4-BE49-F238E27FC236}">
+                <a16:creationId xmlns:a16="http://schemas.microsoft.com/office/drawing/2014/main" id="{B2BCAD1A-CFBC-A349-DD67-7349B93D3720}"/>
+              </a:ext>
+            </a:extLst>
+          </p:cNvPr>
+          <p:cNvSpPr>
+            <a:spLocks noGrp="1"/>
+          </p:cNvSpPr>
+          <p:nvPr>
+            <p:ph type="ftr" sz="quarter" idx="11"/>
+          </p:nvPr>
+        </p:nvSpPr>
+        <p:spPr/>
+        <p:txBody>
+          <a:bodyPr/>
+          <a:lstStyle/>
+          <a:p>
+            <a:r>
+              <a:rPr lang="en-US"/>
+              <a:t>SAMPLE FOOTER TEXT</a:t>
+            </a:r>
+            <a:endParaRPr lang="en-US" dirty="0"/>
+          </a:p>
+        </p:txBody>
+      </p:sp>
+      <p:sp>
+        <p:nvSpPr>
+          <p:cNvPr id="4" name="Date Placeholder 3">
+            <a:extLst>
+              <a:ext uri="{FF2B5EF4-FFF2-40B4-BE49-F238E27FC236}">
+                <a16:creationId xmlns:a16="http://schemas.microsoft.com/office/drawing/2014/main" id="{3BA4730D-F0FF-B752-323B-BE0157CA02F8}"/>
+              </a:ext>
+            </a:extLst>
+          </p:cNvPr>
+          <p:cNvSpPr>
+            <a:spLocks noGrp="1"/>
+          </p:cNvSpPr>
+          <p:nvPr>
+            <p:ph type="dt" sz="half" idx="10"/>
+          </p:nvPr>
+        </p:nvSpPr>
+        <p:spPr/>
+        <p:txBody>
+          <a:bodyPr/>
+          <a:lstStyle/>
+          <a:p>
+            <a:fld id="{010D0AB2-23BC-3043-AC30-5928E542C0CE}" type="datetime1">
+              <a:rPr lang="en-US" smtClean="0"/>
+              <a:t>7/19/2026</a:t>
+            </a:fld>
+            <a:endParaRPr lang="en-US" dirty="0"/>
+          </a:p>
+        </p:txBody>
+      </p:sp>
+      <p:sp>
+        <p:nvSpPr>
+          <p:cNvPr id="5" name="Slide Number Placeholder 4">
+            <a:extLst>
+              <a:ext uri="{FF2B5EF4-FFF2-40B4-BE49-F238E27FC236}">
+                <a16:creationId xmlns:a16="http://schemas.microsoft.com/office/drawing/2014/main" id="{49E7DB59-C4F8-CDE1-61A4-49E42A74492A}"/>
+              </a:ext>
+            </a:extLst>
+          </p:cNvPr>
+          <p:cNvSpPr>
+            <a:spLocks noGrp="1"/>
+          </p:cNvSpPr>
+          <p:nvPr>
+            <p:ph type="sldNum" sz="quarter" idx="12"/>
+          </p:nvPr>
+        </p:nvSpPr>
+        <p:spPr/>
+        <p:txBody>
+          <a:bodyPr/>
+          <a:lstStyle/>
+          <a:p>
+            <a:fld id="{CC057153-B650-4DEB-B370-79DDCFDCE934}" type="slidenum">
+              <a:rPr lang="en-US" smtClean="0"/>
+              <a:pPr/>
+              <a:t>13</a:t>
+            </a:fld>
+            <a:endParaRPr lang="en-US" dirty="0"/>
+          </a:p>
+        </p:txBody>
+      </p:sp>
+    </p:spTree>
+    <p:extLst>
+      <p:ext uri="{BB962C8B-B14F-4D97-AF65-F5344CB8AC3E}">
+        <p14:creationId xmlns:p14="http://schemas.microsoft.com/office/powerpoint/2010/main" val="1662138044"/>
+      </p:ext>
+    </p:extLst>
+  </p:cSld>
+  <p:clrMapOvr>
+    <a:masterClrMapping/>
+  </p:clrMapOvr>
+</p:sld>
+</file>
+
+<file path=ppt/slides/slide14.xml><?xml version="1.0" encoding="utf-8"?>
+<p:sld xmlns:a="http://schemas.openxmlformats.org/drawingml/2006/main" xmlns:r="http://schemas.openxmlformats.org/officeDocument/2006/relationships" xmlns:p="http://schemas.openxmlformats.org/presentationml/2006/main">
+  <p:cSld>
+    <p:spTree>
+      <p:nvGrpSpPr>
+        <p:cNvPr id="1" name=""/>
+        <p:cNvGrpSpPr/>
+        <p:nvPr/>
+      </p:nvGrpSpPr>
+      <p:grpSpPr>
+        <a:xfrm>
+          <a:off x="0" y="0"/>
+          <a:ext cx="0" cy="0"/>
+          <a:chOff x="0" y="0"/>
+          <a:chExt cx="0" cy="0"/>
+        </a:xfrm>
+      </p:grpSpPr>
+      <p:sp>
+        <p:nvSpPr>
+          <p:cNvPr id="2" name="Title 1">
+            <a:extLst>
+              <a:ext uri="{FF2B5EF4-FFF2-40B4-BE49-F238E27FC236}">
+                <a16:creationId xmlns:a16="http://schemas.microsoft.com/office/drawing/2014/main" id="{F27EEF88-486E-52FF-3AF3-C50D322E6819}"/>
+              </a:ext>
+            </a:extLst>
+          </p:cNvPr>
+          <p:cNvSpPr>
+            <a:spLocks noGrp="1"/>
+          </p:cNvSpPr>
+          <p:nvPr>
+            <p:ph type="ctrTitle"/>
+          </p:nvPr>
+        </p:nvSpPr>
+        <p:spPr/>
+        <p:txBody>
+          <a:bodyPr/>
+          <a:lstStyle/>
+          <a:p>
+            <a:r>
+              <a:rPr lang="en-SG" dirty="0"/>
+              <a:t>KUBERNATES</a:t>
+            </a:r>
+          </a:p>
+        </p:txBody>
+      </p:sp>
+      <p:sp>
+        <p:nvSpPr>
+          <p:cNvPr id="3" name="Footer Placeholder 2">
+            <a:extLst>
+              <a:ext uri="{FF2B5EF4-FFF2-40B4-BE49-F238E27FC236}">
+                <a16:creationId xmlns:a16="http://schemas.microsoft.com/office/drawing/2014/main" id="{D2F62700-C8BC-371F-E4A0-146018195E63}"/>
+              </a:ext>
+            </a:extLst>
+          </p:cNvPr>
+          <p:cNvSpPr>
+            <a:spLocks noGrp="1"/>
+          </p:cNvSpPr>
+          <p:nvPr>
+            <p:ph type="ftr" sz="quarter" idx="11"/>
+          </p:nvPr>
+        </p:nvSpPr>
+        <p:spPr/>
+        <p:txBody>
+          <a:bodyPr/>
+          <a:lstStyle/>
+          <a:p>
+            <a:r>
+              <a:rPr lang="en-US"/>
+              <a:t>SAMPLE FOOTER TEXT</a:t>
+            </a:r>
+            <a:endParaRPr lang="en-US" dirty="0"/>
+          </a:p>
+        </p:txBody>
+      </p:sp>
+      <p:sp>
+        <p:nvSpPr>
+          <p:cNvPr id="4" name="Date Placeholder 3">
+            <a:extLst>
+              <a:ext uri="{FF2B5EF4-FFF2-40B4-BE49-F238E27FC236}">
+                <a16:creationId xmlns:a16="http://schemas.microsoft.com/office/drawing/2014/main" id="{97386FD1-37AC-99FB-025F-EC72261EF737}"/>
+              </a:ext>
+            </a:extLst>
+          </p:cNvPr>
+          <p:cNvSpPr>
+            <a:spLocks noGrp="1"/>
+          </p:cNvSpPr>
+          <p:nvPr>
+            <p:ph type="dt" sz="half" idx="10"/>
+          </p:nvPr>
+        </p:nvSpPr>
+        <p:spPr/>
+        <p:txBody>
+          <a:bodyPr/>
+          <a:lstStyle/>
+          <a:p>
+            <a:fld id="{010D0AB2-23BC-3043-AC30-5928E542C0CE}" type="datetime1">
+              <a:rPr lang="en-US" smtClean="0"/>
+              <a:t>7/19/2026</a:t>
+            </a:fld>
+            <a:endParaRPr lang="en-US" dirty="0"/>
+          </a:p>
+        </p:txBody>
+      </p:sp>
+      <p:sp>
+        <p:nvSpPr>
+          <p:cNvPr id="5" name="Slide Number Placeholder 4">
+            <a:extLst>
+              <a:ext uri="{FF2B5EF4-FFF2-40B4-BE49-F238E27FC236}">
+                <a16:creationId xmlns:a16="http://schemas.microsoft.com/office/drawing/2014/main" id="{D08F73AA-8FFF-4571-C0CF-0F21F722B187}"/>
+              </a:ext>
+            </a:extLst>
+          </p:cNvPr>
+          <p:cNvSpPr>
+            <a:spLocks noGrp="1"/>
+          </p:cNvSpPr>
+          <p:nvPr>
+            <p:ph type="sldNum" sz="quarter" idx="12"/>
+          </p:nvPr>
+        </p:nvSpPr>
+        <p:spPr/>
+        <p:txBody>
+          <a:bodyPr/>
+          <a:lstStyle/>
+          <a:p>
+            <a:fld id="{CC057153-B650-4DEB-B370-79DDCFDCE934}" type="slidenum">
+              <a:rPr lang="en-US" smtClean="0"/>
+              <a:pPr/>
+              <a:t>14</a:t>
+            </a:fld>
+            <a:endParaRPr lang="en-US" dirty="0"/>
+          </a:p>
+        </p:txBody>
+      </p:sp>
+    </p:spTree>
+    <p:extLst>
+      <p:ext uri="{BB962C8B-B14F-4D97-AF65-F5344CB8AC3E}">
+        <p14:creationId xmlns:p14="http://schemas.microsoft.com/office/powerpoint/2010/main" val="2037361668"/>
+      </p:ext>
+    </p:extLst>
+  </p:cSld>
+  <p:clrMapOvr>
+    <a:masterClrMapping/>
+  </p:clrMapOvr>
+</p:sld>
+</file>
+
+<file path=ppt/slides/slide15.xml><?xml version="1.0" encoding="utf-8"?>
+<p:sld xmlns:a="http://schemas.openxmlformats.org/drawingml/2006/main" xmlns:r="http://schemas.openxmlformats.org/officeDocument/2006/relationships" xmlns:p="http://schemas.openxmlformats.org/presentationml/2006/main">
+  <p:cSld>
+    <p:spTree>
+      <p:nvGrpSpPr>
+        <p:cNvPr id="1" name=""/>
+        <p:cNvGrpSpPr/>
+        <p:nvPr/>
+      </p:nvGrpSpPr>
+      <p:grpSpPr>
+        <a:xfrm>
+          <a:off x="0" y="0"/>
+          <a:ext cx="0" cy="0"/>
+          <a:chOff x="0" y="0"/>
+          <a:chExt cx="0" cy="0"/>
+        </a:xfrm>
+      </p:grpSpPr>
+      <p:sp>
+        <p:nvSpPr>
+          <p:cNvPr id="2" name="Title 1">
+            <a:extLst>
+              <a:ext uri="{FF2B5EF4-FFF2-40B4-BE49-F238E27FC236}">
+                <a16:creationId xmlns:a16="http://schemas.microsoft.com/office/drawing/2014/main" id="{5399766A-8D26-6DCE-60BF-703811C9A8AF}"/>
+              </a:ext>
+            </a:extLst>
+          </p:cNvPr>
+          <p:cNvSpPr>
+            <a:spLocks noGrp="1"/>
+          </p:cNvSpPr>
+          <p:nvPr>
+            <p:ph type="ctrTitle"/>
+          </p:nvPr>
+        </p:nvSpPr>
+        <p:spPr>
+          <a:xfrm>
+            <a:off x="3536831" y="1463040"/>
+            <a:ext cx="5210354" cy="3931920"/>
+          </a:xfrm>
+        </p:spPr>
+        <p:txBody>
+          <a:bodyPr/>
+          <a:lstStyle/>
+          <a:p>
+            <a:r>
+              <a:rPr lang="en-SG" dirty="0"/>
+              <a:t>MICROSERVICES</a:t>
+            </a:r>
+          </a:p>
+        </p:txBody>
+      </p:sp>
+      <p:sp>
+        <p:nvSpPr>
+          <p:cNvPr id="3" name="Footer Placeholder 2">
+            <a:extLst>
+              <a:ext uri="{FF2B5EF4-FFF2-40B4-BE49-F238E27FC236}">
+                <a16:creationId xmlns:a16="http://schemas.microsoft.com/office/drawing/2014/main" id="{02CD1AC0-9939-D7DA-C1B5-89896E5490E1}"/>
+              </a:ext>
+            </a:extLst>
+          </p:cNvPr>
+          <p:cNvSpPr>
+            <a:spLocks noGrp="1"/>
+          </p:cNvSpPr>
+          <p:nvPr>
+            <p:ph type="ftr" sz="quarter" idx="11"/>
+          </p:nvPr>
+        </p:nvSpPr>
+        <p:spPr/>
+        <p:txBody>
+          <a:bodyPr/>
+          <a:lstStyle/>
+          <a:p>
+            <a:r>
+              <a:rPr lang="en-US"/>
+              <a:t>SAMPLE FOOTER TEXT</a:t>
+            </a:r>
+            <a:endParaRPr lang="en-US" dirty="0"/>
+          </a:p>
+        </p:txBody>
+      </p:sp>
+      <p:sp>
+        <p:nvSpPr>
+          <p:cNvPr id="4" name="Date Placeholder 3">
+            <a:extLst>
+              <a:ext uri="{FF2B5EF4-FFF2-40B4-BE49-F238E27FC236}">
+                <a16:creationId xmlns:a16="http://schemas.microsoft.com/office/drawing/2014/main" id="{19E5B9C4-A021-AD37-4063-4CD82AEA3362}"/>
+              </a:ext>
+            </a:extLst>
+          </p:cNvPr>
+          <p:cNvSpPr>
+            <a:spLocks noGrp="1"/>
+          </p:cNvSpPr>
+          <p:nvPr>
+            <p:ph type="dt" sz="half" idx="10"/>
+          </p:nvPr>
+        </p:nvSpPr>
+        <p:spPr/>
+        <p:txBody>
+          <a:bodyPr/>
+          <a:lstStyle/>
+          <a:p>
+            <a:fld id="{010D0AB2-23BC-3043-AC30-5928E542C0CE}" type="datetime1">
+              <a:rPr lang="en-US" smtClean="0"/>
+              <a:t>7/19/2026</a:t>
+            </a:fld>
+            <a:endParaRPr lang="en-US" dirty="0"/>
+          </a:p>
+        </p:txBody>
+      </p:sp>
+      <p:sp>
+        <p:nvSpPr>
+          <p:cNvPr id="5" name="Slide Number Placeholder 4">
+            <a:extLst>
+              <a:ext uri="{FF2B5EF4-FFF2-40B4-BE49-F238E27FC236}">
+                <a16:creationId xmlns:a16="http://schemas.microsoft.com/office/drawing/2014/main" id="{D796FA40-EF4F-7414-795C-90E90F514FCC}"/>
+              </a:ext>
+            </a:extLst>
+          </p:cNvPr>
+          <p:cNvSpPr>
+            <a:spLocks noGrp="1"/>
+          </p:cNvSpPr>
+          <p:nvPr>
+            <p:ph type="sldNum" sz="quarter" idx="12"/>
+          </p:nvPr>
+        </p:nvSpPr>
+        <p:spPr/>
+        <p:txBody>
+          <a:bodyPr/>
+          <a:lstStyle/>
+          <a:p>
+            <a:fld id="{CC057153-B650-4DEB-B370-79DDCFDCE934}" type="slidenum">
+              <a:rPr lang="en-US" smtClean="0"/>
+              <a:pPr/>
+              <a:t>15</a:t>
+            </a:fld>
+            <a:endParaRPr lang="en-US" dirty="0"/>
+          </a:p>
+        </p:txBody>
+      </p:sp>
+    </p:spTree>
+    <p:extLst>
+      <p:ext uri="{BB962C8B-B14F-4D97-AF65-F5344CB8AC3E}">
+        <p14:creationId xmlns:p14="http://schemas.microsoft.com/office/powerpoint/2010/main" val="1787156668"/>
+      </p:ext>
+    </p:extLst>
+  </p:cSld>
+  <p:clrMapOvr>
+    <a:masterClrMapping/>
+  </p:clrMapOvr>
+</p:sld>
+</file>
+
+<file path=ppt/slides/slide16.xml><?xml version="1.0" encoding="utf-8"?>
+<p:sld xmlns:a="http://schemas.openxmlformats.org/drawingml/2006/main" xmlns:r="http://schemas.openxmlformats.org/officeDocument/2006/relationships" xmlns:p="http://schemas.openxmlformats.org/presentationml/2006/main">
+  <p:cSld>
+    <p:spTree>
+      <p:nvGrpSpPr>
+        <p:cNvPr id="1" name=""/>
+        <p:cNvGrpSpPr/>
+        <p:nvPr/>
+      </p:nvGrpSpPr>
+      <p:grpSpPr>
+        <a:xfrm>
+          <a:off x="0" y="0"/>
+          <a:ext cx="0" cy="0"/>
+          <a:chOff x="0" y="0"/>
+          <a:chExt cx="0" cy="0"/>
+        </a:xfrm>
+      </p:grpSpPr>
+      <p:sp>
+        <p:nvSpPr>
+          <p:cNvPr id="2" name="Title 1">
+            <a:extLst>
+              <a:ext uri="{FF2B5EF4-FFF2-40B4-BE49-F238E27FC236}">
+                <a16:creationId xmlns:a16="http://schemas.microsoft.com/office/drawing/2014/main" id="{9DEAAF09-CB58-6E0F-3345-27591FA4FF54}"/>
+              </a:ext>
+            </a:extLst>
+          </p:cNvPr>
+          <p:cNvSpPr>
+            <a:spLocks noGrp="1"/>
+          </p:cNvSpPr>
+          <p:nvPr>
+            <p:ph type="ctrTitle"/>
+          </p:nvPr>
+        </p:nvSpPr>
+        <p:spPr/>
+        <p:txBody>
+          <a:bodyPr/>
+          <a:lstStyle/>
+          <a:p>
+            <a:r>
+              <a:rPr lang="en-SG" dirty="0"/>
+              <a:t>DATA SOURCE</a:t>
+            </a:r>
+          </a:p>
+        </p:txBody>
+      </p:sp>
+      <p:sp>
+        <p:nvSpPr>
+          <p:cNvPr id="3" name="Footer Placeholder 2">
+            <a:extLst>
+              <a:ext uri="{FF2B5EF4-FFF2-40B4-BE49-F238E27FC236}">
+                <a16:creationId xmlns:a16="http://schemas.microsoft.com/office/drawing/2014/main" id="{3F6A2061-CB22-D700-DFFA-693366FF7DAC}"/>
+              </a:ext>
+            </a:extLst>
+          </p:cNvPr>
+          <p:cNvSpPr>
+            <a:spLocks noGrp="1"/>
+          </p:cNvSpPr>
+          <p:nvPr>
+            <p:ph type="ftr" sz="quarter" idx="11"/>
+          </p:nvPr>
+        </p:nvSpPr>
+        <p:spPr/>
+        <p:txBody>
+          <a:bodyPr/>
+          <a:lstStyle/>
+          <a:p>
+            <a:r>
+              <a:rPr lang="en-US"/>
+              <a:t>SAMPLE FOOTER TEXT</a:t>
+            </a:r>
+            <a:endParaRPr lang="en-US" dirty="0"/>
+          </a:p>
+        </p:txBody>
+      </p:sp>
+      <p:sp>
+        <p:nvSpPr>
+          <p:cNvPr id="4" name="Date Placeholder 3">
+            <a:extLst>
+              <a:ext uri="{FF2B5EF4-FFF2-40B4-BE49-F238E27FC236}">
+                <a16:creationId xmlns:a16="http://schemas.microsoft.com/office/drawing/2014/main" id="{FB2649DC-6302-6FE7-EB8D-567208A1C78E}"/>
+              </a:ext>
+            </a:extLst>
+          </p:cNvPr>
+          <p:cNvSpPr>
+            <a:spLocks noGrp="1"/>
+          </p:cNvSpPr>
+          <p:nvPr>
+            <p:ph type="dt" sz="half" idx="10"/>
+          </p:nvPr>
+        </p:nvSpPr>
+        <p:spPr/>
+        <p:txBody>
+          <a:bodyPr/>
+          <a:lstStyle/>
+          <a:p>
+            <a:fld id="{010D0AB2-23BC-3043-AC30-5928E542C0CE}" type="datetime1">
+              <a:rPr lang="en-US" smtClean="0"/>
+              <a:t>7/19/2026</a:t>
+            </a:fld>
+            <a:endParaRPr lang="en-US" dirty="0"/>
+          </a:p>
+        </p:txBody>
+      </p:sp>
+      <p:sp>
+        <p:nvSpPr>
+          <p:cNvPr id="5" name="Slide Number Placeholder 4">
+            <a:extLst>
+              <a:ext uri="{FF2B5EF4-FFF2-40B4-BE49-F238E27FC236}">
+                <a16:creationId xmlns:a16="http://schemas.microsoft.com/office/drawing/2014/main" id="{66FF4A67-54EF-04B0-A7D5-1AED7EE1442F}"/>
+              </a:ext>
+            </a:extLst>
+          </p:cNvPr>
+          <p:cNvSpPr>
+            <a:spLocks noGrp="1"/>
+          </p:cNvSpPr>
+          <p:nvPr>
+            <p:ph type="sldNum" sz="quarter" idx="12"/>
+          </p:nvPr>
+        </p:nvSpPr>
+        <p:spPr/>
+        <p:txBody>
+          <a:bodyPr/>
+          <a:lstStyle/>
+          <a:p>
+            <a:fld id="{CC057153-B650-4DEB-B370-79DDCFDCE934}" type="slidenum">
+              <a:rPr lang="en-US" smtClean="0"/>
+              <a:pPr/>
+              <a:t>16</a:t>
+            </a:fld>
+            <a:endParaRPr lang="en-US" dirty="0"/>
+          </a:p>
+        </p:txBody>
+      </p:sp>
+    </p:spTree>
+    <p:extLst>
+      <p:ext uri="{BB962C8B-B14F-4D97-AF65-F5344CB8AC3E}">
+        <p14:creationId xmlns:p14="http://schemas.microsoft.com/office/powerpoint/2010/main" val="1748166942"/>
+      </p:ext>
+    </p:extLst>
+  </p:cSld>
+  <p:clrMapOvr>
+    <a:masterClrMapping/>
+  </p:clrMapOvr>
+</p:sld>
+</file>
+
+<file path=ppt/slides/slide17.xml><?xml version="1.0" encoding="utf-8"?>
+<p:sld xmlns:a="http://schemas.openxmlformats.org/drawingml/2006/main" xmlns:r="http://schemas.openxmlformats.org/officeDocument/2006/relationships" xmlns:p="http://schemas.openxmlformats.org/presentationml/2006/main">
+  <p:cSld>
+    <p:spTree>
+      <p:nvGrpSpPr>
+        <p:cNvPr id="1" name=""/>
+        <p:cNvGrpSpPr/>
+        <p:nvPr/>
+      </p:nvGrpSpPr>
+      <p:grpSpPr>
+        <a:xfrm>
+          <a:off x="0" y="0"/>
+          <a:ext cx="0" cy="0"/>
+          <a:chOff x="0" y="0"/>
+          <a:chExt cx="0" cy="0"/>
+        </a:xfrm>
+      </p:grpSpPr>
+      <p:sp>
+        <p:nvSpPr>
+          <p:cNvPr id="2" name="Title 1">
+            <a:extLst>
+              <a:ext uri="{FF2B5EF4-FFF2-40B4-BE49-F238E27FC236}">
+                <a16:creationId xmlns:a16="http://schemas.microsoft.com/office/drawing/2014/main" id="{EE58C531-7A30-5D0B-55FA-6704B085156E}"/>
+              </a:ext>
+            </a:extLst>
+          </p:cNvPr>
+          <p:cNvSpPr>
+            <a:spLocks noGrp="1"/>
+          </p:cNvSpPr>
+          <p:nvPr>
+            <p:ph type="ctrTitle"/>
+          </p:nvPr>
+        </p:nvSpPr>
+        <p:spPr/>
+        <p:txBody>
+          <a:bodyPr/>
+          <a:lstStyle/>
+          <a:p>
+            <a:r>
+              <a:rPr lang="en-SG" dirty="0"/>
+              <a:t>ISSUES AND LIMITATIONS</a:t>
+            </a:r>
+          </a:p>
+        </p:txBody>
+      </p:sp>
+      <p:sp>
+        <p:nvSpPr>
+          <p:cNvPr id="3" name="Footer Placeholder 2">
+            <a:extLst>
+              <a:ext uri="{FF2B5EF4-FFF2-40B4-BE49-F238E27FC236}">
+                <a16:creationId xmlns:a16="http://schemas.microsoft.com/office/drawing/2014/main" id="{935A7A2C-0E66-E74E-6AAA-46749892E93F}"/>
+              </a:ext>
+            </a:extLst>
+          </p:cNvPr>
+          <p:cNvSpPr>
+            <a:spLocks noGrp="1"/>
+          </p:cNvSpPr>
+          <p:nvPr>
+            <p:ph type="ftr" sz="quarter" idx="11"/>
+          </p:nvPr>
+        </p:nvSpPr>
+        <p:spPr/>
+        <p:txBody>
+          <a:bodyPr/>
+          <a:lstStyle/>
+          <a:p>
+            <a:r>
+              <a:rPr lang="en-US"/>
+              <a:t>SAMPLE FOOTER TEXT</a:t>
+            </a:r>
+            <a:endParaRPr lang="en-US" dirty="0"/>
+          </a:p>
+        </p:txBody>
+      </p:sp>
+      <p:sp>
+        <p:nvSpPr>
+          <p:cNvPr id="4" name="Date Placeholder 3">
+            <a:extLst>
+              <a:ext uri="{FF2B5EF4-FFF2-40B4-BE49-F238E27FC236}">
+                <a16:creationId xmlns:a16="http://schemas.microsoft.com/office/drawing/2014/main" id="{406F36CD-8CAF-F2A3-0961-D2C12A048190}"/>
+              </a:ext>
+            </a:extLst>
+          </p:cNvPr>
+          <p:cNvSpPr>
+            <a:spLocks noGrp="1"/>
+          </p:cNvSpPr>
+          <p:nvPr>
+            <p:ph type="dt" sz="half" idx="10"/>
+          </p:nvPr>
+        </p:nvSpPr>
+        <p:spPr/>
+        <p:txBody>
+          <a:bodyPr/>
+          <a:lstStyle/>
+          <a:p>
+            <a:fld id="{010D0AB2-23BC-3043-AC30-5928E542C0CE}" type="datetime1">
+              <a:rPr lang="en-US" smtClean="0"/>
+              <a:t>7/19/2026</a:t>
+            </a:fld>
+            <a:endParaRPr lang="en-US" dirty="0"/>
+          </a:p>
+        </p:txBody>
+      </p:sp>
+      <p:sp>
+        <p:nvSpPr>
+          <p:cNvPr id="5" name="Slide Number Placeholder 4">
+            <a:extLst>
+              <a:ext uri="{FF2B5EF4-FFF2-40B4-BE49-F238E27FC236}">
+                <a16:creationId xmlns:a16="http://schemas.microsoft.com/office/drawing/2014/main" id="{C01ACBED-585F-43F1-E030-A9F82EDE5DEB}"/>
+              </a:ext>
+            </a:extLst>
+          </p:cNvPr>
+          <p:cNvSpPr>
+            <a:spLocks noGrp="1"/>
+          </p:cNvSpPr>
+          <p:nvPr>
+            <p:ph type="sldNum" sz="quarter" idx="12"/>
+          </p:nvPr>
+        </p:nvSpPr>
+        <p:spPr/>
+        <p:txBody>
+          <a:bodyPr/>
+          <a:lstStyle/>
+          <a:p>
+            <a:fld id="{CC057153-B650-4DEB-B370-79DDCFDCE934}" type="slidenum">
+              <a:rPr lang="en-US" smtClean="0"/>
+              <a:pPr/>
+              <a:t>17</a:t>
             </a:fld>
             <a:endParaRPr lang="en-US" dirty="0"/>
           </a:p>
@@ -33700,7 +34746,7 @@
 </p:sld>
 </file>
 
-<file path=ppt/slides/slide12.xml><?xml version="1.0" encoding="utf-8"?>
+<file path=ppt/slides/slide18.xml><?xml version="1.0" encoding="utf-8"?>
 <p:sld xmlns:a="http://schemas.openxmlformats.org/drawingml/2006/main" xmlns:r="http://schemas.openxmlformats.org/officeDocument/2006/relationships" xmlns:p="http://schemas.openxmlformats.org/presentationml/2006/main">
   <p:cSld>
     <p:spTree>
@@ -33785,25 +34831,32 @@
           <p:cNvPr id="2" name="Title 1">
             <a:extLst>
               <a:ext uri="{FF2B5EF4-FFF2-40B4-BE49-F238E27FC236}">
-                <a16:creationId xmlns:a16="http://schemas.microsoft.com/office/drawing/2014/main" id="{D7795239-9BBD-01A8-B192-6B72EB6F89DF}"/>
-              </a:ext>
-            </a:extLst>
-          </p:cNvPr>
-          <p:cNvSpPr>
-            <a:spLocks noGrp="1"/>
-          </p:cNvSpPr>
-          <p:nvPr>
-            <p:ph type="ctrTitle"/>
-          </p:nvPr>
-        </p:nvSpPr>
-        <p:spPr/>
-        <p:txBody>
-          <a:bodyPr/>
+                <a16:creationId xmlns:a16="http://schemas.microsoft.com/office/drawing/2014/main" id="{C6F9A5B3-D1E4-D0C2-F83A-1FA0DFF13296}"/>
+              </a:ext>
+            </a:extLst>
+          </p:cNvPr>
+          <p:cNvSpPr>
+            <a:spLocks noGrp="1"/>
+          </p:cNvSpPr>
+          <p:nvPr>
+            <p:ph type="title"/>
+          </p:nvPr>
+        </p:nvSpPr>
+        <p:spPr>
+          <a:xfrm>
+            <a:off x="1255032" y="862335"/>
+            <a:ext cx="4389120" cy="5120640"/>
+          </a:xfrm>
+        </p:spPr>
+        <p:txBody>
+          <a:bodyPr anchor="ctr">
+            <a:normAutofit/>
+          </a:bodyPr>
           <a:lstStyle/>
           <a:p>
             <a:r>
               <a:rPr lang="en-SG" dirty="0"/>
-              <a:t>Problem statement</a:t>
+              <a:t>Problem Statement</a:t>
             </a:r>
           </a:p>
         </p:txBody>
@@ -33813,7 +34866,7 @@
           <p:cNvPr id="3" name="Footer Placeholder 2">
             <a:extLst>
               <a:ext uri="{FF2B5EF4-FFF2-40B4-BE49-F238E27FC236}">
-                <a16:creationId xmlns:a16="http://schemas.microsoft.com/office/drawing/2014/main" id="{FB484B56-B94D-6D6D-F0E1-26A03E022FF6}"/>
+                <a16:creationId xmlns:a16="http://schemas.microsoft.com/office/drawing/2014/main" id="{0EE80E97-6251-AC91-6D35-87EF2A034F80}"/>
               </a:ext>
             </a:extLst>
           </p:cNvPr>
@@ -33824,25 +34877,74 @@
             <p:ph type="ftr" sz="quarter" idx="11"/>
           </p:nvPr>
         </p:nvSpPr>
-        <p:spPr/>
-        <p:txBody>
-          <a:bodyPr/>
+        <p:spPr>
+          <a:xfrm rot="16200000">
+            <a:off x="-1005840" y="1525384"/>
+            <a:ext cx="2805405" cy="365125"/>
+          </a:xfrm>
+        </p:spPr>
+        <p:txBody>
+          <a:bodyPr anchor="ctr">
+            <a:normAutofit/>
+          </a:bodyPr>
           <a:lstStyle/>
           <a:p>
+            <a:pPr>
+              <a:spcAft>
+                <a:spcPts val="600"/>
+              </a:spcAft>
+            </a:pPr>
             <a:r>
               <a:rPr lang="en-US"/>
               <a:t>SAMPLE FOOTER TEXT</a:t>
             </a:r>
-            <a:endParaRPr lang="en-US" dirty="0"/>
-          </a:p>
-        </p:txBody>
-      </p:sp>
-      <p:sp>
-        <p:nvSpPr>
-          <p:cNvPr id="4" name="Date Placeholder 3">
-            <a:extLst>
-              <a:ext uri="{FF2B5EF4-FFF2-40B4-BE49-F238E27FC236}">
-                <a16:creationId xmlns:a16="http://schemas.microsoft.com/office/drawing/2014/main" id="{FB73928D-F822-872E-AEB2-898C26A51BBC}"/>
+          </a:p>
+        </p:txBody>
+      </p:sp>
+      <p:sp>
+        <p:nvSpPr>
+          <p:cNvPr id="4" name="Content Placeholder 3">
+            <a:extLst>
+              <a:ext uri="{FF2B5EF4-FFF2-40B4-BE49-F238E27FC236}">
+                <a16:creationId xmlns:a16="http://schemas.microsoft.com/office/drawing/2014/main" id="{7D2A119A-9A1B-4BDC-333B-C4F2A646A21F}"/>
+              </a:ext>
+            </a:extLst>
+          </p:cNvPr>
+          <p:cNvSpPr>
+            <a:spLocks noGrp="1"/>
+          </p:cNvSpPr>
+          <p:nvPr>
+            <p:ph sz="quarter" idx="13"/>
+          </p:nvPr>
+        </p:nvSpPr>
+        <p:spPr>
+          <a:xfrm>
+            <a:off x="6547100" y="816615"/>
+            <a:ext cx="4389120" cy="5212080"/>
+          </a:xfrm>
+        </p:spPr>
+        <p:txBody>
+          <a:bodyPr anchor="ctr">
+            <a:normAutofit/>
+          </a:bodyPr>
+          <a:lstStyle/>
+          <a:p>
+            <a:r>
+              <a:rPr lang="en-SG"/>
+              <a:t>Current environmental monitoring systems rely on manual analysis of sensor data, which is inefficient and prone to delayed responses. This project proposes an AI-powered Smart Environmental Monitoring System that automatically detects anomalies using machine learning and is deployed with Docker and Kubernetes for scalable and reliable operation.</a:t>
+            </a:r>
+          </a:p>
+          <a:p>
+            <a:endParaRPr lang="en-SG" dirty="0"/>
+          </a:p>
+        </p:txBody>
+      </p:sp>
+      <p:sp>
+        <p:nvSpPr>
+          <p:cNvPr id="5" name="Date Placeholder 4">
+            <a:extLst>
+              <a:ext uri="{FF2B5EF4-FFF2-40B4-BE49-F238E27FC236}">
+                <a16:creationId xmlns:a16="http://schemas.microsoft.com/office/drawing/2014/main" id="{A0D81173-2692-1EC8-9E30-62838359A5A5}"/>
               </a:ext>
             </a:extLst>
           </p:cNvPr>
@@ -33853,25 +34955,42 @@
             <p:ph type="dt" sz="half" idx="10"/>
           </p:nvPr>
         </p:nvSpPr>
-        <p:spPr/>
-        <p:txBody>
-          <a:bodyPr/>
+        <p:spPr>
+          <a:xfrm rot="5400000">
+            <a:off x="10040831" y="4206240"/>
+            <a:ext cx="3494314" cy="365125"/>
+          </a:xfrm>
+        </p:spPr>
+        <p:txBody>
+          <a:bodyPr anchor="ctr">
+            <a:normAutofit/>
+          </a:bodyPr>
           <a:lstStyle/>
           <a:p>
-            <a:fld id="{010D0AB2-23BC-3043-AC30-5928E542C0CE}" type="datetime1">
+            <a:pPr>
+              <a:spcAft>
+                <a:spcPts val="600"/>
+              </a:spcAft>
+            </a:pPr>
+            <a:fld id="{927C0DEB-4AE1-EA4D-826D-E3C22802B942}" type="datetime1">
               <a:rPr lang="en-US" smtClean="0"/>
-              <a:t>7/16/2026</a:t>
+              <a:pPr>
+                <a:spcAft>
+                  <a:spcPts val="600"/>
+                </a:spcAft>
+              </a:pPr>
+              <a:t>7/19/2026</a:t>
             </a:fld>
-            <a:endParaRPr lang="en-US" dirty="0"/>
-          </a:p>
-        </p:txBody>
-      </p:sp>
-      <p:sp>
-        <p:nvSpPr>
-          <p:cNvPr id="5" name="Slide Number Placeholder 4">
-            <a:extLst>
-              <a:ext uri="{FF2B5EF4-FFF2-40B4-BE49-F238E27FC236}">
-                <a16:creationId xmlns:a16="http://schemas.microsoft.com/office/drawing/2014/main" id="{D5722563-0A53-48A7-6503-2538BC40FD39}"/>
+            <a:endParaRPr lang="en-US"/>
+          </a:p>
+        </p:txBody>
+      </p:sp>
+      <p:sp>
+        <p:nvSpPr>
+          <p:cNvPr id="6" name="Slide Number Placeholder 5">
+            <a:extLst>
+              <a:ext uri="{FF2B5EF4-FFF2-40B4-BE49-F238E27FC236}">
+                <a16:creationId xmlns:a16="http://schemas.microsoft.com/office/drawing/2014/main" id="{ABB406EC-D35C-8A52-7BBB-EB512633B053}"/>
               </a:ext>
             </a:extLst>
           </p:cNvPr>
@@ -33882,24 +35001,40 @@
             <p:ph type="sldNum" sz="quarter" idx="12"/>
           </p:nvPr>
         </p:nvSpPr>
-        <p:spPr/>
-        <p:txBody>
-          <a:bodyPr/>
+        <p:spPr>
+          <a:xfrm>
+            <a:off x="11573385" y="6229552"/>
+            <a:ext cx="429207" cy="365125"/>
+          </a:xfrm>
+        </p:spPr>
+        <p:txBody>
+          <a:bodyPr anchor="ctr">
+            <a:normAutofit/>
+          </a:bodyPr>
           <a:lstStyle/>
           <a:p>
+            <a:pPr>
+              <a:spcAft>
+                <a:spcPts val="600"/>
+              </a:spcAft>
+            </a:pPr>
             <a:fld id="{CC057153-B650-4DEB-B370-79DDCFDCE934}" type="slidenum">
               <a:rPr lang="en-US" smtClean="0"/>
-              <a:pPr/>
+              <a:pPr>
+                <a:spcAft>
+                  <a:spcPts val="600"/>
+                </a:spcAft>
+              </a:pPr>
               <a:t>2</a:t>
             </a:fld>
-            <a:endParaRPr lang="en-US" dirty="0"/>
+            <a:endParaRPr lang="en-US"/>
           </a:p>
         </p:txBody>
       </p:sp>
     </p:spTree>
     <p:extLst>
       <p:ext uri="{BB962C8B-B14F-4D97-AF65-F5344CB8AC3E}">
-        <p14:creationId xmlns:p14="http://schemas.microsoft.com/office/powerpoint/2010/main" val="2823699821"/>
+        <p14:creationId xmlns:p14="http://schemas.microsoft.com/office/powerpoint/2010/main" val="703768538"/>
       </p:ext>
     </p:extLst>
   </p:cSld>
@@ -33931,7 +35066,7 @@
           <p:cNvPr id="2" name="Title 1">
             <a:extLst>
               <a:ext uri="{FF2B5EF4-FFF2-40B4-BE49-F238E27FC236}">
-                <a16:creationId xmlns:a16="http://schemas.microsoft.com/office/drawing/2014/main" id="{C6F9A5B3-D1E4-D0C2-F83A-1FA0DFF13296}"/>
+                <a16:creationId xmlns:a16="http://schemas.microsoft.com/office/drawing/2014/main" id="{55246322-0B3D-4729-5132-3C4A130943A7}"/>
               </a:ext>
             </a:extLst>
           </p:cNvPr>
@@ -33947,7 +35082,10 @@
           <a:bodyPr/>
           <a:lstStyle/>
           <a:p>
-            <a:endParaRPr lang="en-SG"/>
+            <a:r>
+              <a:rPr lang="en-SG" dirty="0"/>
+              <a:t>Relevance to the real world</a:t>
+            </a:r>
           </a:p>
         </p:txBody>
       </p:sp>
@@ -33956,7 +35094,7 @@
           <p:cNvPr id="3" name="Footer Placeholder 2">
             <a:extLst>
               <a:ext uri="{FF2B5EF4-FFF2-40B4-BE49-F238E27FC236}">
-                <a16:creationId xmlns:a16="http://schemas.microsoft.com/office/drawing/2014/main" id="{0EE80E97-6251-AC91-6D35-87EF2A034F80}"/>
+                <a16:creationId xmlns:a16="http://schemas.microsoft.com/office/drawing/2014/main" id="{0E30E219-9D5F-7F72-FC83-20A688DEAC8D}"/>
               </a:ext>
             </a:extLst>
           </p:cNvPr>
@@ -33985,7 +35123,7 @@
           <p:cNvPr id="4" name="Content Placeholder 3">
             <a:extLst>
               <a:ext uri="{FF2B5EF4-FFF2-40B4-BE49-F238E27FC236}">
-                <a16:creationId xmlns:a16="http://schemas.microsoft.com/office/drawing/2014/main" id="{7D2A119A-9A1B-4BDC-333B-C4F2A646A21F}"/>
+                <a16:creationId xmlns:a16="http://schemas.microsoft.com/office/drawing/2014/main" id="{ACB4BD60-8BD7-8099-D66F-D520E6307C4D}"/>
               </a:ext>
             </a:extLst>
           </p:cNvPr>
@@ -34001,7 +35139,106 @@
           <a:bodyPr/>
           <a:lstStyle/>
           <a:p>
-            <a:endParaRPr lang="en-SG" dirty="0"/>
+            <a:r>
+              <a:rPr lang="en-SG" dirty="0"/>
+              <a:t>Manual monitoring of large volumes of environmental data is </a:t>
+            </a:r>
+            <a:r>
+              <a:rPr lang="en-SG" b="1" dirty="0"/>
+              <a:t>time-consuming</a:t>
+            </a:r>
+            <a:r>
+              <a:rPr lang="en-SG" dirty="0"/>
+              <a:t> and prone to </a:t>
+            </a:r>
+            <a:r>
+              <a:rPr lang="en-SG" b="1" dirty="0"/>
+              <a:t>human error</a:t>
+            </a:r>
+            <a:r>
+              <a:rPr lang="en-SG" dirty="0"/>
+              <a:t>.</a:t>
+            </a:r>
+          </a:p>
+          <a:p>
+            <a:r>
+              <a:rPr lang="en-SG" dirty="0"/>
+              <a:t>Delayed detection of abnormal conditions can lead to </a:t>
+            </a:r>
+            <a:r>
+              <a:rPr lang="en-SG" b="1" dirty="0"/>
+              <a:t>equipment damage</a:t>
+            </a:r>
+            <a:r>
+              <a:rPr lang="en-SG" dirty="0"/>
+              <a:t>, </a:t>
+            </a:r>
+            <a:r>
+              <a:rPr lang="en-SG" b="1" dirty="0"/>
+              <a:t>safety risks</a:t>
+            </a:r>
+            <a:r>
+              <a:rPr lang="en-SG" dirty="0"/>
+              <a:t>, and </a:t>
+            </a:r>
+            <a:r>
+              <a:rPr lang="en-SG" b="1" dirty="0"/>
+              <a:t>operational downtime</a:t>
+            </a:r>
+            <a:r>
+              <a:rPr lang="en-SG" dirty="0"/>
+              <a:t>.</a:t>
+            </a:r>
+          </a:p>
+          <a:p>
+            <a:r>
+              <a:rPr lang="en-SG" b="1" dirty="0"/>
+              <a:t>Machine learning</a:t>
+            </a:r>
+            <a:r>
+              <a:rPr lang="en-SG" dirty="0"/>
+              <a:t> automatically analyses environmental data to detect anomalies early, enabling faster decision-making.</a:t>
+            </a:r>
+          </a:p>
+          <a:p>
+            <a:r>
+              <a:rPr lang="en-SG" b="1" dirty="0"/>
+              <a:t>Docker</a:t>
+            </a:r>
+            <a:r>
+              <a:rPr lang="en-SG" dirty="0"/>
+              <a:t> and </a:t>
+            </a:r>
+            <a:r>
+              <a:rPr lang="en-SG" b="1" dirty="0"/>
+              <a:t>Kubernetes</a:t>
+            </a:r>
+            <a:r>
+              <a:rPr lang="en-SG" dirty="0"/>
+              <a:t> provide a scalable and reliable microservices platform that can support increasing numbers of sensors and users.</a:t>
+            </a:r>
+          </a:p>
+          <a:p>
+            <a:r>
+              <a:rPr lang="en-SG" dirty="0"/>
+              <a:t>The system transforms environmental monitoring from </a:t>
+            </a:r>
+            <a:r>
+              <a:rPr lang="en-SG" b="1" dirty="0"/>
+              <a:t>reactive</a:t>
+            </a:r>
+            <a:r>
+              <a:rPr lang="en-SG" dirty="0"/>
+              <a:t> to </a:t>
+            </a:r>
+            <a:r>
+              <a:rPr lang="en-SG" b="1" dirty="0"/>
+              <a:t>proactive</a:t>
+            </a:r>
+            <a:r>
+              <a:rPr lang="en-SG" dirty="0"/>
+              <a:t>, improving efficiency and reliability.</a:t>
+            </a:r>
           </a:p>
         </p:txBody>
       </p:sp>
@@ -34010,7 +35247,7 @@
           <p:cNvPr id="5" name="Date Placeholder 4">
             <a:extLst>
               <a:ext uri="{FF2B5EF4-FFF2-40B4-BE49-F238E27FC236}">
-                <a16:creationId xmlns:a16="http://schemas.microsoft.com/office/drawing/2014/main" id="{A0D81173-2692-1EC8-9E30-62838359A5A5}"/>
+                <a16:creationId xmlns:a16="http://schemas.microsoft.com/office/drawing/2014/main" id="{B1CFFEBF-A7C8-0A3F-7105-B1C503C1B628}"/>
               </a:ext>
             </a:extLst>
           </p:cNvPr>
@@ -34028,7 +35265,7 @@
           <a:p>
             <a:fld id="{927C0DEB-4AE1-EA4D-826D-E3C22802B942}" type="datetime1">
               <a:rPr lang="en-US" smtClean="0"/>
-              <a:t>7/16/2026</a:t>
+              <a:t>7/20/2026</a:t>
             </a:fld>
             <a:endParaRPr lang="en-US" dirty="0"/>
           </a:p>
@@ -34039,7 +35276,7 @@
           <p:cNvPr id="6" name="Slide Number Placeholder 5">
             <a:extLst>
               <a:ext uri="{FF2B5EF4-FFF2-40B4-BE49-F238E27FC236}">
-                <a16:creationId xmlns:a16="http://schemas.microsoft.com/office/drawing/2014/main" id="{ABB406EC-D35C-8A52-7BBB-EB512633B053}"/>
+                <a16:creationId xmlns:a16="http://schemas.microsoft.com/office/drawing/2014/main" id="{A8BA9DB4-3C1C-F59A-B451-43E2C29B63CD}"/>
               </a:ext>
             </a:extLst>
           </p:cNvPr>
@@ -34067,7 +35304,7 @@
     </p:spTree>
     <p:extLst>
       <p:ext uri="{BB962C8B-B14F-4D97-AF65-F5344CB8AC3E}">
-        <p14:creationId xmlns:p14="http://schemas.microsoft.com/office/powerpoint/2010/main" val="703768538"/>
+        <p14:creationId xmlns:p14="http://schemas.microsoft.com/office/powerpoint/2010/main" val="2964319661"/>
       </p:ext>
     </p:extLst>
   </p:cSld>
@@ -34099,25 +35336,32 @@
           <p:cNvPr id="2" name="Title 1">
             <a:extLst>
               <a:ext uri="{FF2B5EF4-FFF2-40B4-BE49-F238E27FC236}">
-                <a16:creationId xmlns:a16="http://schemas.microsoft.com/office/drawing/2014/main" id="{54A8FB65-E92A-9D55-F7E1-938891E8A248}"/>
-              </a:ext>
-            </a:extLst>
-          </p:cNvPr>
-          <p:cNvSpPr>
-            <a:spLocks noGrp="1"/>
-          </p:cNvSpPr>
-          <p:nvPr>
-            <p:ph type="ctrTitle"/>
-          </p:nvPr>
-        </p:nvSpPr>
-        <p:spPr/>
-        <p:txBody>
-          <a:bodyPr/>
+                <a16:creationId xmlns:a16="http://schemas.microsoft.com/office/drawing/2014/main" id="{E3055C9A-7E3C-6B76-FADF-47C0F26633B7}"/>
+              </a:ext>
+            </a:extLst>
+          </p:cNvPr>
+          <p:cNvSpPr>
+            <a:spLocks noGrp="1"/>
+          </p:cNvSpPr>
+          <p:nvPr>
+            <p:ph type="title"/>
+          </p:nvPr>
+        </p:nvSpPr>
+        <p:spPr>
+          <a:xfrm>
+            <a:off x="1255032" y="862335"/>
+            <a:ext cx="4389120" cy="5120640"/>
+          </a:xfrm>
+        </p:spPr>
+        <p:txBody>
+          <a:bodyPr anchor="ctr">
+            <a:normAutofit/>
+          </a:bodyPr>
           <a:lstStyle/>
           <a:p>
             <a:r>
               <a:rPr lang="en-SG" dirty="0"/>
-              <a:t>Objectives</a:t>
+              <a:t>objectives</a:t>
             </a:r>
           </a:p>
         </p:txBody>
@@ -34127,7 +35371,7 @@
           <p:cNvPr id="3" name="Footer Placeholder 2">
             <a:extLst>
               <a:ext uri="{FF2B5EF4-FFF2-40B4-BE49-F238E27FC236}">
-                <a16:creationId xmlns:a16="http://schemas.microsoft.com/office/drawing/2014/main" id="{DA4EFA38-3F70-0F7D-636F-755C34F032F7}"/>
+                <a16:creationId xmlns:a16="http://schemas.microsoft.com/office/drawing/2014/main" id="{29BC339A-8F50-0784-BA77-D11E3DB36706}"/>
               </a:ext>
             </a:extLst>
           </p:cNvPr>
@@ -34138,25 +35382,92 @@
             <p:ph type="ftr" sz="quarter" idx="11"/>
           </p:nvPr>
         </p:nvSpPr>
-        <p:spPr/>
-        <p:txBody>
-          <a:bodyPr/>
+        <p:spPr>
+          <a:xfrm rot="16200000">
+            <a:off x="-1005840" y="1525384"/>
+            <a:ext cx="2805405" cy="365125"/>
+          </a:xfrm>
+        </p:spPr>
+        <p:txBody>
+          <a:bodyPr anchor="ctr">
+            <a:normAutofit/>
+          </a:bodyPr>
           <a:lstStyle/>
           <a:p>
+            <a:pPr>
+              <a:spcAft>
+                <a:spcPts val="600"/>
+              </a:spcAft>
+            </a:pPr>
             <a:r>
               <a:rPr lang="en-US"/>
               <a:t>SAMPLE FOOTER TEXT</a:t>
             </a:r>
-            <a:endParaRPr lang="en-US" dirty="0"/>
-          </a:p>
-        </p:txBody>
-      </p:sp>
-      <p:sp>
-        <p:nvSpPr>
-          <p:cNvPr id="4" name="Date Placeholder 3">
-            <a:extLst>
-              <a:ext uri="{FF2B5EF4-FFF2-40B4-BE49-F238E27FC236}">
-                <a16:creationId xmlns:a16="http://schemas.microsoft.com/office/drawing/2014/main" id="{49E71233-6318-9E50-6D27-72BFB585494C}"/>
+          </a:p>
+        </p:txBody>
+      </p:sp>
+      <p:sp>
+        <p:nvSpPr>
+          <p:cNvPr id="4" name="Content Placeholder 3">
+            <a:extLst>
+              <a:ext uri="{FF2B5EF4-FFF2-40B4-BE49-F238E27FC236}">
+                <a16:creationId xmlns:a16="http://schemas.microsoft.com/office/drawing/2014/main" id="{2EA954F3-E23B-4AAA-7854-BCF9CAC0B0EB}"/>
+              </a:ext>
+            </a:extLst>
+          </p:cNvPr>
+          <p:cNvSpPr>
+            <a:spLocks noGrp="1"/>
+          </p:cNvSpPr>
+          <p:nvPr>
+            <p:ph sz="quarter" idx="13"/>
+          </p:nvPr>
+        </p:nvSpPr>
+        <p:spPr>
+          <a:xfrm>
+            <a:off x="6547100" y="816615"/>
+            <a:ext cx="4389120" cy="5212080"/>
+          </a:xfrm>
+        </p:spPr>
+        <p:txBody>
+          <a:bodyPr anchor="ctr">
+            <a:normAutofit/>
+          </a:bodyPr>
+          <a:lstStyle/>
+          <a:p>
+            <a:pPr marL="342900" indent="-342900">
+              <a:buFont typeface="+mj-lt"/>
+              <a:buAutoNum type="arabicPeriod"/>
+            </a:pPr>
+            <a:r>
+              <a:rPr lang="en-SG" dirty="0"/>
+              <a:t>Automated Analysis: Use machine learning to interpret sensor data instead of relying solely on raw readings</a:t>
+            </a:r>
+            <a:br>
+              <a:rPr lang="en-SG" dirty="0"/>
+            </a:br>
+            <a:endParaRPr lang="en-SG" dirty="0"/>
+          </a:p>
+          <a:p>
+            <a:pPr marL="342900" indent="-342900">
+              <a:buFont typeface="+mj-lt"/>
+              <a:buAutoNum type="arabicPeriod"/>
+            </a:pPr>
+            <a:r>
+              <a:rPr lang="en-SG" dirty="0"/>
+              <a:t>Early Detection: Identify abnormal environmental conditions (e.g., pollution spikes, temperature anomalies) before they escalate.</a:t>
+            </a:r>
+          </a:p>
+          <a:p>
+            <a:endParaRPr lang="en-SG" dirty="0"/>
+          </a:p>
+        </p:txBody>
+      </p:sp>
+      <p:sp>
+        <p:nvSpPr>
+          <p:cNvPr id="5" name="Date Placeholder 4">
+            <a:extLst>
+              <a:ext uri="{FF2B5EF4-FFF2-40B4-BE49-F238E27FC236}">
+                <a16:creationId xmlns:a16="http://schemas.microsoft.com/office/drawing/2014/main" id="{FB80295A-201E-4C8E-5F1C-78321DECB4E1}"/>
               </a:ext>
             </a:extLst>
           </p:cNvPr>
@@ -34167,25 +35478,42 @@
             <p:ph type="dt" sz="half" idx="10"/>
           </p:nvPr>
         </p:nvSpPr>
-        <p:spPr/>
-        <p:txBody>
-          <a:bodyPr/>
+        <p:spPr>
+          <a:xfrm rot="5400000">
+            <a:off x="10040831" y="4206240"/>
+            <a:ext cx="3494314" cy="365125"/>
+          </a:xfrm>
+        </p:spPr>
+        <p:txBody>
+          <a:bodyPr anchor="ctr">
+            <a:normAutofit/>
+          </a:bodyPr>
           <a:lstStyle/>
           <a:p>
-            <a:fld id="{010D0AB2-23BC-3043-AC30-5928E542C0CE}" type="datetime1">
+            <a:pPr>
+              <a:spcAft>
+                <a:spcPts val="600"/>
+              </a:spcAft>
+            </a:pPr>
+            <a:fld id="{927C0DEB-4AE1-EA4D-826D-E3C22802B942}" type="datetime1">
               <a:rPr lang="en-US" smtClean="0"/>
-              <a:t>7/16/2026</a:t>
+              <a:pPr>
+                <a:spcAft>
+                  <a:spcPts val="600"/>
+                </a:spcAft>
+              </a:pPr>
+              <a:t>7/20/2026</a:t>
             </a:fld>
-            <a:endParaRPr lang="en-US" dirty="0"/>
-          </a:p>
-        </p:txBody>
-      </p:sp>
-      <p:sp>
-        <p:nvSpPr>
-          <p:cNvPr id="5" name="Slide Number Placeholder 4">
-            <a:extLst>
-              <a:ext uri="{FF2B5EF4-FFF2-40B4-BE49-F238E27FC236}">
-                <a16:creationId xmlns:a16="http://schemas.microsoft.com/office/drawing/2014/main" id="{0143C50A-6321-93AA-1E3D-B2D85FEBB0A2}"/>
+            <a:endParaRPr lang="en-US"/>
+          </a:p>
+        </p:txBody>
+      </p:sp>
+      <p:sp>
+        <p:nvSpPr>
+          <p:cNvPr id="6" name="Slide Number Placeholder 5">
+            <a:extLst>
+              <a:ext uri="{FF2B5EF4-FFF2-40B4-BE49-F238E27FC236}">
+                <a16:creationId xmlns:a16="http://schemas.microsoft.com/office/drawing/2014/main" id="{DDF07D2A-8B5E-C403-63AE-D9A0F7900580}"/>
               </a:ext>
             </a:extLst>
           </p:cNvPr>
@@ -34196,24 +35524,40 @@
             <p:ph type="sldNum" sz="quarter" idx="12"/>
           </p:nvPr>
         </p:nvSpPr>
-        <p:spPr/>
-        <p:txBody>
-          <a:bodyPr/>
+        <p:spPr>
+          <a:xfrm>
+            <a:off x="11573385" y="6229552"/>
+            <a:ext cx="429207" cy="365125"/>
+          </a:xfrm>
+        </p:spPr>
+        <p:txBody>
+          <a:bodyPr anchor="ctr">
+            <a:normAutofit/>
+          </a:bodyPr>
           <a:lstStyle/>
           <a:p>
+            <a:pPr>
+              <a:spcAft>
+                <a:spcPts val="600"/>
+              </a:spcAft>
+            </a:pPr>
             <a:fld id="{CC057153-B650-4DEB-B370-79DDCFDCE934}" type="slidenum">
               <a:rPr lang="en-US" smtClean="0"/>
-              <a:pPr/>
+              <a:pPr>
+                <a:spcAft>
+                  <a:spcPts val="600"/>
+                </a:spcAft>
+              </a:pPr>
               <a:t>4</a:t>
             </a:fld>
-            <a:endParaRPr lang="en-US" dirty="0"/>
+            <a:endParaRPr lang="en-US"/>
           </a:p>
         </p:txBody>
       </p:sp>
     </p:spTree>
     <p:extLst>
       <p:ext uri="{BB962C8B-B14F-4D97-AF65-F5344CB8AC3E}">
-        <p14:creationId xmlns:p14="http://schemas.microsoft.com/office/powerpoint/2010/main" val="169991198"/>
+        <p14:creationId xmlns:p14="http://schemas.microsoft.com/office/powerpoint/2010/main" val="4086145406"/>
       </p:ext>
     </p:extLst>
   </p:cSld>
@@ -34245,122 +35589,308 @@
           <p:cNvPr id="2" name="Title 1">
             <a:extLst>
               <a:ext uri="{FF2B5EF4-FFF2-40B4-BE49-F238E27FC236}">
-                <a16:creationId xmlns:a16="http://schemas.microsoft.com/office/drawing/2014/main" id="{2DFFA181-16A4-7A9A-470B-6E45C0622691}"/>
-              </a:ext>
-            </a:extLst>
-          </p:cNvPr>
-          <p:cNvSpPr>
-            <a:spLocks noGrp="1"/>
-          </p:cNvSpPr>
-          <p:nvPr>
-            <p:ph type="ctrTitle"/>
-          </p:nvPr>
-        </p:nvSpPr>
-        <p:spPr/>
+                <a16:creationId xmlns:a16="http://schemas.microsoft.com/office/drawing/2014/main" id="{52CDCD7B-6D14-57C9-31B0-FF2C7F3508F8}"/>
+              </a:ext>
+            </a:extLst>
+          </p:cNvPr>
+          <p:cNvSpPr>
+            <a:spLocks noGrp="1"/>
+          </p:cNvSpPr>
+          <p:nvPr>
+            <p:ph type="title"/>
+          </p:nvPr>
+        </p:nvSpPr>
+        <p:spPr>
+          <a:xfrm>
+            <a:off x="1245108" y="786384"/>
+            <a:ext cx="4023360" cy="1280160"/>
+          </a:xfrm>
+        </p:spPr>
+        <p:txBody>
+          <a:bodyPr anchor="t">
+            <a:normAutofit/>
+          </a:bodyPr>
+          <a:lstStyle/>
+          <a:p>
+            <a:r>
+              <a:rPr lang="en-SG" dirty="0"/>
+              <a:t>Intended benefits</a:t>
+            </a:r>
+          </a:p>
+        </p:txBody>
+      </p:sp>
+      <p:sp>
+        <p:nvSpPr>
+          <p:cNvPr id="3" name="Footer Placeholder 2">
+            <a:extLst>
+              <a:ext uri="{FF2B5EF4-FFF2-40B4-BE49-F238E27FC236}">
+                <a16:creationId xmlns:a16="http://schemas.microsoft.com/office/drawing/2014/main" id="{1A2E9870-B90D-6107-EC7C-F94E7FF3D9B9}"/>
+              </a:ext>
+            </a:extLst>
+          </p:cNvPr>
+          <p:cNvSpPr>
+            <a:spLocks noGrp="1"/>
+          </p:cNvSpPr>
+          <p:nvPr>
+            <p:ph type="ftr" sz="quarter" idx="11"/>
+          </p:nvPr>
+        </p:nvSpPr>
+        <p:spPr>
+          <a:xfrm rot="16200000">
+            <a:off x="-1005840" y="1525384"/>
+            <a:ext cx="2805405" cy="365125"/>
+          </a:xfrm>
+        </p:spPr>
+        <p:txBody>
+          <a:bodyPr anchor="ctr">
+            <a:normAutofit/>
+          </a:bodyPr>
+          <a:lstStyle/>
+          <a:p>
+            <a:pPr>
+              <a:spcAft>
+                <a:spcPts val="600"/>
+              </a:spcAft>
+            </a:pPr>
+            <a:r>
+              <a:rPr lang="en-US"/>
+              <a:t>SAMPLE FOOTER TEXT</a:t>
+            </a:r>
+          </a:p>
+        </p:txBody>
+      </p:sp>
+      <p:sp>
+        <p:nvSpPr>
+          <p:cNvPr id="11" name="Picture Placeholder 3">
+            <a:extLst>
+              <a:ext uri="{FF2B5EF4-FFF2-40B4-BE49-F238E27FC236}">
+                <a16:creationId xmlns:a16="http://schemas.microsoft.com/office/drawing/2014/main" id="{219EA569-FBDF-BD75-F62D-BCFC76D305F0}"/>
+              </a:ext>
+            </a:extLst>
+          </p:cNvPr>
+          <p:cNvSpPr>
+            <a:spLocks noGrp="1"/>
+          </p:cNvSpPr>
+          <p:nvPr>
+            <p:ph type="pic" sz="quarter" idx="13"/>
+          </p:nvPr>
+        </p:nvSpPr>
+        <p:spPr>
+          <a:xfrm>
+            <a:off x="1220455" y="2396086"/>
+            <a:ext cx="4070907" cy="3637825"/>
+          </a:xfrm>
+        </p:spPr>
         <p:txBody>
           <a:bodyPr/>
           <a:lstStyle/>
           <a:p>
-            <a:r>
-              <a:rPr lang="en-US" dirty="0"/>
-              <a:t>DATA SOURCES</a:t>
-            </a:r>
+            <a:endParaRPr lang="en-SG"/>
+          </a:p>
+        </p:txBody>
+      </p:sp>
+      <p:sp>
+        <p:nvSpPr>
+          <p:cNvPr id="4" name="Content Placeholder 3">
+            <a:extLst>
+              <a:ext uri="{FF2B5EF4-FFF2-40B4-BE49-F238E27FC236}">
+                <a16:creationId xmlns:a16="http://schemas.microsoft.com/office/drawing/2014/main" id="{45B5A5C7-4764-9F54-D4E6-F24E40DF50E1}"/>
+              </a:ext>
+            </a:extLst>
+          </p:cNvPr>
+          <p:cNvSpPr>
+            <a:spLocks noGrp="1"/>
+          </p:cNvSpPr>
+          <p:nvPr>
+            <p:ph sz="quarter" idx="14"/>
+          </p:nvPr>
+        </p:nvSpPr>
+        <p:spPr>
+          <a:xfrm>
+            <a:off x="5669280" y="786384"/>
+            <a:ext cx="5303520" cy="5303520"/>
+          </a:xfrm>
+        </p:spPr>
+        <p:txBody>
+          <a:bodyPr>
+            <a:normAutofit/>
+          </a:bodyPr>
+          <a:lstStyle/>
+          <a:p>
+            <a:pPr marL="342900" indent="-342900">
+              <a:buFont typeface="+mj-lt"/>
+              <a:buAutoNum type="arabicPeriod"/>
+            </a:pPr>
+            <a:r>
+              <a:rPr lang="en-SG" dirty="0"/>
+              <a:t>Reduced Manual Monitoring: Eliminates the need for users to constantly track large datasets.</a:t>
+            </a:r>
+          </a:p>
+          <a:p>
+            <a:pPr marL="342900" indent="-342900">
+              <a:buFont typeface="+mj-lt"/>
+              <a:buAutoNum type="arabicPeriod"/>
+            </a:pPr>
+            <a:r>
+              <a:rPr lang="en-SG" dirty="0"/>
+              <a:t>Timely Responses: Early warnings help prevent environmental hazards or mitigate their impact.</a:t>
+            </a:r>
+          </a:p>
+          <a:p>
+            <a:pPr marL="342900" indent="-342900">
+              <a:buFont typeface="+mj-lt"/>
+              <a:buAutoNum type="arabicPeriod"/>
+            </a:pPr>
+            <a:r>
+              <a:rPr lang="en-SG" dirty="0"/>
+              <a:t>Scalability &amp; Reliability: Kubernetes ensures the system can handle growing sensor networks and data streams.</a:t>
+            </a:r>
+          </a:p>
+          <a:p>
+            <a:pPr marL="342900" indent="-342900">
+              <a:buFont typeface="+mj-lt"/>
+              <a:buAutoNum type="arabicPeriod"/>
+            </a:pPr>
+            <a:r>
+              <a:rPr lang="en-SG" dirty="0"/>
+              <a:t>Improved Accuracy: AI models can detect subtle anomalies that humans might miss.</a:t>
+            </a:r>
+          </a:p>
+          <a:p>
+            <a:pPr marL="342900" indent="-342900">
+              <a:buFont typeface="+mj-lt"/>
+              <a:buAutoNum type="arabicPeriod"/>
+            </a:pPr>
+            <a:r>
+              <a:rPr lang="en-SG" dirty="0"/>
+              <a:t>Cross-Domain Applications: Supports monitoring of air quality, water pollution, biodiversity, and climate hazards.</a:t>
+            </a:r>
+          </a:p>
+          <a:p>
+            <a:pPr marL="342900" indent="-342900">
+              <a:buFont typeface="+mj-lt"/>
+              <a:buAutoNum type="arabicPeriod"/>
+            </a:pPr>
+            <a:r>
+              <a:rPr lang="en-SG" dirty="0"/>
+              <a:t>Operational Efficiency: Microservices allow faster updates, easier maintenance, and resilience against failures.</a:t>
+            </a:r>
+          </a:p>
+          <a:p>
+            <a:pPr marL="342900" indent="-342900">
+              <a:buFont typeface="+mj-lt"/>
+              <a:buAutoNum type="arabicPeriod"/>
+            </a:pPr>
+            <a:r>
+              <a:rPr lang="en-SG" dirty="0"/>
+              <a:t>Public Accountability: Provides transparent, scientifically valid insights for policymakers and communities.</a:t>
+            </a:r>
+          </a:p>
+          <a:p>
+            <a:pPr marL="342900" indent="-342900">
+              <a:buFont typeface="+mj-lt"/>
+              <a:buAutoNum type="arabicPeriod"/>
+            </a:pPr>
             <a:endParaRPr lang="en-SG" dirty="0"/>
           </a:p>
         </p:txBody>
       </p:sp>
       <p:sp>
         <p:nvSpPr>
-          <p:cNvPr id="3" name="Footer Placeholder 2">
-            <a:extLst>
-              <a:ext uri="{FF2B5EF4-FFF2-40B4-BE49-F238E27FC236}">
-                <a16:creationId xmlns:a16="http://schemas.microsoft.com/office/drawing/2014/main" id="{EDA3C22C-23C6-3AD7-5E8D-02A5C12887BC}"/>
-              </a:ext>
-            </a:extLst>
-          </p:cNvPr>
-          <p:cNvSpPr>
-            <a:spLocks noGrp="1"/>
-          </p:cNvSpPr>
-          <p:nvPr>
-            <p:ph type="ftr" sz="quarter" idx="11"/>
-          </p:nvPr>
-        </p:nvSpPr>
-        <p:spPr/>
-        <p:txBody>
-          <a:bodyPr/>
+          <p:cNvPr id="5" name="Date Placeholder 4">
+            <a:extLst>
+              <a:ext uri="{FF2B5EF4-FFF2-40B4-BE49-F238E27FC236}">
+                <a16:creationId xmlns:a16="http://schemas.microsoft.com/office/drawing/2014/main" id="{81DD13BB-A229-9E27-75B9-43DFD4F62A99}"/>
+              </a:ext>
+            </a:extLst>
+          </p:cNvPr>
+          <p:cNvSpPr>
+            <a:spLocks noGrp="1"/>
+          </p:cNvSpPr>
+          <p:nvPr>
+            <p:ph type="dt" sz="half" idx="10"/>
+          </p:nvPr>
+        </p:nvSpPr>
+        <p:spPr>
+          <a:xfrm rot="5400000">
+            <a:off x="10040831" y="4206240"/>
+            <a:ext cx="3494314" cy="365125"/>
+          </a:xfrm>
+        </p:spPr>
+        <p:txBody>
+          <a:bodyPr anchor="ctr">
+            <a:normAutofit/>
+          </a:bodyPr>
           <a:lstStyle/>
           <a:p>
-            <a:r>
-              <a:rPr lang="en-US"/>
-              <a:t>SAMPLE FOOTER TEXT</a:t>
-            </a:r>
-            <a:endParaRPr lang="en-US" dirty="0"/>
-          </a:p>
-        </p:txBody>
-      </p:sp>
-      <p:sp>
-        <p:nvSpPr>
-          <p:cNvPr id="4" name="Date Placeholder 3">
-            <a:extLst>
-              <a:ext uri="{FF2B5EF4-FFF2-40B4-BE49-F238E27FC236}">
-                <a16:creationId xmlns:a16="http://schemas.microsoft.com/office/drawing/2014/main" id="{D6152659-5563-EC41-26B2-E75502BC1D6E}"/>
-              </a:ext>
-            </a:extLst>
-          </p:cNvPr>
-          <p:cNvSpPr>
-            <a:spLocks noGrp="1"/>
-          </p:cNvSpPr>
-          <p:nvPr>
-            <p:ph type="dt" sz="half" idx="10"/>
-          </p:nvPr>
-        </p:nvSpPr>
-        <p:spPr/>
-        <p:txBody>
-          <a:bodyPr/>
+            <a:pPr>
+              <a:spcAft>
+                <a:spcPts val="600"/>
+              </a:spcAft>
+            </a:pPr>
+            <a:fld id="{927C0DEB-4AE1-EA4D-826D-E3C22802B942}" type="datetime1">
+              <a:rPr lang="en-US" smtClean="0"/>
+              <a:pPr>
+                <a:spcAft>
+                  <a:spcPts val="600"/>
+                </a:spcAft>
+              </a:pPr>
+              <a:t>7/20/2026</a:t>
+            </a:fld>
+            <a:endParaRPr lang="en-US"/>
+          </a:p>
+        </p:txBody>
+      </p:sp>
+      <p:sp>
+        <p:nvSpPr>
+          <p:cNvPr id="6" name="Slide Number Placeholder 5">
+            <a:extLst>
+              <a:ext uri="{FF2B5EF4-FFF2-40B4-BE49-F238E27FC236}">
+                <a16:creationId xmlns:a16="http://schemas.microsoft.com/office/drawing/2014/main" id="{7DCCAA88-BC96-D2FB-AD61-20AC8FD044C9}"/>
+              </a:ext>
+            </a:extLst>
+          </p:cNvPr>
+          <p:cNvSpPr>
+            <a:spLocks noGrp="1"/>
+          </p:cNvSpPr>
+          <p:nvPr>
+            <p:ph type="sldNum" sz="quarter" idx="12"/>
+          </p:nvPr>
+        </p:nvSpPr>
+        <p:spPr>
+          <a:xfrm>
+            <a:off x="11573385" y="6229552"/>
+            <a:ext cx="429207" cy="365125"/>
+          </a:xfrm>
+        </p:spPr>
+        <p:txBody>
+          <a:bodyPr anchor="ctr">
+            <a:normAutofit/>
+          </a:bodyPr>
           <a:lstStyle/>
           <a:p>
-            <a:fld id="{53D1C53B-D534-AA48-85B3-4F5B03DDCBA8}" type="datetime1">
-              <a:rPr lang="en-US" smtClean="0"/>
-              <a:t>7/16/2026</a:t>
-            </a:fld>
-            <a:endParaRPr lang="en-US" dirty="0"/>
-          </a:p>
-        </p:txBody>
-      </p:sp>
-      <p:sp>
-        <p:nvSpPr>
-          <p:cNvPr id="5" name="Slide Number Placeholder 4">
-            <a:extLst>
-              <a:ext uri="{FF2B5EF4-FFF2-40B4-BE49-F238E27FC236}">
-                <a16:creationId xmlns:a16="http://schemas.microsoft.com/office/drawing/2014/main" id="{1460C55C-E9B4-3D3E-8062-271E6DBDB208}"/>
-              </a:ext>
-            </a:extLst>
-          </p:cNvPr>
-          <p:cNvSpPr>
-            <a:spLocks noGrp="1"/>
-          </p:cNvSpPr>
-          <p:nvPr>
-            <p:ph type="sldNum" sz="quarter" idx="12"/>
-          </p:nvPr>
-        </p:nvSpPr>
-        <p:spPr/>
-        <p:txBody>
-          <a:bodyPr/>
-          <a:lstStyle/>
-          <a:p>
+            <a:pPr>
+              <a:spcAft>
+                <a:spcPts val="600"/>
+              </a:spcAft>
+            </a:pPr>
             <a:fld id="{CC057153-B650-4DEB-B370-79DDCFDCE934}" type="slidenum">
               <a:rPr lang="en-US" smtClean="0"/>
-              <a:pPr/>
+              <a:pPr>
+                <a:spcAft>
+                  <a:spcPts val="600"/>
+                </a:spcAft>
+              </a:pPr>
               <a:t>5</a:t>
             </a:fld>
-            <a:endParaRPr lang="en-US" dirty="0"/>
+            <a:endParaRPr lang="en-US"/>
           </a:p>
         </p:txBody>
       </p:sp>
     </p:spTree>
     <p:extLst>
       <p:ext uri="{BB962C8B-B14F-4D97-AF65-F5344CB8AC3E}">
-        <p14:creationId xmlns:p14="http://schemas.microsoft.com/office/powerpoint/2010/main" val="1755218782"/>
+        <p14:creationId xmlns:p14="http://schemas.microsoft.com/office/powerpoint/2010/main" val="131214016"/>
       </p:ext>
     </p:extLst>
   </p:cSld>
@@ -34392,7 +35922,7 @@
           <p:cNvPr id="2" name="Title 1">
             <a:extLst>
               <a:ext uri="{FF2B5EF4-FFF2-40B4-BE49-F238E27FC236}">
-                <a16:creationId xmlns:a16="http://schemas.microsoft.com/office/drawing/2014/main" id="{620370BE-8DE3-A822-3581-32C470E6A7C5}"/>
+                <a16:creationId xmlns:a16="http://schemas.microsoft.com/office/drawing/2014/main" id="{2DFFA181-16A4-7A9A-470B-6E45C0622691}"/>
               </a:ext>
             </a:extLst>
           </p:cNvPr>
@@ -34403,19 +35933,14 @@
             <p:ph type="ctrTitle"/>
           </p:nvPr>
         </p:nvSpPr>
-        <p:spPr>
-          <a:xfrm>
-            <a:off x="3525329" y="1463040"/>
-            <a:ext cx="5135592" cy="3931920"/>
-          </a:xfrm>
-        </p:spPr>
+        <p:spPr/>
         <p:txBody>
           <a:bodyPr/>
           <a:lstStyle/>
           <a:p>
             <a:r>
               <a:rPr lang="en-US" dirty="0"/>
-              <a:t>SYSTEM ARCHITECTURE</a:t>
+              <a:t>DATA SOURCES</a:t>
             </a:r>
             <a:endParaRPr lang="en-SG" dirty="0"/>
           </a:p>
@@ -34426,7 +35951,7 @@
           <p:cNvPr id="3" name="Footer Placeholder 2">
             <a:extLst>
               <a:ext uri="{FF2B5EF4-FFF2-40B4-BE49-F238E27FC236}">
-                <a16:creationId xmlns:a16="http://schemas.microsoft.com/office/drawing/2014/main" id="{73069D14-BAC5-3AD0-19AE-5205566A5BF9}"/>
+                <a16:creationId xmlns:a16="http://schemas.microsoft.com/office/drawing/2014/main" id="{EDA3C22C-23C6-3AD7-5E8D-02A5C12887BC}"/>
               </a:ext>
             </a:extLst>
           </p:cNvPr>
@@ -34455,7 +35980,7 @@
           <p:cNvPr id="4" name="Date Placeholder 3">
             <a:extLst>
               <a:ext uri="{FF2B5EF4-FFF2-40B4-BE49-F238E27FC236}">
-                <a16:creationId xmlns:a16="http://schemas.microsoft.com/office/drawing/2014/main" id="{7FF7D1A3-9AE2-A2B4-0F26-15EEA9A91F03}"/>
+                <a16:creationId xmlns:a16="http://schemas.microsoft.com/office/drawing/2014/main" id="{D6152659-5563-EC41-26B2-E75502BC1D6E}"/>
               </a:ext>
             </a:extLst>
           </p:cNvPr>
@@ -34473,7 +35998,7 @@
           <a:p>
             <a:fld id="{53D1C53B-D534-AA48-85B3-4F5B03DDCBA8}" type="datetime1">
               <a:rPr lang="en-US" smtClean="0"/>
-              <a:t>7/16/2026</a:t>
+              <a:t>7/19/2026</a:t>
             </a:fld>
             <a:endParaRPr lang="en-US" dirty="0"/>
           </a:p>
@@ -34484,7 +36009,7 @@
           <p:cNvPr id="5" name="Slide Number Placeholder 4">
             <a:extLst>
               <a:ext uri="{FF2B5EF4-FFF2-40B4-BE49-F238E27FC236}">
-                <a16:creationId xmlns:a16="http://schemas.microsoft.com/office/drawing/2014/main" id="{31C00A42-6809-D208-69EF-84DEF6850371}"/>
+                <a16:creationId xmlns:a16="http://schemas.microsoft.com/office/drawing/2014/main" id="{1460C55C-E9B4-3D3E-8062-271E6DBDB208}"/>
               </a:ext>
             </a:extLst>
           </p:cNvPr>
@@ -34512,7 +36037,7 @@
     </p:spTree>
     <p:extLst>
       <p:ext uri="{BB962C8B-B14F-4D97-AF65-F5344CB8AC3E}">
-        <p14:creationId xmlns:p14="http://schemas.microsoft.com/office/powerpoint/2010/main" val="123989611"/>
+        <p14:creationId xmlns:p14="http://schemas.microsoft.com/office/powerpoint/2010/main" val="1755218782"/>
       </p:ext>
     </p:extLst>
   </p:cSld>
@@ -34544,7 +36069,7 @@
           <p:cNvPr id="2" name="Title 1">
             <a:extLst>
               <a:ext uri="{FF2B5EF4-FFF2-40B4-BE49-F238E27FC236}">
-                <a16:creationId xmlns:a16="http://schemas.microsoft.com/office/drawing/2014/main" id="{DEFF6106-7A0A-48DF-A54A-1203136FE872}"/>
+                <a16:creationId xmlns:a16="http://schemas.microsoft.com/office/drawing/2014/main" id="{620370BE-8DE3-A822-3581-32C470E6A7C5}"/>
               </a:ext>
             </a:extLst>
           </p:cNvPr>
@@ -34555,15 +36080,21 @@
             <p:ph type="ctrTitle"/>
           </p:nvPr>
         </p:nvSpPr>
-        <p:spPr/>
+        <p:spPr>
+          <a:xfrm>
+            <a:off x="3525329" y="1463040"/>
+            <a:ext cx="5135592" cy="3931920"/>
+          </a:xfrm>
+        </p:spPr>
         <p:txBody>
           <a:bodyPr/>
           <a:lstStyle/>
           <a:p>
             <a:r>
-              <a:rPr lang="en-SG" dirty="0"/>
-              <a:t>Docker</a:t>
-            </a:r>
+              <a:rPr lang="en-US" dirty="0"/>
+              <a:t>SYSTEM ARCHITECTURE</a:t>
+            </a:r>
+            <a:endParaRPr lang="en-SG" dirty="0"/>
           </a:p>
         </p:txBody>
       </p:sp>
@@ -34572,7 +36103,7 @@
           <p:cNvPr id="3" name="Footer Placeholder 2">
             <a:extLst>
               <a:ext uri="{FF2B5EF4-FFF2-40B4-BE49-F238E27FC236}">
-                <a16:creationId xmlns:a16="http://schemas.microsoft.com/office/drawing/2014/main" id="{B2BCAD1A-CFBC-A349-DD67-7349B93D3720}"/>
+                <a16:creationId xmlns:a16="http://schemas.microsoft.com/office/drawing/2014/main" id="{73069D14-BAC5-3AD0-19AE-5205566A5BF9}"/>
               </a:ext>
             </a:extLst>
           </p:cNvPr>
@@ -34601,7 +36132,7 @@
           <p:cNvPr id="4" name="Date Placeholder 3">
             <a:extLst>
               <a:ext uri="{FF2B5EF4-FFF2-40B4-BE49-F238E27FC236}">
-                <a16:creationId xmlns:a16="http://schemas.microsoft.com/office/drawing/2014/main" id="{3BA4730D-F0FF-B752-323B-BE0157CA02F8}"/>
+                <a16:creationId xmlns:a16="http://schemas.microsoft.com/office/drawing/2014/main" id="{7FF7D1A3-9AE2-A2B4-0F26-15EEA9A91F03}"/>
               </a:ext>
             </a:extLst>
           </p:cNvPr>
@@ -34617,9 +36148,9 @@
           <a:bodyPr/>
           <a:lstStyle/>
           <a:p>
-            <a:fld id="{010D0AB2-23BC-3043-AC30-5928E542C0CE}" type="datetime1">
+            <a:fld id="{53D1C53B-D534-AA48-85B3-4F5B03DDCBA8}" type="datetime1">
               <a:rPr lang="en-US" smtClean="0"/>
-              <a:t>7/16/2026</a:t>
+              <a:t>7/19/2026</a:t>
             </a:fld>
             <a:endParaRPr lang="en-US" dirty="0"/>
           </a:p>
@@ -34630,7 +36161,7 @@
           <p:cNvPr id="5" name="Slide Number Placeholder 4">
             <a:extLst>
               <a:ext uri="{FF2B5EF4-FFF2-40B4-BE49-F238E27FC236}">
-                <a16:creationId xmlns:a16="http://schemas.microsoft.com/office/drawing/2014/main" id="{49E7DB59-C4F8-CDE1-61A4-49E42A74492A}"/>
+                <a16:creationId xmlns:a16="http://schemas.microsoft.com/office/drawing/2014/main" id="{31C00A42-6809-D208-69EF-84DEF6850371}"/>
               </a:ext>
             </a:extLst>
           </p:cNvPr>
@@ -34658,7 +36189,7 @@
     </p:spTree>
     <p:extLst>
       <p:ext uri="{BB962C8B-B14F-4D97-AF65-F5344CB8AC3E}">
-        <p14:creationId xmlns:p14="http://schemas.microsoft.com/office/powerpoint/2010/main" val="1662138044"/>
+        <p14:creationId xmlns:p14="http://schemas.microsoft.com/office/powerpoint/2010/main" val="123989611"/>
       </p:ext>
     </p:extLst>
   </p:cSld>
@@ -34673,7 +36204,13 @@
   <p:cSld>
     <p:spTree>
       <p:nvGrpSpPr>
-        <p:cNvPr id="1" name=""/>
+        <p:cNvPr id="1" name="">
+          <a:extLst>
+            <a:ext uri="{FF2B5EF4-FFF2-40B4-BE49-F238E27FC236}">
+              <a16:creationId xmlns:a16="http://schemas.microsoft.com/office/drawing/2014/main" id="{FC24A24B-A787-5443-C639-97DBBA59FD9C}"/>
+            </a:ext>
+          </a:extLst>
+        </p:cNvPr>
         <p:cNvGrpSpPr/>
         <p:nvPr/>
       </p:nvGrpSpPr>
@@ -34690,15 +36227,15 @@
           <p:cNvPr id="2" name="Title 1">
             <a:extLst>
               <a:ext uri="{FF2B5EF4-FFF2-40B4-BE49-F238E27FC236}">
-                <a16:creationId xmlns:a16="http://schemas.microsoft.com/office/drawing/2014/main" id="{F27EEF88-486E-52FF-3AF3-C50D322E6819}"/>
-              </a:ext>
-            </a:extLst>
-          </p:cNvPr>
-          <p:cNvSpPr>
-            <a:spLocks noGrp="1"/>
-          </p:cNvSpPr>
-          <p:nvPr>
-            <p:ph type="ctrTitle"/>
+                <a16:creationId xmlns:a16="http://schemas.microsoft.com/office/drawing/2014/main" id="{E24BDE2F-EF30-1E71-B29C-168161ABE53C}"/>
+              </a:ext>
+            </a:extLst>
+          </p:cNvPr>
+          <p:cNvSpPr>
+            <a:spLocks noGrp="1"/>
+          </p:cNvSpPr>
+          <p:nvPr>
+            <p:ph type="title"/>
           </p:nvPr>
         </p:nvSpPr>
         <p:spPr/>
@@ -34708,7 +36245,7 @@
           <a:p>
             <a:r>
               <a:rPr lang="en-SG" dirty="0"/>
-              <a:t>KUBERNATES</a:t>
+              <a:t>Diagram</a:t>
             </a:r>
           </a:p>
         </p:txBody>
@@ -34718,7 +36255,7 @@
           <p:cNvPr id="3" name="Footer Placeholder 2">
             <a:extLst>
               <a:ext uri="{FF2B5EF4-FFF2-40B4-BE49-F238E27FC236}">
-                <a16:creationId xmlns:a16="http://schemas.microsoft.com/office/drawing/2014/main" id="{D2F62700-C8BC-371F-E4A0-146018195E63}"/>
+                <a16:creationId xmlns:a16="http://schemas.microsoft.com/office/drawing/2014/main" id="{7EACCE7B-2684-148E-BB6E-33DA03210D84}"/>
               </a:ext>
             </a:extLst>
           </p:cNvPr>
@@ -34744,10 +36281,10 @@
       </p:sp>
       <p:sp>
         <p:nvSpPr>
-          <p:cNvPr id="4" name="Date Placeholder 3">
-            <a:extLst>
-              <a:ext uri="{FF2B5EF4-FFF2-40B4-BE49-F238E27FC236}">
-                <a16:creationId xmlns:a16="http://schemas.microsoft.com/office/drawing/2014/main" id="{97386FD1-37AC-99FB-025F-EC72261EF737}"/>
+          <p:cNvPr id="5" name="Date Placeholder 4">
+            <a:extLst>
+              <a:ext uri="{FF2B5EF4-FFF2-40B4-BE49-F238E27FC236}">
+                <a16:creationId xmlns:a16="http://schemas.microsoft.com/office/drawing/2014/main" id="{EDD1A501-7E82-3D8C-AB0A-B3B0E72B9A3C}"/>
               </a:ext>
             </a:extLst>
           </p:cNvPr>
@@ -34763,9 +36300,9 @@
           <a:bodyPr/>
           <a:lstStyle/>
           <a:p>
-            <a:fld id="{010D0AB2-23BC-3043-AC30-5928E542C0CE}" type="datetime1">
+            <a:fld id="{927C0DEB-4AE1-EA4D-826D-E3C22802B942}" type="datetime1">
               <a:rPr lang="en-US" smtClean="0"/>
-              <a:t>7/16/2026</a:t>
+              <a:t>7/19/2026</a:t>
             </a:fld>
             <a:endParaRPr lang="en-US" dirty="0"/>
           </a:p>
@@ -34773,10 +36310,10 @@
       </p:sp>
       <p:sp>
         <p:nvSpPr>
-          <p:cNvPr id="5" name="Slide Number Placeholder 4">
-            <a:extLst>
-              <a:ext uri="{FF2B5EF4-FFF2-40B4-BE49-F238E27FC236}">
-                <a16:creationId xmlns:a16="http://schemas.microsoft.com/office/drawing/2014/main" id="{D08F73AA-8FFF-4571-C0CF-0F21F722B187}"/>
+          <p:cNvPr id="6" name="Slide Number Placeholder 5">
+            <a:extLst>
+              <a:ext uri="{FF2B5EF4-FFF2-40B4-BE49-F238E27FC236}">
+                <a16:creationId xmlns:a16="http://schemas.microsoft.com/office/drawing/2014/main" id="{6CFB3B95-33D1-EDB4-AD85-91D9821199BB}"/>
               </a:ext>
             </a:extLst>
           </p:cNvPr>
@@ -34801,10 +36338,844 @@
           </a:p>
         </p:txBody>
       </p:sp>
+      <p:sp>
+        <p:nvSpPr>
+          <p:cNvPr id="7" name="Rectangle 6">
+            <a:extLst>
+              <a:ext uri="{FF2B5EF4-FFF2-40B4-BE49-F238E27FC236}">
+                <a16:creationId xmlns:a16="http://schemas.microsoft.com/office/drawing/2014/main" id="{C49624F9-6982-B0C4-38E1-4DF939FAC8AC}"/>
+              </a:ext>
+            </a:extLst>
+          </p:cNvPr>
+          <p:cNvSpPr/>
+          <p:nvPr/>
+        </p:nvSpPr>
+        <p:spPr>
+          <a:xfrm>
+            <a:off x="1066800" y="1736785"/>
+            <a:ext cx="2007080" cy="971910"/>
+          </a:xfrm>
+          <a:prstGeom prst="rect">
+            <a:avLst/>
+          </a:prstGeom>
+        </p:spPr>
+        <p:style>
+          <a:lnRef idx="2">
+            <a:schemeClr val="accent2">
+              <a:shade val="15000"/>
+            </a:schemeClr>
+          </a:lnRef>
+          <a:fillRef idx="1">
+            <a:schemeClr val="accent2"/>
+          </a:fillRef>
+          <a:effectRef idx="0">
+            <a:schemeClr val="accent2"/>
+          </a:effectRef>
+          <a:fontRef idx="minor">
+            <a:schemeClr val="lt1"/>
+          </a:fontRef>
+        </p:style>
+        <p:txBody>
+          <a:bodyPr rtlCol="0" anchor="ctr"/>
+          <a:lstStyle/>
+          <a:p>
+            <a:pPr algn="ctr"/>
+            <a:r>
+              <a:rPr lang="en-SG" b="1" dirty="0"/>
+              <a:t>FRONTEND DASHBOARD</a:t>
+            </a:r>
+          </a:p>
+        </p:txBody>
+      </p:sp>
+      <p:sp>
+        <p:nvSpPr>
+          <p:cNvPr id="9" name="Rectangle 8">
+            <a:extLst>
+              <a:ext uri="{FF2B5EF4-FFF2-40B4-BE49-F238E27FC236}">
+                <a16:creationId xmlns:a16="http://schemas.microsoft.com/office/drawing/2014/main" id="{CFC3B6A0-E473-03E1-ECE2-795F3E7548F0}"/>
+              </a:ext>
+            </a:extLst>
+          </p:cNvPr>
+          <p:cNvSpPr/>
+          <p:nvPr/>
+        </p:nvSpPr>
+        <p:spPr>
+          <a:xfrm>
+            <a:off x="4317452" y="1736785"/>
+            <a:ext cx="2007080" cy="971910"/>
+          </a:xfrm>
+          <a:prstGeom prst="rect">
+            <a:avLst/>
+          </a:prstGeom>
+        </p:spPr>
+        <p:style>
+          <a:lnRef idx="2">
+            <a:schemeClr val="accent2">
+              <a:shade val="15000"/>
+            </a:schemeClr>
+          </a:lnRef>
+          <a:fillRef idx="1">
+            <a:schemeClr val="accent2"/>
+          </a:fillRef>
+          <a:effectRef idx="0">
+            <a:schemeClr val="accent2"/>
+          </a:effectRef>
+          <a:fontRef idx="minor">
+            <a:schemeClr val="lt1"/>
+          </a:fontRef>
+        </p:style>
+        <p:txBody>
+          <a:bodyPr rtlCol="0" anchor="ctr"/>
+          <a:lstStyle/>
+          <a:p>
+            <a:pPr algn="ctr"/>
+            <a:r>
+              <a:rPr lang="en-SG" b="1" dirty="0"/>
+              <a:t>REST API REQUEST</a:t>
+            </a:r>
+          </a:p>
+        </p:txBody>
+      </p:sp>
+      <p:sp>
+        <p:nvSpPr>
+          <p:cNvPr id="11" name="Rectangle 10">
+            <a:extLst>
+              <a:ext uri="{FF2B5EF4-FFF2-40B4-BE49-F238E27FC236}">
+                <a16:creationId xmlns:a16="http://schemas.microsoft.com/office/drawing/2014/main" id="{B9E4D4B0-BE1C-030E-B0D2-192719231248}"/>
+              </a:ext>
+            </a:extLst>
+          </p:cNvPr>
+          <p:cNvSpPr/>
+          <p:nvPr/>
+        </p:nvSpPr>
+        <p:spPr>
+          <a:xfrm>
+            <a:off x="7529089" y="1736785"/>
+            <a:ext cx="2007080" cy="971910"/>
+          </a:xfrm>
+          <a:prstGeom prst="rect">
+            <a:avLst/>
+          </a:prstGeom>
+        </p:spPr>
+        <p:style>
+          <a:lnRef idx="2">
+            <a:schemeClr val="accent2">
+              <a:shade val="15000"/>
+            </a:schemeClr>
+          </a:lnRef>
+          <a:fillRef idx="1">
+            <a:schemeClr val="accent2"/>
+          </a:fillRef>
+          <a:effectRef idx="0">
+            <a:schemeClr val="accent2"/>
+          </a:effectRef>
+          <a:fontRef idx="minor">
+            <a:schemeClr val="lt1"/>
+          </a:fontRef>
+        </p:style>
+        <p:txBody>
+          <a:bodyPr rtlCol="0" anchor="ctr"/>
+          <a:lstStyle/>
+          <a:p>
+            <a:pPr algn="ctr"/>
+            <a:r>
+              <a:rPr lang="en-SG" b="1" dirty="0"/>
+              <a:t>BACKEND API </a:t>
+            </a:r>
+          </a:p>
+        </p:txBody>
+      </p:sp>
+      <p:sp>
+        <p:nvSpPr>
+          <p:cNvPr id="13" name="Rectangle 12">
+            <a:extLst>
+              <a:ext uri="{FF2B5EF4-FFF2-40B4-BE49-F238E27FC236}">
+                <a16:creationId xmlns:a16="http://schemas.microsoft.com/office/drawing/2014/main" id="{D44F0444-B1A7-0403-96E1-13A8F5C1EC4D}"/>
+              </a:ext>
+            </a:extLst>
+          </p:cNvPr>
+          <p:cNvSpPr/>
+          <p:nvPr/>
+        </p:nvSpPr>
+        <p:spPr>
+          <a:xfrm>
+            <a:off x="7529089" y="3274249"/>
+            <a:ext cx="2007080" cy="971910"/>
+          </a:xfrm>
+          <a:prstGeom prst="rect">
+            <a:avLst/>
+          </a:prstGeom>
+        </p:spPr>
+        <p:style>
+          <a:lnRef idx="2">
+            <a:schemeClr val="accent2">
+              <a:shade val="15000"/>
+            </a:schemeClr>
+          </a:lnRef>
+          <a:fillRef idx="1">
+            <a:schemeClr val="accent2"/>
+          </a:fillRef>
+          <a:effectRef idx="0">
+            <a:schemeClr val="accent2"/>
+          </a:effectRef>
+          <a:fontRef idx="minor">
+            <a:schemeClr val="lt1"/>
+          </a:fontRef>
+        </p:style>
+        <p:txBody>
+          <a:bodyPr rtlCol="0" anchor="ctr"/>
+          <a:lstStyle/>
+          <a:p>
+            <a:pPr algn="ctr"/>
+            <a:r>
+              <a:rPr lang="en-SG" b="1" dirty="0"/>
+              <a:t>DATABASE</a:t>
+            </a:r>
+          </a:p>
+        </p:txBody>
+      </p:sp>
+      <p:sp>
+        <p:nvSpPr>
+          <p:cNvPr id="15" name="Rectangle 14">
+            <a:extLst>
+              <a:ext uri="{FF2B5EF4-FFF2-40B4-BE49-F238E27FC236}">
+                <a16:creationId xmlns:a16="http://schemas.microsoft.com/office/drawing/2014/main" id="{57DE8DC9-11C5-303A-41EB-9DF7D09F57AB}"/>
+              </a:ext>
+            </a:extLst>
+          </p:cNvPr>
+          <p:cNvSpPr/>
+          <p:nvPr/>
+        </p:nvSpPr>
+        <p:spPr>
+          <a:xfrm>
+            <a:off x="4329033" y="3274249"/>
+            <a:ext cx="2007080" cy="971910"/>
+          </a:xfrm>
+          <a:prstGeom prst="rect">
+            <a:avLst/>
+          </a:prstGeom>
+        </p:spPr>
+        <p:style>
+          <a:lnRef idx="2">
+            <a:schemeClr val="accent2">
+              <a:shade val="15000"/>
+            </a:schemeClr>
+          </a:lnRef>
+          <a:fillRef idx="1">
+            <a:schemeClr val="accent2"/>
+          </a:fillRef>
+          <a:effectRef idx="0">
+            <a:schemeClr val="accent2"/>
+          </a:effectRef>
+          <a:fontRef idx="minor">
+            <a:schemeClr val="lt1"/>
+          </a:fontRef>
+        </p:style>
+        <p:txBody>
+          <a:bodyPr rtlCol="0" anchor="ctr"/>
+          <a:lstStyle/>
+          <a:p>
+            <a:pPr algn="ctr"/>
+            <a:r>
+              <a:rPr lang="en-SG" b="1" dirty="0"/>
+              <a:t>MACHINE LEARNING</a:t>
+            </a:r>
+          </a:p>
+        </p:txBody>
+      </p:sp>
+      <p:sp>
+        <p:nvSpPr>
+          <p:cNvPr id="17" name="Rectangle 16">
+            <a:extLst>
+              <a:ext uri="{FF2B5EF4-FFF2-40B4-BE49-F238E27FC236}">
+                <a16:creationId xmlns:a16="http://schemas.microsoft.com/office/drawing/2014/main" id="{37083AA4-F232-F3BF-862F-4B730881E4AD}"/>
+              </a:ext>
+            </a:extLst>
+          </p:cNvPr>
+          <p:cNvSpPr/>
+          <p:nvPr/>
+        </p:nvSpPr>
+        <p:spPr>
+          <a:xfrm>
+            <a:off x="1043638" y="3274249"/>
+            <a:ext cx="2007080" cy="971910"/>
+          </a:xfrm>
+          <a:prstGeom prst="rect">
+            <a:avLst/>
+          </a:prstGeom>
+        </p:spPr>
+        <p:style>
+          <a:lnRef idx="2">
+            <a:schemeClr val="accent2">
+              <a:shade val="15000"/>
+            </a:schemeClr>
+          </a:lnRef>
+          <a:fillRef idx="1">
+            <a:schemeClr val="accent2"/>
+          </a:fillRef>
+          <a:effectRef idx="0">
+            <a:schemeClr val="accent2"/>
+          </a:effectRef>
+          <a:fontRef idx="minor">
+            <a:schemeClr val="lt1"/>
+          </a:fontRef>
+        </p:style>
+        <p:txBody>
+          <a:bodyPr rtlCol="0" anchor="ctr"/>
+          <a:lstStyle/>
+          <a:p>
+            <a:pPr algn="ctr"/>
+            <a:r>
+              <a:rPr lang="en-SG" b="1" dirty="0"/>
+              <a:t>DATABASE</a:t>
+            </a:r>
+          </a:p>
+        </p:txBody>
+      </p:sp>
+      <p:sp>
+        <p:nvSpPr>
+          <p:cNvPr id="19" name="Rectangle 18">
+            <a:extLst>
+              <a:ext uri="{FF2B5EF4-FFF2-40B4-BE49-F238E27FC236}">
+                <a16:creationId xmlns:a16="http://schemas.microsoft.com/office/drawing/2014/main" id="{82CCFD25-8EE3-FEE1-4035-D3DE5F08BEBB}"/>
+              </a:ext>
+            </a:extLst>
+          </p:cNvPr>
+          <p:cNvSpPr/>
+          <p:nvPr/>
+        </p:nvSpPr>
+        <p:spPr>
+          <a:xfrm>
+            <a:off x="1043638" y="5029116"/>
+            <a:ext cx="2007080" cy="971910"/>
+          </a:xfrm>
+          <a:prstGeom prst="rect">
+            <a:avLst/>
+          </a:prstGeom>
+        </p:spPr>
+        <p:style>
+          <a:lnRef idx="2">
+            <a:schemeClr val="accent2">
+              <a:shade val="15000"/>
+            </a:schemeClr>
+          </a:lnRef>
+          <a:fillRef idx="1">
+            <a:schemeClr val="accent2"/>
+          </a:fillRef>
+          <a:effectRef idx="0">
+            <a:schemeClr val="accent2"/>
+          </a:effectRef>
+          <a:fontRef idx="minor">
+            <a:schemeClr val="lt1"/>
+          </a:fontRef>
+        </p:style>
+        <p:txBody>
+          <a:bodyPr rtlCol="0" anchor="ctr"/>
+          <a:lstStyle/>
+          <a:p>
+            <a:pPr algn="ctr"/>
+            <a:r>
+              <a:rPr lang="en-SG" b="1" dirty="0"/>
+              <a:t>BACKEND API </a:t>
+            </a:r>
+          </a:p>
+        </p:txBody>
+      </p:sp>
+      <p:sp>
+        <p:nvSpPr>
+          <p:cNvPr id="21" name="Rectangle 20">
+            <a:extLst>
+              <a:ext uri="{FF2B5EF4-FFF2-40B4-BE49-F238E27FC236}">
+                <a16:creationId xmlns:a16="http://schemas.microsoft.com/office/drawing/2014/main" id="{AFC60817-335B-FB4E-DB77-7D0AA77F5DC1}"/>
+              </a:ext>
+            </a:extLst>
+          </p:cNvPr>
+          <p:cNvSpPr/>
+          <p:nvPr/>
+        </p:nvSpPr>
+        <p:spPr>
+          <a:xfrm>
+            <a:off x="4329033" y="5029116"/>
+            <a:ext cx="2007080" cy="971910"/>
+          </a:xfrm>
+          <a:prstGeom prst="rect">
+            <a:avLst/>
+          </a:prstGeom>
+        </p:spPr>
+        <p:style>
+          <a:lnRef idx="2">
+            <a:schemeClr val="accent2">
+              <a:shade val="15000"/>
+            </a:schemeClr>
+          </a:lnRef>
+          <a:fillRef idx="1">
+            <a:schemeClr val="accent2"/>
+          </a:fillRef>
+          <a:effectRef idx="0">
+            <a:schemeClr val="accent2"/>
+          </a:effectRef>
+          <a:fontRef idx="minor">
+            <a:schemeClr val="lt1"/>
+          </a:fontRef>
+        </p:style>
+        <p:txBody>
+          <a:bodyPr rtlCol="0" anchor="ctr"/>
+          <a:lstStyle/>
+          <a:p>
+            <a:pPr algn="ctr"/>
+            <a:r>
+              <a:rPr lang="en-SG" b="1" dirty="0"/>
+              <a:t>FRONTEND DASHBOARD</a:t>
+            </a:r>
+          </a:p>
+        </p:txBody>
+      </p:sp>
+      <p:cxnSp>
+        <p:nvCxnSpPr>
+          <p:cNvPr id="23" name="Straight Arrow Connector 22">
+            <a:extLst>
+              <a:ext uri="{FF2B5EF4-FFF2-40B4-BE49-F238E27FC236}">
+                <a16:creationId xmlns:a16="http://schemas.microsoft.com/office/drawing/2014/main" id="{1E18CB8C-27B7-999F-0D60-9C0CB9D43C61}"/>
+              </a:ext>
+            </a:extLst>
+          </p:cNvPr>
+          <p:cNvCxnSpPr>
+            <a:stCxn id="7" idx="3"/>
+            <a:endCxn id="9" idx="1"/>
+          </p:cNvCxnSpPr>
+          <p:nvPr/>
+        </p:nvCxnSpPr>
+        <p:spPr>
+          <a:xfrm>
+            <a:off x="3073880" y="2222740"/>
+            <a:ext cx="1243572" cy="0"/>
+          </a:xfrm>
+          <a:prstGeom prst="straightConnector1">
+            <a:avLst/>
+          </a:prstGeom>
+          <a:ln w="19050" cap="flat" cmpd="sng" algn="ctr">
+            <a:solidFill>
+              <a:schemeClr val="accent2"/>
+            </a:solidFill>
+            <a:prstDash val="solid"/>
+            <a:round/>
+            <a:headEnd type="none" w="med" len="med"/>
+            <a:tailEnd type="arrow" w="med" len="med"/>
+          </a:ln>
+        </p:spPr>
+        <p:style>
+          <a:lnRef idx="0">
+            <a:scrgbClr r="0" g="0" b="0"/>
+          </a:lnRef>
+          <a:fillRef idx="0">
+            <a:scrgbClr r="0" g="0" b="0"/>
+          </a:fillRef>
+          <a:effectRef idx="0">
+            <a:scrgbClr r="0" g="0" b="0"/>
+          </a:effectRef>
+          <a:fontRef idx="minor">
+            <a:schemeClr val="tx1"/>
+          </a:fontRef>
+        </p:style>
+      </p:cxnSp>
+      <p:cxnSp>
+        <p:nvCxnSpPr>
+          <p:cNvPr id="25" name="Straight Arrow Connector 24">
+            <a:extLst>
+              <a:ext uri="{FF2B5EF4-FFF2-40B4-BE49-F238E27FC236}">
+                <a16:creationId xmlns:a16="http://schemas.microsoft.com/office/drawing/2014/main" id="{C8605026-19AE-2552-B82E-278DBC7642BB}"/>
+              </a:ext>
+            </a:extLst>
+          </p:cNvPr>
+          <p:cNvCxnSpPr>
+            <a:cxnSpLocks/>
+            <a:stCxn id="9" idx="3"/>
+            <a:endCxn id="11" idx="1"/>
+          </p:cNvCxnSpPr>
+          <p:nvPr/>
+        </p:nvCxnSpPr>
+        <p:spPr>
+          <a:xfrm>
+            <a:off x="6324532" y="2222740"/>
+            <a:ext cx="1204557" cy="0"/>
+          </a:xfrm>
+          <a:prstGeom prst="straightConnector1">
+            <a:avLst/>
+          </a:prstGeom>
+          <a:ln w="19050" cap="flat" cmpd="sng" algn="ctr">
+            <a:solidFill>
+              <a:schemeClr val="accent2"/>
+            </a:solidFill>
+            <a:prstDash val="solid"/>
+            <a:round/>
+            <a:headEnd type="none" w="med" len="med"/>
+            <a:tailEnd type="arrow" w="med" len="med"/>
+          </a:ln>
+        </p:spPr>
+        <p:style>
+          <a:lnRef idx="0">
+            <a:scrgbClr r="0" g="0" b="0"/>
+          </a:lnRef>
+          <a:fillRef idx="0">
+            <a:scrgbClr r="0" g="0" b="0"/>
+          </a:fillRef>
+          <a:effectRef idx="0">
+            <a:scrgbClr r="0" g="0" b="0"/>
+          </a:effectRef>
+          <a:fontRef idx="minor">
+            <a:schemeClr val="tx1"/>
+          </a:fontRef>
+        </p:style>
+      </p:cxnSp>
+      <p:cxnSp>
+        <p:nvCxnSpPr>
+          <p:cNvPr id="29" name="Straight Arrow Connector 28">
+            <a:extLst>
+              <a:ext uri="{FF2B5EF4-FFF2-40B4-BE49-F238E27FC236}">
+                <a16:creationId xmlns:a16="http://schemas.microsoft.com/office/drawing/2014/main" id="{9FB595AA-95C4-8DD5-6CAB-64CC4EF25F7E}"/>
+              </a:ext>
+            </a:extLst>
+          </p:cNvPr>
+          <p:cNvCxnSpPr>
+            <a:stCxn id="11" idx="2"/>
+            <a:endCxn id="13" idx="0"/>
+          </p:cNvCxnSpPr>
+          <p:nvPr/>
+        </p:nvCxnSpPr>
+        <p:spPr>
+          <a:xfrm>
+            <a:off x="8532629" y="2708695"/>
+            <a:ext cx="0" cy="565554"/>
+          </a:xfrm>
+          <a:prstGeom prst="straightConnector1">
+            <a:avLst/>
+          </a:prstGeom>
+          <a:ln w="19050" cap="flat" cmpd="sng" algn="ctr">
+            <a:solidFill>
+              <a:schemeClr val="accent2"/>
+            </a:solidFill>
+            <a:prstDash val="solid"/>
+            <a:round/>
+            <a:headEnd type="none" w="med" len="med"/>
+            <a:tailEnd type="arrow" w="med" len="med"/>
+          </a:ln>
+        </p:spPr>
+        <p:style>
+          <a:lnRef idx="0">
+            <a:scrgbClr r="0" g="0" b="0"/>
+          </a:lnRef>
+          <a:fillRef idx="0">
+            <a:scrgbClr r="0" g="0" b="0"/>
+          </a:fillRef>
+          <a:effectRef idx="0">
+            <a:scrgbClr r="0" g="0" b="0"/>
+          </a:effectRef>
+          <a:fontRef idx="minor">
+            <a:schemeClr val="tx1"/>
+          </a:fontRef>
+        </p:style>
+      </p:cxnSp>
+      <p:cxnSp>
+        <p:nvCxnSpPr>
+          <p:cNvPr id="32" name="Straight Arrow Connector 31">
+            <a:extLst>
+              <a:ext uri="{FF2B5EF4-FFF2-40B4-BE49-F238E27FC236}">
+                <a16:creationId xmlns:a16="http://schemas.microsoft.com/office/drawing/2014/main" id="{A769D896-C4CE-B2AF-5303-59C4706AAF52}"/>
+              </a:ext>
+            </a:extLst>
+          </p:cNvPr>
+          <p:cNvCxnSpPr>
+            <a:stCxn id="13" idx="1"/>
+            <a:endCxn id="15" idx="3"/>
+          </p:cNvCxnSpPr>
+          <p:nvPr/>
+        </p:nvCxnSpPr>
+        <p:spPr>
+          <a:xfrm flipH="1">
+            <a:off x="6336113" y="3760204"/>
+            <a:ext cx="1192976" cy="0"/>
+          </a:xfrm>
+          <a:prstGeom prst="straightConnector1">
+            <a:avLst/>
+          </a:prstGeom>
+          <a:ln w="19050" cap="flat" cmpd="sng" algn="ctr">
+            <a:solidFill>
+              <a:schemeClr val="accent2"/>
+            </a:solidFill>
+            <a:prstDash val="solid"/>
+            <a:round/>
+            <a:headEnd type="none" w="med" len="med"/>
+            <a:tailEnd type="arrow" w="med" len="med"/>
+          </a:ln>
+        </p:spPr>
+        <p:style>
+          <a:lnRef idx="0">
+            <a:scrgbClr r="0" g="0" b="0"/>
+          </a:lnRef>
+          <a:fillRef idx="0">
+            <a:scrgbClr r="0" g="0" b="0"/>
+          </a:fillRef>
+          <a:effectRef idx="0">
+            <a:scrgbClr r="0" g="0" b="0"/>
+          </a:effectRef>
+          <a:fontRef idx="minor">
+            <a:schemeClr val="tx1"/>
+          </a:fontRef>
+        </p:style>
+      </p:cxnSp>
+      <p:cxnSp>
+        <p:nvCxnSpPr>
+          <p:cNvPr id="34" name="Straight Arrow Connector 33">
+            <a:extLst>
+              <a:ext uri="{FF2B5EF4-FFF2-40B4-BE49-F238E27FC236}">
+                <a16:creationId xmlns:a16="http://schemas.microsoft.com/office/drawing/2014/main" id="{82CCA0C9-4E67-06C8-5F06-97A1EBA73AF7}"/>
+              </a:ext>
+            </a:extLst>
+          </p:cNvPr>
+          <p:cNvCxnSpPr>
+            <a:stCxn id="15" idx="1"/>
+            <a:endCxn id="17" idx="3"/>
+          </p:cNvCxnSpPr>
+          <p:nvPr/>
+        </p:nvCxnSpPr>
+        <p:spPr>
+          <a:xfrm flipH="1">
+            <a:off x="3050718" y="3760204"/>
+            <a:ext cx="1278315" cy="0"/>
+          </a:xfrm>
+          <a:prstGeom prst="straightConnector1">
+            <a:avLst/>
+          </a:prstGeom>
+          <a:ln w="19050" cap="flat" cmpd="sng" algn="ctr">
+            <a:solidFill>
+              <a:schemeClr val="accent2"/>
+            </a:solidFill>
+            <a:prstDash val="solid"/>
+            <a:round/>
+            <a:headEnd type="none" w="med" len="med"/>
+            <a:tailEnd type="arrow" w="med" len="med"/>
+          </a:ln>
+        </p:spPr>
+        <p:style>
+          <a:lnRef idx="0">
+            <a:scrgbClr r="0" g="0" b="0"/>
+          </a:lnRef>
+          <a:fillRef idx="0">
+            <a:scrgbClr r="0" g="0" b="0"/>
+          </a:fillRef>
+          <a:effectRef idx="0">
+            <a:scrgbClr r="0" g="0" b="0"/>
+          </a:effectRef>
+          <a:fontRef idx="minor">
+            <a:schemeClr val="tx1"/>
+          </a:fontRef>
+        </p:style>
+      </p:cxnSp>
+      <p:cxnSp>
+        <p:nvCxnSpPr>
+          <p:cNvPr id="36" name="Straight Arrow Connector 35">
+            <a:extLst>
+              <a:ext uri="{FF2B5EF4-FFF2-40B4-BE49-F238E27FC236}">
+                <a16:creationId xmlns:a16="http://schemas.microsoft.com/office/drawing/2014/main" id="{B7C09E6D-8179-6929-B8C7-3B8DF8919F1F}"/>
+              </a:ext>
+            </a:extLst>
+          </p:cNvPr>
+          <p:cNvCxnSpPr>
+            <a:stCxn id="17" idx="2"/>
+            <a:endCxn id="19" idx="0"/>
+          </p:cNvCxnSpPr>
+          <p:nvPr/>
+        </p:nvCxnSpPr>
+        <p:spPr>
+          <a:xfrm>
+            <a:off x="2047178" y="4246159"/>
+            <a:ext cx="0" cy="782957"/>
+          </a:xfrm>
+          <a:prstGeom prst="straightConnector1">
+            <a:avLst/>
+          </a:prstGeom>
+          <a:ln w="19050" cap="flat" cmpd="sng" algn="ctr">
+            <a:solidFill>
+              <a:schemeClr val="accent2"/>
+            </a:solidFill>
+            <a:prstDash val="solid"/>
+            <a:round/>
+            <a:headEnd type="none" w="med" len="med"/>
+            <a:tailEnd type="arrow" w="med" len="med"/>
+          </a:ln>
+        </p:spPr>
+        <p:style>
+          <a:lnRef idx="0">
+            <a:scrgbClr r="0" g="0" b="0"/>
+          </a:lnRef>
+          <a:fillRef idx="0">
+            <a:scrgbClr r="0" g="0" b="0"/>
+          </a:fillRef>
+          <a:effectRef idx="0">
+            <a:scrgbClr r="0" g="0" b="0"/>
+          </a:effectRef>
+          <a:fontRef idx="minor">
+            <a:schemeClr val="tx1"/>
+          </a:fontRef>
+        </p:style>
+      </p:cxnSp>
+      <p:cxnSp>
+        <p:nvCxnSpPr>
+          <p:cNvPr id="41" name="Straight Arrow Connector 40">
+            <a:extLst>
+              <a:ext uri="{FF2B5EF4-FFF2-40B4-BE49-F238E27FC236}">
+                <a16:creationId xmlns:a16="http://schemas.microsoft.com/office/drawing/2014/main" id="{C860D47B-8950-6405-088D-8C47A9B4BA89}"/>
+              </a:ext>
+            </a:extLst>
+          </p:cNvPr>
+          <p:cNvCxnSpPr>
+            <a:stCxn id="19" idx="3"/>
+            <a:endCxn id="21" idx="1"/>
+          </p:cNvCxnSpPr>
+          <p:nvPr/>
+        </p:nvCxnSpPr>
+        <p:spPr>
+          <a:xfrm>
+            <a:off x="3050718" y="5515071"/>
+            <a:ext cx="1278315" cy="0"/>
+          </a:xfrm>
+          <a:prstGeom prst="straightConnector1">
+            <a:avLst/>
+          </a:prstGeom>
+          <a:ln w="19050" cap="flat" cmpd="sng" algn="ctr">
+            <a:solidFill>
+              <a:schemeClr val="accent2"/>
+            </a:solidFill>
+            <a:prstDash val="solid"/>
+            <a:round/>
+            <a:headEnd type="none" w="med" len="med"/>
+            <a:tailEnd type="arrow" w="med" len="med"/>
+          </a:ln>
+        </p:spPr>
+        <p:style>
+          <a:lnRef idx="0">
+            <a:scrgbClr r="0" g="0" b="0"/>
+          </a:lnRef>
+          <a:fillRef idx="0">
+            <a:scrgbClr r="0" g="0" b="0"/>
+          </a:fillRef>
+          <a:effectRef idx="0">
+            <a:scrgbClr r="0" g="0" b="0"/>
+          </a:effectRef>
+          <a:fontRef idx="minor">
+            <a:schemeClr val="tx1"/>
+          </a:fontRef>
+        </p:style>
+      </p:cxnSp>
+      <p:sp>
+        <p:nvSpPr>
+          <p:cNvPr id="42" name="TextBox 41">
+            <a:extLst>
+              <a:ext uri="{FF2B5EF4-FFF2-40B4-BE49-F238E27FC236}">
+                <a16:creationId xmlns:a16="http://schemas.microsoft.com/office/drawing/2014/main" id="{B0DB540F-21B3-F355-93D9-C446F53FE396}"/>
+              </a:ext>
+            </a:extLst>
+          </p:cNvPr>
+          <p:cNvSpPr txBox="1"/>
+          <p:nvPr/>
+        </p:nvSpPr>
+        <p:spPr>
+          <a:xfrm>
+            <a:off x="3220836" y="5087428"/>
+            <a:ext cx="938077" cy="369332"/>
+          </a:xfrm>
+          <a:prstGeom prst="rect">
+            <a:avLst/>
+          </a:prstGeom>
+          <a:noFill/>
+        </p:spPr>
+        <p:txBody>
+          <a:bodyPr wrap="none" rtlCol="0">
+            <a:spAutoFit/>
+          </a:bodyPr>
+          <a:lstStyle/>
+          <a:p>
+            <a:r>
+              <a:rPr lang="en-SG" dirty="0"/>
+              <a:t>Display</a:t>
+            </a:r>
+          </a:p>
+        </p:txBody>
+      </p:sp>
+      <p:sp>
+        <p:nvSpPr>
+          <p:cNvPr id="44" name="TextBox 43">
+            <a:extLst>
+              <a:ext uri="{FF2B5EF4-FFF2-40B4-BE49-F238E27FC236}">
+                <a16:creationId xmlns:a16="http://schemas.microsoft.com/office/drawing/2014/main" id="{DB9A1047-40CE-AE69-17DB-F70C5AAECBF9}"/>
+              </a:ext>
+            </a:extLst>
+          </p:cNvPr>
+          <p:cNvSpPr txBox="1"/>
+          <p:nvPr/>
+        </p:nvSpPr>
+        <p:spPr>
+          <a:xfrm>
+            <a:off x="6324532" y="3060949"/>
+            <a:ext cx="1685026" cy="615553"/>
+          </a:xfrm>
+          <a:prstGeom prst="rect">
+            <a:avLst/>
+          </a:prstGeom>
+          <a:noFill/>
+        </p:spPr>
+        <p:txBody>
+          <a:bodyPr wrap="square" rtlCol="0">
+            <a:spAutoFit/>
+          </a:bodyPr>
+          <a:lstStyle/>
+          <a:p>
+            <a:r>
+              <a:rPr lang="en-SG" sz="1700" dirty="0"/>
+              <a:t>Pre-processing</a:t>
+            </a:r>
+          </a:p>
+        </p:txBody>
+      </p:sp>
+      <p:sp>
+        <p:nvSpPr>
+          <p:cNvPr id="50" name="TextBox 49">
+            <a:extLst>
+              <a:ext uri="{FF2B5EF4-FFF2-40B4-BE49-F238E27FC236}">
+                <a16:creationId xmlns:a16="http://schemas.microsoft.com/office/drawing/2014/main" id="{EEFCA747-8D72-04FC-A8D8-1B699871D0F4}"/>
+              </a:ext>
+            </a:extLst>
+          </p:cNvPr>
+          <p:cNvSpPr txBox="1"/>
+          <p:nvPr/>
+        </p:nvSpPr>
+        <p:spPr>
+          <a:xfrm>
+            <a:off x="3220835" y="3274249"/>
+            <a:ext cx="845103" cy="369332"/>
+          </a:xfrm>
+          <a:prstGeom prst="rect">
+            <a:avLst/>
+          </a:prstGeom>
+          <a:noFill/>
+        </p:spPr>
+        <p:txBody>
+          <a:bodyPr wrap="none" rtlCol="0">
+            <a:spAutoFit/>
+          </a:bodyPr>
+          <a:lstStyle/>
+          <a:p>
+            <a:r>
+              <a:rPr lang="en-SG" dirty="0"/>
+              <a:t>Result</a:t>
+            </a:r>
+          </a:p>
+        </p:txBody>
+      </p:sp>
     </p:spTree>
     <p:extLst>
       <p:ext uri="{BB962C8B-B14F-4D97-AF65-F5344CB8AC3E}">
-        <p14:creationId xmlns:p14="http://schemas.microsoft.com/office/powerpoint/2010/main" val="2037361668"/>
+        <p14:creationId xmlns:p14="http://schemas.microsoft.com/office/powerpoint/2010/main" val="2648405994"/>
       </p:ext>
     </p:extLst>
   </p:cSld>
@@ -34836,30 +37207,25 @@
           <p:cNvPr id="2" name="Title 1">
             <a:extLst>
               <a:ext uri="{FF2B5EF4-FFF2-40B4-BE49-F238E27FC236}">
-                <a16:creationId xmlns:a16="http://schemas.microsoft.com/office/drawing/2014/main" id="{5399766A-8D26-6DCE-60BF-703811C9A8AF}"/>
-              </a:ext>
-            </a:extLst>
-          </p:cNvPr>
-          <p:cNvSpPr>
-            <a:spLocks noGrp="1"/>
-          </p:cNvSpPr>
-          <p:nvPr>
-            <p:ph type="ctrTitle"/>
-          </p:nvPr>
-        </p:nvSpPr>
-        <p:spPr>
-          <a:xfrm>
-            <a:off x="3536831" y="1463040"/>
-            <a:ext cx="5210354" cy="3931920"/>
-          </a:xfrm>
-        </p:spPr>
+                <a16:creationId xmlns:a16="http://schemas.microsoft.com/office/drawing/2014/main" id="{5C971468-309A-F249-8785-022D994B40F8}"/>
+              </a:ext>
+            </a:extLst>
+          </p:cNvPr>
+          <p:cNvSpPr>
+            <a:spLocks noGrp="1"/>
+          </p:cNvSpPr>
+          <p:nvPr>
+            <p:ph type="title"/>
+          </p:nvPr>
+        </p:nvSpPr>
+        <p:spPr/>
         <p:txBody>
           <a:bodyPr/>
           <a:lstStyle/>
           <a:p>
             <a:r>
               <a:rPr lang="en-SG" dirty="0"/>
-              <a:t>MICROSERVICES</a:t>
+              <a:t>FRONTEND DASHBOARD</a:t>
             </a:r>
           </a:p>
         </p:txBody>
@@ -34869,7 +37235,7 @@
           <p:cNvPr id="3" name="Footer Placeholder 2">
             <a:extLst>
               <a:ext uri="{FF2B5EF4-FFF2-40B4-BE49-F238E27FC236}">
-                <a16:creationId xmlns:a16="http://schemas.microsoft.com/office/drawing/2014/main" id="{02CD1AC0-9939-D7DA-C1B5-89896E5490E1}"/>
+                <a16:creationId xmlns:a16="http://schemas.microsoft.com/office/drawing/2014/main" id="{67AF8A32-848F-6580-5D1D-863E7ACC1449}"/>
               </a:ext>
             </a:extLst>
           </p:cNvPr>
@@ -34895,18 +37261,18 @@
       </p:sp>
       <p:sp>
         <p:nvSpPr>
-          <p:cNvPr id="4" name="Date Placeholder 3">
-            <a:extLst>
-              <a:ext uri="{FF2B5EF4-FFF2-40B4-BE49-F238E27FC236}">
-                <a16:creationId xmlns:a16="http://schemas.microsoft.com/office/drawing/2014/main" id="{19E5B9C4-A021-AD37-4063-4CD82AEA3362}"/>
-              </a:ext>
-            </a:extLst>
-          </p:cNvPr>
-          <p:cNvSpPr>
-            <a:spLocks noGrp="1"/>
-          </p:cNvSpPr>
-          <p:nvPr>
-            <p:ph type="dt" sz="half" idx="10"/>
+          <p:cNvPr id="4" name="Content Placeholder 3">
+            <a:extLst>
+              <a:ext uri="{FF2B5EF4-FFF2-40B4-BE49-F238E27FC236}">
+                <a16:creationId xmlns:a16="http://schemas.microsoft.com/office/drawing/2014/main" id="{48189E54-8A42-FC2B-2617-0003B6CC127C}"/>
+              </a:ext>
+            </a:extLst>
+          </p:cNvPr>
+          <p:cNvSpPr>
+            <a:spLocks noGrp="1"/>
+          </p:cNvSpPr>
+          <p:nvPr>
+            <p:ph sz="quarter" idx="13"/>
           </p:nvPr>
         </p:nvSpPr>
         <p:spPr/>
@@ -34914,9 +37280,34 @@
           <a:bodyPr/>
           <a:lstStyle/>
           <a:p>
-            <a:fld id="{010D0AB2-23BC-3043-AC30-5928E542C0CE}" type="datetime1">
+            <a:endParaRPr lang="en-SG"/>
+          </a:p>
+        </p:txBody>
+      </p:sp>
+      <p:sp>
+        <p:nvSpPr>
+          <p:cNvPr id="5" name="Date Placeholder 4">
+            <a:extLst>
+              <a:ext uri="{FF2B5EF4-FFF2-40B4-BE49-F238E27FC236}">
+                <a16:creationId xmlns:a16="http://schemas.microsoft.com/office/drawing/2014/main" id="{38F89DBF-AAD8-E49E-2244-336A204599CC}"/>
+              </a:ext>
+            </a:extLst>
+          </p:cNvPr>
+          <p:cNvSpPr>
+            <a:spLocks noGrp="1"/>
+          </p:cNvSpPr>
+          <p:nvPr>
+            <p:ph type="dt" sz="half" idx="10"/>
+          </p:nvPr>
+        </p:nvSpPr>
+        <p:spPr/>
+        <p:txBody>
+          <a:bodyPr/>
+          <a:lstStyle/>
+          <a:p>
+            <a:fld id="{927C0DEB-4AE1-EA4D-826D-E3C22802B942}" type="datetime1">
               <a:rPr lang="en-US" smtClean="0"/>
-              <a:t>7/16/2026</a:t>
+              <a:t>7/20/2026</a:t>
             </a:fld>
             <a:endParaRPr lang="en-US" dirty="0"/>
           </a:p>
@@ -34924,10 +37315,10 @@
       </p:sp>
       <p:sp>
         <p:nvSpPr>
-          <p:cNvPr id="5" name="Slide Number Placeholder 4">
-            <a:extLst>
-              <a:ext uri="{FF2B5EF4-FFF2-40B4-BE49-F238E27FC236}">
-                <a16:creationId xmlns:a16="http://schemas.microsoft.com/office/drawing/2014/main" id="{D796FA40-EF4F-7414-795C-90E90F514FCC}"/>
+          <p:cNvPr id="6" name="Slide Number Placeholder 5">
+            <a:extLst>
+              <a:ext uri="{FF2B5EF4-FFF2-40B4-BE49-F238E27FC236}">
+                <a16:creationId xmlns:a16="http://schemas.microsoft.com/office/drawing/2014/main" id="{FFE04B86-3E7C-BF8A-4395-0323C52E4558}"/>
               </a:ext>
             </a:extLst>
           </p:cNvPr>
@@ -34955,7 +37346,7 @@
     </p:spTree>
     <p:extLst>
       <p:ext uri="{BB962C8B-B14F-4D97-AF65-F5344CB8AC3E}">
-        <p14:creationId xmlns:p14="http://schemas.microsoft.com/office/powerpoint/2010/main" val="1787156668"/>
+        <p14:creationId xmlns:p14="http://schemas.microsoft.com/office/powerpoint/2010/main" val="1382694037"/>
       </p:ext>
     </p:extLst>
   </p:cSld>
@@ -35797,6 +38188,26 @@
 </file>
 
 <file path=customXml/item1.xml><?xml version="1.0" encoding="utf-8"?>
+<p:properties xmlns:p="http://schemas.microsoft.com/office/2006/metadata/properties" xmlns:xsi="http://www.w3.org/2001/XMLSchema-instance" xmlns:pc="http://schemas.microsoft.com/office/infopath/2007/PartnerControls">
+  <documentManagement>
+    <_ip_UnifiedCompliancePolicyUIAction xmlns="http://schemas.microsoft.com/sharepoint/v3" xsi:nil="true"/>
+    <Image xmlns="71af3243-3dd4-4a8d-8c0d-dd76da1f02a5">
+      <Url xsi:nil="true"/>
+      <Description xsi:nil="true"/>
+    </Image>
+    <Status xmlns="71af3243-3dd4-4a8d-8c0d-dd76da1f02a5">Not started</Status>
+    <Background xmlns="71af3243-3dd4-4a8d-8c0d-dd76da1f02a5">false</Background>
+    <_ip_UnifiedCompliancePolicyProperties xmlns="http://schemas.microsoft.com/sharepoint/v3" xsi:nil="true"/>
+    <ImageTagsTaxHTField xmlns="71af3243-3dd4-4a8d-8c0d-dd76da1f02a5">
+      <Terms xmlns="http://schemas.microsoft.com/office/infopath/2007/PartnerControls"/>
+    </ImageTagsTaxHTField>
+    <TaxCatchAll xmlns="230e9df3-be65-4c73-a93b-d1236ebd677e" xsi:nil="true"/>
+    <MediaServiceKeyPoints xmlns="71af3243-3dd4-4a8d-8c0d-dd76da1f02a5" xsi:nil="true"/>
+  </documentManagement>
+</p:properties>
+</file>
+
+<file path=customXml/item2.xml><?xml version="1.0" encoding="utf-8"?>
 <ct:contentTypeSchema xmlns:ct="http://schemas.microsoft.com/office/2006/metadata/contentType" xmlns:ma="http://schemas.microsoft.com/office/2006/metadata/properties/metaAttributes" ct:_="" ma:_="" ma:contentTypeName="Document" ma:contentTypeID="0x01010079F111ED35F8CC479449609E8A0923A6" ma:contentTypeVersion="30" ma:contentTypeDescription="Create a new document." ma:contentTypeScope="" ma:versionID="cec0622158e8f13124e9e8fd4de31bd1">
   <xsd:schema xmlns:xsd="http://www.w3.org/2001/XMLSchema" xmlns:xs="http://www.w3.org/2001/XMLSchema" xmlns:p="http://schemas.microsoft.com/office/2006/metadata/properties" xmlns:ns1="http://schemas.microsoft.com/sharepoint/v3" xmlns:ns2="71af3243-3dd4-4a8d-8c0d-dd76da1f02a5" xmlns:ns3="16c05727-aa75-4e4a-9b5f-8a80a1165891" xmlns:ns4="230e9df3-be65-4c73-a93b-d1236ebd677e" targetNamespace="http://schemas.microsoft.com/office/2006/metadata/properties" ma:root="true" ma:fieldsID="3b52f30ab005d15df08657af532e6e38" ns1:_="" ns2:_="" ns3:_="" ns4:_="">
     <xsd:import namespace="http://schemas.microsoft.com/sharepoint/v3"/>
@@ -36114,26 +38525,6 @@
 </ct:contentTypeSchema>
 </file>
 
-<file path=customXml/item2.xml><?xml version="1.0" encoding="utf-8"?>
-<p:properties xmlns:p="http://schemas.microsoft.com/office/2006/metadata/properties" xmlns:xsi="http://www.w3.org/2001/XMLSchema-instance" xmlns:pc="http://schemas.microsoft.com/office/infopath/2007/PartnerControls">
-  <documentManagement>
-    <_ip_UnifiedCompliancePolicyUIAction xmlns="http://schemas.microsoft.com/sharepoint/v3" xsi:nil="true"/>
-    <Image xmlns="71af3243-3dd4-4a8d-8c0d-dd76da1f02a5">
-      <Url xsi:nil="true"/>
-      <Description xsi:nil="true"/>
-    </Image>
-    <Status xmlns="71af3243-3dd4-4a8d-8c0d-dd76da1f02a5">Not started</Status>
-    <Background xmlns="71af3243-3dd4-4a8d-8c0d-dd76da1f02a5">false</Background>
-    <_ip_UnifiedCompliancePolicyProperties xmlns="http://schemas.microsoft.com/sharepoint/v3" xsi:nil="true"/>
-    <ImageTagsTaxHTField xmlns="71af3243-3dd4-4a8d-8c0d-dd76da1f02a5">
-      <Terms xmlns="http://schemas.microsoft.com/office/infopath/2007/PartnerControls"/>
-    </ImageTagsTaxHTField>
-    <TaxCatchAll xmlns="230e9df3-be65-4c73-a93b-d1236ebd677e" xsi:nil="true"/>
-    <MediaServiceKeyPoints xmlns="71af3243-3dd4-4a8d-8c0d-dd76da1f02a5" xsi:nil="true"/>
-  </documentManagement>
-</p:properties>
-</file>
-
 <file path=customXml/item3.xml><?xml version="1.0" encoding="utf-8"?>
 <?mso-contentType ?>
 <FormTemplates xmlns="http://schemas.microsoft.com/sharepoint/v3/contenttype/forms">
@@ -36144,6 +38535,25 @@
 </file>
 
 <file path=customXml/itemProps1.xml><?xml version="1.0" encoding="utf-8"?>
+<ds:datastoreItem xmlns:ds="http://schemas.openxmlformats.org/officeDocument/2006/customXml" ds:itemID="{D1CEDABF-7176-4A42-8EF9-E5D4DD31FF6C}">
+  <ds:schemaRefs>
+    <ds:schemaRef ds:uri="http://schemas.microsoft.com/office/infopath/2007/PartnerControls"/>
+    <ds:schemaRef ds:uri="http://purl.org/dc/terms/"/>
+    <ds:schemaRef ds:uri="http://schemas.microsoft.com/office/2006/metadata/properties"/>
+    <ds:schemaRef ds:uri="http://schemas.microsoft.com/office/2006/documentManagement/types"/>
+    <ds:schemaRef ds:uri="http://purl.org/dc/dcmitype/"/>
+    <ds:schemaRef ds:uri="http://schemas.openxmlformats.org/package/2006/metadata/core-properties"/>
+    <ds:schemaRef ds:uri="http://www.w3.org/XML/1998/namespace"/>
+    <ds:schemaRef ds:uri="230e9df3-be65-4c73-a93b-d1236ebd677e"/>
+    <ds:schemaRef ds:uri="http://purl.org/dc/elements/1.1/"/>
+    <ds:schemaRef ds:uri="16c05727-aa75-4e4a-9b5f-8a80a1165891"/>
+    <ds:schemaRef ds:uri="71af3243-3dd4-4a8d-8c0d-dd76da1f02a5"/>
+    <ds:schemaRef ds:uri="http://schemas.microsoft.com/sharepoint/v3"/>
+  </ds:schemaRefs>
+</ds:datastoreItem>
+</file>
+
+<file path=customXml/itemProps2.xml><?xml version="1.0" encoding="utf-8"?>
 <ds:datastoreItem xmlns:ds="http://schemas.openxmlformats.org/officeDocument/2006/customXml" ds:itemID="{9EEC3793-C1BC-496C-A03C-202DFFC513D6}">
   <ds:schemaRefs>
     <ds:schemaRef ds:uri="http://schemas.microsoft.com/office/2006/metadata/contentType"/>
@@ -36164,25 +38574,6 @@
 </ds:datastoreItem>
 </file>
 
-<file path=customXml/itemProps2.xml><?xml version="1.0" encoding="utf-8"?>
-<ds:datastoreItem xmlns:ds="http://schemas.openxmlformats.org/officeDocument/2006/customXml" ds:itemID="{D1CEDABF-7176-4A42-8EF9-E5D4DD31FF6C}">
-  <ds:schemaRefs>
-    <ds:schemaRef ds:uri="http://schemas.microsoft.com/office/infopath/2007/PartnerControls"/>
-    <ds:schemaRef ds:uri="http://purl.org/dc/terms/"/>
-    <ds:schemaRef ds:uri="http://schemas.microsoft.com/office/2006/metadata/properties"/>
-    <ds:schemaRef ds:uri="http://schemas.microsoft.com/office/2006/documentManagement/types"/>
-    <ds:schemaRef ds:uri="http://purl.org/dc/dcmitype/"/>
-    <ds:schemaRef ds:uri="http://schemas.openxmlformats.org/package/2006/metadata/core-properties"/>
-    <ds:schemaRef ds:uri="http://www.w3.org/XML/1998/namespace"/>
-    <ds:schemaRef ds:uri="230e9df3-be65-4c73-a93b-d1236ebd677e"/>
-    <ds:schemaRef ds:uri="http://purl.org/dc/elements/1.1/"/>
-    <ds:schemaRef ds:uri="16c05727-aa75-4e4a-9b5f-8a80a1165891"/>
-    <ds:schemaRef ds:uri="71af3243-3dd4-4a8d-8c0d-dd76da1f02a5"/>
-    <ds:schemaRef ds:uri="http://schemas.microsoft.com/sharepoint/v3"/>
-  </ds:schemaRefs>
-</ds:datastoreItem>
-</file>
-
 <file path=customXml/itemProps3.xml><?xml version="1.0" encoding="utf-8"?>
 <ds:datastoreItem xmlns:ds="http://schemas.openxmlformats.org/officeDocument/2006/customXml" ds:itemID="{D3301439-688F-4D19-B908-B48B62C56078}">
   <ds:schemaRefs>

</xml_diff>

<commit_message>
system architecture explanation and diagram
</commit_message>
<xml_diff>
--- a/EGT307 PRESENTATION.pptx
+++ b/EGT307 PRESENTATION.pptx
@@ -241,7 +241,7 @@
           <a:p>
             <a:fld id="{D5D1EC30-5B0B-48D0-A1A8-66A96720DF24}" type="datetimeFigureOut">
               <a:rPr lang="en-US" smtClean="0"/>
-              <a:t>7/19/2026</a:t>
+              <a:t>7/27/2026</a:t>
             </a:fld>
             <a:endParaRPr lang="en-US" dirty="0"/>
           </a:p>
@@ -418,7 +418,7 @@
           <a:p>
             <a:fld id="{69F68A4D-42A7-45F7-9930-00E8DCB48D7E}" type="datetimeFigureOut">
               <a:rPr lang="en-US" smtClean="0"/>
-              <a:t>7/19/2026</a:t>
+              <a:t>7/27/2026</a:t>
             </a:fld>
             <a:endParaRPr lang="en-US" dirty="0"/>
           </a:p>
@@ -1979,7 +1979,7 @@
           <a:p>
             <a:fld id="{EBC9FF77-C2BC-3842-9757-C2EBADB34099}" type="datetime1">
               <a:rPr lang="en-US" smtClean="0"/>
-              <a:t>7/19/2026</a:t>
+              <a:t>7/27/2026</a:t>
             </a:fld>
             <a:endParaRPr lang="en-US" dirty="0"/>
           </a:p>
@@ -2343,7 +2343,7 @@
           <a:p>
             <a:fld id="{010D0AB2-23BC-3043-AC30-5928E542C0CE}" type="datetime1">
               <a:rPr lang="en-US" smtClean="0"/>
-              <a:t>7/19/2026</a:t>
+              <a:t>7/27/2026</a:t>
             </a:fld>
             <a:endParaRPr lang="en-US" dirty="0"/>
           </a:p>
@@ -2869,7 +2869,7 @@
           <a:p>
             <a:fld id="{3EE24C61-4277-DA47-BF4A-DCEFD7F4C6B4}" type="datetime1">
               <a:rPr lang="en-US" smtClean="0"/>
-              <a:t>7/19/2026</a:t>
+              <a:t>7/27/2026</a:t>
             </a:fld>
             <a:endParaRPr lang="en-US" dirty="0"/>
           </a:p>
@@ -3395,7 +3395,7 @@
           <a:p>
             <a:fld id="{53D1C53B-D534-AA48-85B3-4F5B03DDCBA8}" type="datetime1">
               <a:rPr lang="en-US" smtClean="0"/>
-              <a:t>7/19/2026</a:t>
+              <a:t>7/27/2026</a:t>
             </a:fld>
             <a:endParaRPr lang="en-US" dirty="0"/>
           </a:p>
@@ -4041,7 +4041,7 @@
           <a:p>
             <a:fld id="{B2A7CB4E-BD8C-8E4D-91FF-B1939559C134}" type="datetime1">
               <a:rPr lang="en-US" smtClean="0"/>
-              <a:t>7/19/2026</a:t>
+              <a:t>7/27/2026</a:t>
             </a:fld>
             <a:endParaRPr lang="en-US" dirty="0"/>
           </a:p>
@@ -4650,7 +4650,7 @@
           <a:p>
             <a:fld id="{4142E188-D61A-9842-B8A2-1559B3399613}" type="datetime1">
               <a:rPr lang="en-US" smtClean="0"/>
-              <a:t>7/19/2026</a:t>
+              <a:t>7/27/2026</a:t>
             </a:fld>
             <a:endParaRPr lang="en-US" dirty="0"/>
           </a:p>
@@ -5221,7 +5221,7 @@
           <a:p>
             <a:fld id="{0D0C1909-8EA0-3E44-B1AC-A9EA56584238}" type="datetime1">
               <a:rPr lang="en-US" smtClean="0"/>
-              <a:t>7/19/2026</a:t>
+              <a:t>7/27/2026</a:t>
             </a:fld>
             <a:endParaRPr lang="en-US" dirty="0"/>
           </a:p>
@@ -5760,7 +5760,7 @@
           <a:p>
             <a:fld id="{C752DD5A-B150-8340-8E59-4C8F3F7E3A59}" type="datetime1">
               <a:rPr lang="en-US" smtClean="0"/>
-              <a:t>7/19/2026</a:t>
+              <a:t>7/27/2026</a:t>
             </a:fld>
             <a:endParaRPr lang="en-US" dirty="0"/>
           </a:p>
@@ -6269,7 +6269,7 @@
           <a:p>
             <a:fld id="{0FD936B8-E398-1A41-8DE9-58DDB113FEEA}" type="datetime1">
               <a:rPr lang="en-US" smtClean="0"/>
-              <a:t>7/19/2026</a:t>
+              <a:t>7/27/2026</a:t>
             </a:fld>
             <a:endParaRPr lang="en-US" dirty="0"/>
           </a:p>
@@ -6767,7 +6767,7 @@
           <a:p>
             <a:fld id="{927C0DEB-4AE1-EA4D-826D-E3C22802B942}" type="datetime1">
               <a:rPr lang="en-US" smtClean="0"/>
-              <a:t>7/19/2026</a:t>
+              <a:t>7/27/2026</a:t>
             </a:fld>
             <a:endParaRPr lang="en-US" dirty="0"/>
           </a:p>
@@ -7252,7 +7252,7 @@
           <a:p>
             <a:fld id="{BE2752B3-7BF7-614C-A80A-1256FFE41AD1}" type="datetime1">
               <a:rPr lang="en-US" smtClean="0"/>
-              <a:t>7/19/2026</a:t>
+              <a:t>7/27/2026</a:t>
             </a:fld>
             <a:endParaRPr lang="en-US" dirty="0"/>
           </a:p>
@@ -7706,7 +7706,7 @@
           <a:p>
             <a:fld id="{40482BA7-8406-1C47-9A76-988652CA5787}" type="datetime1">
               <a:rPr lang="en-US" smtClean="0"/>
-              <a:t>7/19/2026</a:t>
+              <a:t>7/27/2026</a:t>
             </a:fld>
             <a:endParaRPr lang="en-US" dirty="0"/>
           </a:p>
@@ -8263,7 +8263,7 @@
           <a:p>
             <a:fld id="{79F03E26-E542-1A4D-AC7A-1E4E95BAEC6A}" type="datetime1">
               <a:rPr lang="en-US" smtClean="0"/>
-              <a:t>7/19/2026</a:t>
+              <a:t>7/27/2026</a:t>
             </a:fld>
             <a:endParaRPr lang="en-US" dirty="0"/>
           </a:p>
@@ -8861,7 +8861,7 @@
           <a:p>
             <a:fld id="{115476B0-E2C7-E147-B9CE-3E274E847A52}" type="datetime1">
               <a:rPr lang="en-US" smtClean="0"/>
-              <a:t>7/19/2026</a:t>
+              <a:t>7/27/2026</a:t>
             </a:fld>
             <a:endParaRPr lang="en-US" dirty="0"/>
           </a:p>
@@ -9459,7 +9459,7 @@
           <a:p>
             <a:fld id="{30D7DCC1-5043-7A46-8443-F8426D5EAB75}" type="datetime1">
               <a:rPr lang="en-US" smtClean="0"/>
-              <a:t>7/19/2026</a:t>
+              <a:t>7/27/2026</a:t>
             </a:fld>
             <a:endParaRPr lang="en-US" dirty="0"/>
           </a:p>
@@ -10059,7 +10059,7 @@
           <a:p>
             <a:fld id="{D1A2963D-70FD-3A42-A53A-2480966C033D}" type="datetime1">
               <a:rPr lang="en-US" smtClean="0"/>
-              <a:t>7/19/2026</a:t>
+              <a:t>7/27/2026</a:t>
             </a:fld>
             <a:endParaRPr lang="en-US" dirty="0"/>
           </a:p>
@@ -10659,7 +10659,7 @@
           <a:p>
             <a:fld id="{F1A8FB16-FCFB-DA44-98E9-136CD51670D6}" type="datetime1">
               <a:rPr lang="en-US" smtClean="0"/>
-              <a:t>7/19/2026</a:t>
+              <a:t>7/27/2026</a:t>
             </a:fld>
             <a:endParaRPr lang="en-US" dirty="0"/>
           </a:p>
@@ -11257,7 +11257,7 @@
           <a:p>
             <a:fld id="{58EFB3A8-11B5-7149-8412-15238624EFFD}" type="datetime1">
               <a:rPr lang="en-US" smtClean="0"/>
-              <a:t>7/19/2026</a:t>
+              <a:t>7/27/2026</a:t>
             </a:fld>
             <a:endParaRPr lang="en-US" dirty="0"/>
           </a:p>
@@ -11855,7 +11855,7 @@
           <a:p>
             <a:fld id="{650FCFAB-53E3-A342-A296-D67E0AB8D0CD}" type="datetime1">
               <a:rPr lang="en-US" smtClean="0"/>
-              <a:t>7/19/2026</a:t>
+              <a:t>7/27/2026</a:t>
             </a:fld>
             <a:endParaRPr lang="en-US" dirty="0"/>
           </a:p>
@@ -12451,7 +12451,7 @@
           <a:p>
             <a:fld id="{8DC46901-11EF-4445-8903-DC36784F331E}" type="datetime1">
               <a:rPr lang="en-US" smtClean="0"/>
-              <a:t>7/19/2026</a:t>
+              <a:t>7/27/2026</a:t>
             </a:fld>
             <a:endParaRPr lang="en-US" dirty="0"/>
           </a:p>
@@ -12980,7 +12980,7 @@
           <a:p>
             <a:fld id="{86A42598-CA8F-5141-9F98-7018240FA786}" type="datetime1">
               <a:rPr lang="en-US" smtClean="0"/>
-              <a:t>7/19/2026</a:t>
+              <a:t>7/27/2026</a:t>
             </a:fld>
             <a:endParaRPr lang="en-US" dirty="0"/>
           </a:p>
@@ -13596,7 +13596,7 @@
           <a:p>
             <a:fld id="{BB5C750C-98D3-2541-9DBA-212130458E4E}" type="datetime1">
               <a:rPr lang="en-US" smtClean="0"/>
-              <a:t>7/19/2026</a:t>
+              <a:t>7/27/2026</a:t>
             </a:fld>
             <a:endParaRPr lang="en-US" dirty="0"/>
           </a:p>
@@ -14196,7 +14196,7 @@
           <a:p>
             <a:fld id="{91C99844-6C9E-BB4D-8B47-7C2CC32AAC02}" type="datetime1">
               <a:rPr lang="en-US" smtClean="0"/>
-              <a:t>7/19/2026</a:t>
+              <a:t>7/27/2026</a:t>
             </a:fld>
             <a:endParaRPr lang="en-US" dirty="0"/>
           </a:p>
@@ -14796,7 +14796,7 @@
           <a:p>
             <a:fld id="{97582611-C0A2-BD42-A8F7-C2F9A013F10C}" type="datetime1">
               <a:rPr lang="en-US" smtClean="0"/>
-              <a:t>7/19/2026</a:t>
+              <a:t>7/27/2026</a:t>
             </a:fld>
             <a:endParaRPr lang="en-US" dirty="0"/>
           </a:p>
@@ -15394,7 +15394,7 @@
           <a:p>
             <a:fld id="{1048417B-2BA9-FC42-993A-F5CAB8ABAB3C}" type="datetime1">
               <a:rPr lang="en-US" smtClean="0"/>
-              <a:t>7/19/2026</a:t>
+              <a:t>7/27/2026</a:t>
             </a:fld>
             <a:endParaRPr lang="en-US" dirty="0"/>
           </a:p>
@@ -15997,7 +15997,7 @@
           <a:p>
             <a:fld id="{B9956DE8-31F3-0C48-AD89-A99E39B5E351}" type="datetime1">
               <a:rPr lang="en-US" smtClean="0"/>
-              <a:t>7/19/2026</a:t>
+              <a:t>7/27/2026</a:t>
             </a:fld>
             <a:endParaRPr lang="en-US" dirty="0"/>
           </a:p>
@@ -16557,7 +16557,7 @@
           <a:p>
             <a:fld id="{1247F170-621E-394E-A3F2-D37D14C6B270}" type="datetime1">
               <a:rPr lang="en-US" smtClean="0"/>
-              <a:t>7/19/2026</a:t>
+              <a:t>7/27/2026</a:t>
             </a:fld>
             <a:endParaRPr lang="en-US" dirty="0"/>
           </a:p>
@@ -17119,7 +17119,7 @@
           <a:p>
             <a:fld id="{3BFEB256-000B-7640-A176-A6ED88FB302B}" type="datetime1">
               <a:rPr lang="en-US" smtClean="0"/>
-              <a:t>7/19/2026</a:t>
+              <a:t>7/27/2026</a:t>
             </a:fld>
             <a:endParaRPr lang="en-US" dirty="0"/>
           </a:p>
@@ -17676,7 +17676,7 @@
           <a:p>
             <a:fld id="{AD187FAD-DCB9-3D4B-B066-9000219F05FB}" type="datetime1">
               <a:rPr lang="en-US" smtClean="0"/>
-              <a:t>7/19/2026</a:t>
+              <a:t>7/27/2026</a:t>
             </a:fld>
             <a:endParaRPr lang="en-US" dirty="0"/>
           </a:p>
@@ -18276,7 +18276,7 @@
           <a:p>
             <a:fld id="{189C5B77-1EC5-224E-B44E-9B7868782731}" type="datetime1">
               <a:rPr lang="en-US" smtClean="0"/>
-              <a:t>7/19/2026</a:t>
+              <a:t>7/27/2026</a:t>
             </a:fld>
             <a:endParaRPr lang="en-US" dirty="0"/>
           </a:p>
@@ -18879,7 +18879,7 @@
           <a:p>
             <a:fld id="{C8F601A6-19D3-EB49-B7F2-A9801AE13DA6}" type="datetime1">
               <a:rPr lang="en-US" smtClean="0"/>
-              <a:t>7/19/2026</a:t>
+              <a:t>7/27/2026</a:t>
             </a:fld>
             <a:endParaRPr lang="en-US" dirty="0"/>
           </a:p>
@@ -19361,7 +19361,7 @@
           <a:p>
             <a:fld id="{FF5D23C8-9820-654D-9C1E-FE1FC23DA807}" type="datetime1">
               <a:rPr lang="en-US" smtClean="0"/>
-              <a:t>7/19/2026</a:t>
+              <a:t>7/27/2026</a:t>
             </a:fld>
             <a:endParaRPr lang="en-US" dirty="0"/>
           </a:p>
@@ -19982,7 +19982,7 @@
           <a:p>
             <a:fld id="{B5DCFA2C-3BE3-964B-9AAF-C20CC59CEE43}" type="datetime1">
               <a:rPr lang="en-US" smtClean="0"/>
-              <a:t>7/19/2026</a:t>
+              <a:t>7/27/2026</a:t>
             </a:fld>
             <a:endParaRPr lang="en-US" dirty="0"/>
           </a:p>
@@ -20420,7 +20420,7 @@
           <a:p>
             <a:fld id="{79A3CDA5-1015-3148-A386-36088AF5334C}" type="datetime1">
               <a:rPr lang="en-US" smtClean="0"/>
-              <a:t>7/19/2026</a:t>
+              <a:t>7/27/2026</a:t>
             </a:fld>
             <a:endParaRPr lang="en-US" dirty="0"/>
           </a:p>
@@ -20855,7 +20855,7 @@
           <a:p>
             <a:fld id="{C112E8AA-E35F-CF44-B5A4-3B5EDD4AC3FC}" type="datetime1">
               <a:rPr lang="en-US" smtClean="0"/>
-              <a:t>7/19/2026</a:t>
+              <a:t>7/27/2026</a:t>
             </a:fld>
             <a:endParaRPr lang="en-US" dirty="0"/>
           </a:p>
@@ -21467,7 +21467,7 @@
           <a:p>
             <a:fld id="{E0FF3B4E-61F2-9C45-A7C9-0649FA3F05AD}" type="datetime1">
               <a:rPr lang="en-US" smtClean="0"/>
-              <a:t>7/19/2026</a:t>
+              <a:t>7/27/2026</a:t>
             </a:fld>
             <a:endParaRPr lang="en-US" dirty="0"/>
           </a:p>
@@ -22092,7 +22092,7 @@
           <a:p>
             <a:fld id="{CC4A289B-0B17-4246-8E33-E89C12A90840}" type="datetime1">
               <a:rPr lang="en-US" smtClean="0"/>
-              <a:t>7/19/2026</a:t>
+              <a:t>7/27/2026</a:t>
             </a:fld>
             <a:endParaRPr lang="en-US" dirty="0"/>
           </a:p>
@@ -22712,7 +22712,7 @@
           <a:p>
             <a:fld id="{C8092CDE-5B88-E044-9012-03F4795B046E}" type="datetime1">
               <a:rPr lang="en-US" smtClean="0"/>
-              <a:t>7/19/2026</a:t>
+              <a:t>7/27/2026</a:t>
             </a:fld>
             <a:endParaRPr lang="en-US" dirty="0"/>
           </a:p>
@@ -23366,7 +23366,7 @@
           <a:p>
             <a:fld id="{EC076D1D-DE21-9B42-8106-8CD72DA85F70}" type="datetime1">
               <a:rPr lang="en-US" smtClean="0"/>
-              <a:t>7/19/2026</a:t>
+              <a:t>7/27/2026</a:t>
             </a:fld>
             <a:endParaRPr lang="en-US" dirty="0"/>
           </a:p>
@@ -24020,7 +24020,7 @@
           <a:p>
             <a:fld id="{57807DC2-592A-C24E-8E32-92959310D82C}" type="datetime1">
               <a:rPr lang="en-US" smtClean="0"/>
-              <a:t>7/19/2026</a:t>
+              <a:t>7/27/2026</a:t>
             </a:fld>
             <a:endParaRPr lang="en-US" dirty="0"/>
           </a:p>
@@ -24707,7 +24707,7 @@
             <a:fld id="{2A17FF52-3D92-5045-83B3-191BF759FA8D}" type="datetime1">
               <a:rPr lang="en-US" smtClean="0"/>
               <a:pPr/>
-              <a:t>7/19/2026</a:t>
+              <a:t>7/27/2026</a:t>
             </a:fld>
             <a:endParaRPr lang="en-US" dirty="0"/>
           </a:p>
@@ -25148,7 +25148,7 @@
             <a:fld id="{17C67708-7A94-8245-80C8-4B4702495DB1}" type="datetime1">
               <a:rPr lang="en-US" smtClean="0"/>
               <a:pPr/>
-              <a:t>7/19/2026</a:t>
+              <a:t>7/27/2026</a:t>
             </a:fld>
             <a:endParaRPr lang="en-US" dirty="0"/>
           </a:p>
@@ -25673,7 +25673,7 @@
           <a:p>
             <a:fld id="{763C345D-F56F-0743-AB88-4EB3E35EF63D}" type="datetime1">
               <a:rPr lang="en-US" smtClean="0"/>
-              <a:t>7/19/2026</a:t>
+              <a:t>7/27/2026</a:t>
             </a:fld>
             <a:endParaRPr lang="en-US" dirty="0"/>
           </a:p>
@@ -26171,7 +26171,7 @@
             <a:fld id="{C3A90753-8D45-EB44-AB23-49A6290D6DA6}" type="datetime1">
               <a:rPr lang="en-US" smtClean="0"/>
               <a:pPr/>
-              <a:t>7/19/2026</a:t>
+              <a:t>7/27/2026</a:t>
             </a:fld>
             <a:endParaRPr lang="en-US" dirty="0"/>
           </a:p>
@@ -26757,7 +26757,7 @@
           <a:p>
             <a:fld id="{C5059AB6-B751-F44D-A28C-E19CFA261A8F}" type="datetime1">
               <a:rPr lang="en-US" smtClean="0"/>
-              <a:t>7/19/2026</a:t>
+              <a:t>7/27/2026</a:t>
             </a:fld>
             <a:endParaRPr lang="en-US" dirty="0"/>
           </a:p>
@@ -27460,7 +27460,7 @@
           <a:p>
             <a:fld id="{F4B7459A-9905-1A4B-AB1A-C91FAC752AC6}" type="datetime1">
               <a:rPr lang="en-US" smtClean="0"/>
-              <a:t>7/19/2026</a:t>
+              <a:t>7/27/2026</a:t>
             </a:fld>
             <a:endParaRPr lang="en-US" dirty="0"/>
           </a:p>
@@ -27843,7 +27843,7 @@
           <a:p>
             <a:fld id="{D255AB00-997D-D540-BC20-37B7E62B26C1}" type="datetime1">
               <a:rPr lang="en-US" smtClean="0"/>
-              <a:t>7/19/2026</a:t>
+              <a:t>7/27/2026</a:t>
             </a:fld>
             <a:endParaRPr lang="en-US" dirty="0"/>
           </a:p>
@@ -28184,7 +28184,7 @@
           <a:p>
             <a:fld id="{69F3ECCF-2CCD-CA4B-8712-AE4484B24AE9}" type="datetime1">
               <a:rPr lang="en-US" smtClean="0"/>
-              <a:t>7/19/2026</a:t>
+              <a:t>7/27/2026</a:t>
             </a:fld>
             <a:endParaRPr lang="en-US" dirty="0"/>
           </a:p>
@@ -28769,7 +28769,7 @@
           <a:p>
             <a:fld id="{22942A74-7D23-DC49-91AA-85B24B3B8A00}" type="datetime1">
               <a:rPr lang="en-US" smtClean="0"/>
-              <a:t>7/19/2026</a:t>
+              <a:t>7/27/2026</a:t>
             </a:fld>
             <a:endParaRPr lang="en-US" dirty="0"/>
           </a:p>
@@ -29322,7 +29322,7 @@
           <a:p>
             <a:fld id="{22A0247B-8639-BE4B-9EB6-99BF33B2FE57}" type="datetime1">
               <a:rPr lang="en-US" smtClean="0"/>
-              <a:t>7/19/2026</a:t>
+              <a:t>7/27/2026</a:t>
             </a:fld>
             <a:endParaRPr lang="en-US" dirty="0"/>
           </a:p>
@@ -29852,7 +29852,7 @@
           <a:p>
             <a:fld id="{162FAA25-3923-0740-83DA-275C59DD4599}" type="datetime1">
               <a:rPr lang="en-US" smtClean="0"/>
-              <a:t>7/19/2026</a:t>
+              <a:t>7/27/2026</a:t>
             </a:fld>
             <a:endParaRPr lang="en-US" dirty="0"/>
           </a:p>
@@ -30343,7 +30343,7 @@
           <a:p>
             <a:fld id="{AB1B52C7-37F9-BD40-8BE5-16C7107F6B2A}" type="datetime1">
               <a:rPr lang="en-US" smtClean="0"/>
-              <a:t>7/19/2026</a:t>
+              <a:t>7/27/2026</a:t>
             </a:fld>
             <a:endParaRPr lang="en-US" dirty="0"/>
           </a:p>
@@ -31060,7 +31060,7 @@
           <a:p>
             <a:fld id="{FF5D23C8-9820-654D-9C1E-FE1FC23DA807}" type="datetime1">
               <a:rPr lang="en-US" smtClean="0"/>
-              <a:t>7/19/2026</a:t>
+              <a:t>7/27/2026</a:t>
             </a:fld>
             <a:endParaRPr lang="en-US" dirty="0"/>
           </a:p>
@@ -31306,7 +31306,7 @@
           <a:p>
             <a:fld id="{5594B28A-4C74-C14A-960D-ABD28BCC0EB4}" type="datetime1">
               <a:rPr lang="en-US" smtClean="0"/>
-              <a:t>7/19/2026</a:t>
+              <a:t>7/27/2026</a:t>
             </a:fld>
             <a:endParaRPr lang="en-US" dirty="0"/>
           </a:p>
@@ -31724,7 +31724,7 @@
           <a:p>
             <a:fld id="{D8CCD23C-B1EB-604C-96F1-0CF64015D152}" type="datetime1">
               <a:rPr lang="en-US" smtClean="0"/>
-              <a:t>7/19/2026</a:t>
+              <a:t>7/27/2026</a:t>
             </a:fld>
             <a:endParaRPr lang="en-US" dirty="0"/>
           </a:p>
@@ -32161,7 +32161,7 @@
           <a:p>
             <a:fld id="{4BE11430-0446-F343-817C-D9D2C78891B0}" type="datetime1">
               <a:rPr lang="en-US" smtClean="0"/>
-              <a:t>7/19/2026</a:t>
+              <a:t>7/27/2026</a:t>
             </a:fld>
             <a:endParaRPr lang="en-US" dirty="0"/>
           </a:p>
@@ -32682,7 +32682,7 @@
             <a:fld id="{6739503E-9C75-484A-A764-D9D8121AAE05}" type="datetime1">
               <a:rPr lang="en-US" smtClean="0"/>
               <a:pPr/>
-              <a:t>7/19/2026</a:t>
+              <a:t>7/27/2026</a:t>
             </a:fld>
             <a:endParaRPr lang="en-US" dirty="0"/>
           </a:p>
@@ -33620,7 +33620,7 @@
           <a:p>
             <a:fld id="{927C0DEB-4AE1-EA4D-826D-E3C22802B942}" type="datetime1">
               <a:rPr lang="en-US" smtClean="0"/>
-              <a:t>7/20/2026</a:t>
+              <a:t>7/27/2026</a:t>
             </a:fld>
             <a:endParaRPr lang="en-US" dirty="0"/>
           </a:p>
@@ -33791,7 +33791,7 @@
           <a:p>
             <a:fld id="{927C0DEB-4AE1-EA4D-826D-E3C22802B942}" type="datetime1">
               <a:rPr lang="en-US" smtClean="0"/>
-              <a:t>7/20/2026</a:t>
+              <a:t>7/27/2026</a:t>
             </a:fld>
             <a:endParaRPr lang="en-US" dirty="0"/>
           </a:p>
@@ -33962,7 +33962,7 @@
           <a:p>
             <a:fld id="{927C0DEB-4AE1-EA4D-826D-E3C22802B942}" type="datetime1">
               <a:rPr lang="en-US" smtClean="0"/>
-              <a:t>7/20/2026</a:t>
+              <a:t>7/27/2026</a:t>
             </a:fld>
             <a:endParaRPr lang="en-US" dirty="0"/>
           </a:p>
@@ -34108,7 +34108,7 @@
           <a:p>
             <a:fld id="{010D0AB2-23BC-3043-AC30-5928E542C0CE}" type="datetime1">
               <a:rPr lang="en-US" smtClean="0"/>
-              <a:t>7/19/2026</a:t>
+              <a:t>7/27/2026</a:t>
             </a:fld>
             <a:endParaRPr lang="en-US" dirty="0"/>
           </a:p>
@@ -34254,7 +34254,7 @@
           <a:p>
             <a:fld id="{010D0AB2-23BC-3043-AC30-5928E542C0CE}" type="datetime1">
               <a:rPr lang="en-US" smtClean="0"/>
-              <a:t>7/19/2026</a:t>
+              <a:t>7/27/2026</a:t>
             </a:fld>
             <a:endParaRPr lang="en-US" dirty="0"/>
           </a:p>
@@ -34405,7 +34405,7 @@
           <a:p>
             <a:fld id="{010D0AB2-23BC-3043-AC30-5928E542C0CE}" type="datetime1">
               <a:rPr lang="en-US" smtClean="0"/>
-              <a:t>7/19/2026</a:t>
+              <a:t>7/27/2026</a:t>
             </a:fld>
             <a:endParaRPr lang="en-US" dirty="0"/>
           </a:p>
@@ -34551,7 +34551,7 @@
           <a:p>
             <a:fld id="{010D0AB2-23BC-3043-AC30-5928E542C0CE}" type="datetime1">
               <a:rPr lang="en-US" smtClean="0"/>
-              <a:t>7/19/2026</a:t>
+              <a:t>7/27/2026</a:t>
             </a:fld>
             <a:endParaRPr lang="en-US" dirty="0"/>
           </a:p>
@@ -34697,7 +34697,7 @@
           <a:p>
             <a:fld id="{010D0AB2-23BC-3043-AC30-5928E542C0CE}" type="datetime1">
               <a:rPr lang="en-US" smtClean="0"/>
-              <a:t>7/19/2026</a:t>
+              <a:t>7/27/2026</a:t>
             </a:fld>
             <a:endParaRPr lang="en-US" dirty="0"/>
           </a:p>
@@ -34979,7 +34979,7 @@
                   <a:spcPts val="600"/>
                 </a:spcAft>
               </a:pPr>
-              <a:t>7/19/2026</a:t>
+              <a:t>7/27/2026</a:t>
             </a:fld>
             <a:endParaRPr lang="en-US"/>
           </a:p>
@@ -35265,7 +35265,7 @@
           <a:p>
             <a:fld id="{927C0DEB-4AE1-EA4D-826D-E3C22802B942}" type="datetime1">
               <a:rPr lang="en-US" smtClean="0"/>
-              <a:t>7/20/2026</a:t>
+              <a:t>7/27/2026</a:t>
             </a:fld>
             <a:endParaRPr lang="en-US" dirty="0"/>
           </a:p>
@@ -35502,7 +35502,7 @@
                   <a:spcPts val="600"/>
                 </a:spcAft>
               </a:pPr>
-              <a:t>7/20/2026</a:t>
+              <a:t>7/27/2026</a:t>
             </a:fld>
             <a:endParaRPr lang="en-US"/>
           </a:p>
@@ -35835,7 +35835,7 @@
                   <a:spcPts val="600"/>
                 </a:spcAft>
               </a:pPr>
-              <a:t>7/20/2026</a:t>
+              <a:t>7/27/2026</a:t>
             </a:fld>
             <a:endParaRPr lang="en-US"/>
           </a:p>
@@ -35998,7 +35998,7 @@
           <a:p>
             <a:fld id="{53D1C53B-D534-AA48-85B3-4F5B03DDCBA8}" type="datetime1">
               <a:rPr lang="en-US" smtClean="0"/>
-              <a:t>7/19/2026</a:t>
+              <a:t>7/27/2026</a:t>
             </a:fld>
             <a:endParaRPr lang="en-US" dirty="0"/>
           </a:p>
@@ -36150,7 +36150,7 @@
           <a:p>
             <a:fld id="{53D1C53B-D534-AA48-85B3-4F5B03DDCBA8}" type="datetime1">
               <a:rPr lang="en-US" smtClean="0"/>
-              <a:t>7/19/2026</a:t>
+              <a:t>7/27/2026</a:t>
             </a:fld>
             <a:endParaRPr lang="en-US" dirty="0"/>
           </a:p>
@@ -36302,7 +36302,7 @@
           <a:p>
             <a:fld id="{927C0DEB-4AE1-EA4D-826D-E3C22802B942}" type="datetime1">
               <a:rPr lang="en-US" smtClean="0"/>
-              <a:t>7/19/2026</a:t>
+              <a:t>7/27/2026</a:t>
             </a:fld>
             <a:endParaRPr lang="en-US" dirty="0"/>
           </a:p>
@@ -36382,7 +36382,7 @@
             <a:pPr algn="ctr"/>
             <a:r>
               <a:rPr lang="en-SG" b="1" dirty="0"/>
-              <a:t>FRONTEND DASHBOARD</a:t>
+              <a:t>IoT Sensors</a:t>
             </a:r>
           </a:p>
         </p:txBody>
@@ -36431,7 +36431,7 @@
             <a:pPr algn="ctr"/>
             <a:r>
               <a:rPr lang="en-SG" b="1" dirty="0"/>
-              <a:t>REST API REQUEST</a:t>
+              <a:t>Data Ingestion</a:t>
             </a:r>
           </a:p>
         </p:txBody>
@@ -36480,7 +36480,7 @@
             <a:pPr algn="ctr"/>
             <a:r>
               <a:rPr lang="en-SG" b="1" dirty="0"/>
-              <a:t>BACKEND API </a:t>
+              <a:t>Database</a:t>
             </a:r>
           </a:p>
         </p:txBody>
@@ -36529,7 +36529,7 @@
             <a:pPr algn="ctr"/>
             <a:r>
               <a:rPr lang="en-SG" b="1" dirty="0"/>
-              <a:t>DATABASE</a:t>
+              <a:t>Backend API</a:t>
             </a:r>
           </a:p>
         </p:txBody>
@@ -36627,7 +36627,7 @@
             <a:pPr algn="ctr"/>
             <a:r>
               <a:rPr lang="en-SG" b="1" dirty="0"/>
-              <a:t>DATABASE</a:t>
+              <a:t>Prediction</a:t>
             </a:r>
           </a:p>
         </p:txBody>
@@ -36676,7 +36676,7 @@
             <a:pPr algn="ctr"/>
             <a:r>
               <a:rPr lang="en-SG" b="1" dirty="0"/>
-              <a:t>BACKEND API </a:t>
+              <a:t>Notification</a:t>
             </a:r>
           </a:p>
         </p:txBody>
@@ -36725,7 +36725,7 @@
             <a:pPr algn="ctr"/>
             <a:r>
               <a:rPr lang="en-SG" b="1" dirty="0"/>
-              <a:t>FRONTEND DASHBOARD</a:t>
+              <a:t>Telegram Bot</a:t>
             </a:r>
           </a:p>
         </p:txBody>
@@ -37069,109 +37069,101 @@
       </p:cxnSp>
       <p:sp>
         <p:nvSpPr>
-          <p:cNvPr id="42" name="TextBox 41">
-            <a:extLst>
-              <a:ext uri="{FF2B5EF4-FFF2-40B4-BE49-F238E27FC236}">
-                <a16:creationId xmlns:a16="http://schemas.microsoft.com/office/drawing/2014/main" id="{B0DB540F-21B3-F355-93D9-C446F53FE396}"/>
-              </a:ext>
-            </a:extLst>
-          </p:cNvPr>
-          <p:cNvSpPr txBox="1"/>
+          <p:cNvPr id="8" name="Rectangle 7">
+            <a:extLst>
+              <a:ext uri="{FF2B5EF4-FFF2-40B4-BE49-F238E27FC236}">
+                <a16:creationId xmlns:a16="http://schemas.microsoft.com/office/drawing/2014/main" id="{FF7827A5-7D57-8FF6-F4F0-A50EEA2ADA8F}"/>
+              </a:ext>
+            </a:extLst>
+          </p:cNvPr>
+          <p:cNvSpPr/>
           <p:nvPr/>
         </p:nvSpPr>
         <p:spPr>
           <a:xfrm>
-            <a:off x="3220836" y="5087428"/>
-            <a:ext cx="938077" cy="369332"/>
+            <a:off x="7591265" y="5029116"/>
+            <a:ext cx="2007080" cy="971910"/>
           </a:xfrm>
           <a:prstGeom prst="rect">
             <a:avLst/>
           </a:prstGeom>
-          <a:noFill/>
         </p:spPr>
-        <p:txBody>
-          <a:bodyPr wrap="none" rtlCol="0">
-            <a:spAutoFit/>
-          </a:bodyPr>
+        <p:style>
+          <a:lnRef idx="2">
+            <a:schemeClr val="accent2">
+              <a:shade val="15000"/>
+            </a:schemeClr>
+          </a:lnRef>
+          <a:fillRef idx="1">
+            <a:schemeClr val="accent2"/>
+          </a:fillRef>
+          <a:effectRef idx="0">
+            <a:schemeClr val="accent2"/>
+          </a:effectRef>
+          <a:fontRef idx="minor">
+            <a:schemeClr val="lt1"/>
+          </a:fontRef>
+        </p:style>
+        <p:txBody>
+          <a:bodyPr rtlCol="0" anchor="ctr"/>
           <a:lstStyle/>
           <a:p>
-            <a:r>
-              <a:rPr lang="en-SG" dirty="0"/>
-              <a:t>Display</a:t>
-            </a:r>
-          </a:p>
-        </p:txBody>
-      </p:sp>
-      <p:sp>
-        <p:nvSpPr>
-          <p:cNvPr id="44" name="TextBox 43">
-            <a:extLst>
-              <a:ext uri="{FF2B5EF4-FFF2-40B4-BE49-F238E27FC236}">
-                <a16:creationId xmlns:a16="http://schemas.microsoft.com/office/drawing/2014/main" id="{DB9A1047-40CE-AE69-17DB-F70C5AAECBF9}"/>
-              </a:ext>
-            </a:extLst>
-          </p:cNvPr>
-          <p:cNvSpPr txBox="1"/>
+            <a:pPr algn="ctr"/>
+            <a:r>
+              <a:rPr lang="en-SG" b="1" dirty="0"/>
+              <a:t>FRONTEND DASHBOARD</a:t>
+            </a:r>
+          </a:p>
+        </p:txBody>
+      </p:sp>
+      <p:cxnSp>
+        <p:nvCxnSpPr>
+          <p:cNvPr id="12" name="Straight Arrow Connector 11">
+            <a:extLst>
+              <a:ext uri="{FF2B5EF4-FFF2-40B4-BE49-F238E27FC236}">
+                <a16:creationId xmlns:a16="http://schemas.microsoft.com/office/drawing/2014/main" id="{AD051656-A33A-2CF1-E4EB-1BD7EDEF2466}"/>
+              </a:ext>
+            </a:extLst>
+          </p:cNvPr>
+          <p:cNvCxnSpPr>
+            <a:stCxn id="21" idx="3"/>
+            <a:endCxn id="8" idx="1"/>
+          </p:cNvCxnSpPr>
           <p:nvPr/>
-        </p:nvSpPr>
+        </p:nvCxnSpPr>
         <p:spPr>
           <a:xfrm>
-            <a:off x="6324532" y="3060949"/>
-            <a:ext cx="1685026" cy="615553"/>
+            <a:off x="6336113" y="5515071"/>
+            <a:ext cx="1255152" cy="0"/>
           </a:xfrm>
-          <a:prstGeom prst="rect">
+          <a:prstGeom prst="straightConnector1">
             <a:avLst/>
           </a:prstGeom>
-          <a:noFill/>
+          <a:ln w="19050" cap="flat" cmpd="sng" algn="ctr">
+            <a:solidFill>
+              <a:schemeClr val="accent2"/>
+            </a:solidFill>
+            <a:prstDash val="solid"/>
+            <a:round/>
+            <a:headEnd type="none" w="med" len="med"/>
+            <a:tailEnd type="arrow" w="med" len="med"/>
+          </a:ln>
         </p:spPr>
-        <p:txBody>
-          <a:bodyPr wrap="square" rtlCol="0">
-            <a:spAutoFit/>
-          </a:bodyPr>
-          <a:lstStyle/>
-          <a:p>
-            <a:r>
-              <a:rPr lang="en-SG" sz="1700" dirty="0"/>
-              <a:t>Pre-processing</a:t>
-            </a:r>
-          </a:p>
-        </p:txBody>
-      </p:sp>
-      <p:sp>
-        <p:nvSpPr>
-          <p:cNvPr id="50" name="TextBox 49">
-            <a:extLst>
-              <a:ext uri="{FF2B5EF4-FFF2-40B4-BE49-F238E27FC236}">
-                <a16:creationId xmlns:a16="http://schemas.microsoft.com/office/drawing/2014/main" id="{EEFCA747-8D72-04FC-A8D8-1B699871D0F4}"/>
-              </a:ext>
-            </a:extLst>
-          </p:cNvPr>
-          <p:cNvSpPr txBox="1"/>
-          <p:nvPr/>
-        </p:nvSpPr>
-        <p:spPr>
-          <a:xfrm>
-            <a:off x="3220835" y="3274249"/>
-            <a:ext cx="845103" cy="369332"/>
-          </a:xfrm>
-          <a:prstGeom prst="rect">
-            <a:avLst/>
-          </a:prstGeom>
-          <a:noFill/>
-        </p:spPr>
-        <p:txBody>
-          <a:bodyPr wrap="none" rtlCol="0">
-            <a:spAutoFit/>
-          </a:bodyPr>
-          <a:lstStyle/>
-          <a:p>
-            <a:r>
-              <a:rPr lang="en-SG" dirty="0"/>
-              <a:t>Result</a:t>
-            </a:r>
-          </a:p>
-        </p:txBody>
-      </p:sp>
+        <p:style>
+          <a:lnRef idx="0">
+            <a:scrgbClr r="0" g="0" b="0"/>
+          </a:lnRef>
+          <a:fillRef idx="0">
+            <a:scrgbClr r="0" g="0" b="0"/>
+          </a:fillRef>
+          <a:effectRef idx="0">
+            <a:scrgbClr r="0" g="0" b="0"/>
+          </a:effectRef>
+          <a:fontRef idx="minor">
+            <a:schemeClr val="tx1"/>
+          </a:fontRef>
+        </p:style>
+      </p:cxnSp>
     </p:spTree>
     <p:extLst>
       <p:ext uri="{BB962C8B-B14F-4D97-AF65-F5344CB8AC3E}">
@@ -37307,7 +37299,7 @@
           <a:p>
             <a:fld id="{927C0DEB-4AE1-EA4D-826D-E3C22802B942}" type="datetime1">
               <a:rPr lang="en-US" smtClean="0"/>
-              <a:t>7/20/2026</a:t>
+              <a:t>7/27/2026</a:t>
             </a:fld>
             <a:endParaRPr lang="en-US" dirty="0"/>
           </a:p>
@@ -38188,26 +38180,6 @@
 </file>
 
 <file path=customXml/item1.xml><?xml version="1.0" encoding="utf-8"?>
-<p:properties xmlns:p="http://schemas.microsoft.com/office/2006/metadata/properties" xmlns:xsi="http://www.w3.org/2001/XMLSchema-instance" xmlns:pc="http://schemas.microsoft.com/office/infopath/2007/PartnerControls">
-  <documentManagement>
-    <_ip_UnifiedCompliancePolicyUIAction xmlns="http://schemas.microsoft.com/sharepoint/v3" xsi:nil="true"/>
-    <Image xmlns="71af3243-3dd4-4a8d-8c0d-dd76da1f02a5">
-      <Url xsi:nil="true"/>
-      <Description xsi:nil="true"/>
-    </Image>
-    <Status xmlns="71af3243-3dd4-4a8d-8c0d-dd76da1f02a5">Not started</Status>
-    <Background xmlns="71af3243-3dd4-4a8d-8c0d-dd76da1f02a5">false</Background>
-    <_ip_UnifiedCompliancePolicyProperties xmlns="http://schemas.microsoft.com/sharepoint/v3" xsi:nil="true"/>
-    <ImageTagsTaxHTField xmlns="71af3243-3dd4-4a8d-8c0d-dd76da1f02a5">
-      <Terms xmlns="http://schemas.microsoft.com/office/infopath/2007/PartnerControls"/>
-    </ImageTagsTaxHTField>
-    <TaxCatchAll xmlns="230e9df3-be65-4c73-a93b-d1236ebd677e" xsi:nil="true"/>
-    <MediaServiceKeyPoints xmlns="71af3243-3dd4-4a8d-8c0d-dd76da1f02a5" xsi:nil="true"/>
-  </documentManagement>
-</p:properties>
-</file>
-
-<file path=customXml/item2.xml><?xml version="1.0" encoding="utf-8"?>
 <ct:contentTypeSchema xmlns:ct="http://schemas.microsoft.com/office/2006/metadata/contentType" xmlns:ma="http://schemas.microsoft.com/office/2006/metadata/properties/metaAttributes" ct:_="" ma:_="" ma:contentTypeName="Document" ma:contentTypeID="0x01010079F111ED35F8CC479449609E8A0923A6" ma:contentTypeVersion="30" ma:contentTypeDescription="Create a new document." ma:contentTypeScope="" ma:versionID="cec0622158e8f13124e9e8fd4de31bd1">
   <xsd:schema xmlns:xsd="http://www.w3.org/2001/XMLSchema" xmlns:xs="http://www.w3.org/2001/XMLSchema" xmlns:p="http://schemas.microsoft.com/office/2006/metadata/properties" xmlns:ns1="http://schemas.microsoft.com/sharepoint/v3" xmlns:ns2="71af3243-3dd4-4a8d-8c0d-dd76da1f02a5" xmlns:ns3="16c05727-aa75-4e4a-9b5f-8a80a1165891" xmlns:ns4="230e9df3-be65-4c73-a93b-d1236ebd677e" targetNamespace="http://schemas.microsoft.com/office/2006/metadata/properties" ma:root="true" ma:fieldsID="3b52f30ab005d15df08657af532e6e38" ns1:_="" ns2:_="" ns3:_="" ns4:_="">
     <xsd:import namespace="http://schemas.microsoft.com/sharepoint/v3"/>
@@ -38525,6 +38497,26 @@
 </ct:contentTypeSchema>
 </file>
 
+<file path=customXml/item2.xml><?xml version="1.0" encoding="utf-8"?>
+<p:properties xmlns:p="http://schemas.microsoft.com/office/2006/metadata/properties" xmlns:xsi="http://www.w3.org/2001/XMLSchema-instance" xmlns:pc="http://schemas.microsoft.com/office/infopath/2007/PartnerControls">
+  <documentManagement>
+    <_ip_UnifiedCompliancePolicyUIAction xmlns="http://schemas.microsoft.com/sharepoint/v3" xsi:nil="true"/>
+    <Image xmlns="71af3243-3dd4-4a8d-8c0d-dd76da1f02a5">
+      <Url xsi:nil="true"/>
+      <Description xsi:nil="true"/>
+    </Image>
+    <Status xmlns="71af3243-3dd4-4a8d-8c0d-dd76da1f02a5">Not started</Status>
+    <Background xmlns="71af3243-3dd4-4a8d-8c0d-dd76da1f02a5">false</Background>
+    <_ip_UnifiedCompliancePolicyProperties xmlns="http://schemas.microsoft.com/sharepoint/v3" xsi:nil="true"/>
+    <ImageTagsTaxHTField xmlns="71af3243-3dd4-4a8d-8c0d-dd76da1f02a5">
+      <Terms xmlns="http://schemas.microsoft.com/office/infopath/2007/PartnerControls"/>
+    </ImageTagsTaxHTField>
+    <TaxCatchAll xmlns="230e9df3-be65-4c73-a93b-d1236ebd677e" xsi:nil="true"/>
+    <MediaServiceKeyPoints xmlns="71af3243-3dd4-4a8d-8c0d-dd76da1f02a5" xsi:nil="true"/>
+  </documentManagement>
+</p:properties>
+</file>
+
 <file path=customXml/item3.xml><?xml version="1.0" encoding="utf-8"?>
 <?mso-contentType ?>
 <FormTemplates xmlns="http://schemas.microsoft.com/sharepoint/v3/contenttype/forms">
@@ -38535,25 +38527,6 @@
 </file>
 
 <file path=customXml/itemProps1.xml><?xml version="1.0" encoding="utf-8"?>
-<ds:datastoreItem xmlns:ds="http://schemas.openxmlformats.org/officeDocument/2006/customXml" ds:itemID="{D1CEDABF-7176-4A42-8EF9-E5D4DD31FF6C}">
-  <ds:schemaRefs>
-    <ds:schemaRef ds:uri="http://schemas.microsoft.com/office/infopath/2007/PartnerControls"/>
-    <ds:schemaRef ds:uri="http://purl.org/dc/terms/"/>
-    <ds:schemaRef ds:uri="http://schemas.microsoft.com/office/2006/metadata/properties"/>
-    <ds:schemaRef ds:uri="http://schemas.microsoft.com/office/2006/documentManagement/types"/>
-    <ds:schemaRef ds:uri="http://purl.org/dc/dcmitype/"/>
-    <ds:schemaRef ds:uri="http://schemas.openxmlformats.org/package/2006/metadata/core-properties"/>
-    <ds:schemaRef ds:uri="http://www.w3.org/XML/1998/namespace"/>
-    <ds:schemaRef ds:uri="230e9df3-be65-4c73-a93b-d1236ebd677e"/>
-    <ds:schemaRef ds:uri="http://purl.org/dc/elements/1.1/"/>
-    <ds:schemaRef ds:uri="16c05727-aa75-4e4a-9b5f-8a80a1165891"/>
-    <ds:schemaRef ds:uri="71af3243-3dd4-4a8d-8c0d-dd76da1f02a5"/>
-    <ds:schemaRef ds:uri="http://schemas.microsoft.com/sharepoint/v3"/>
-  </ds:schemaRefs>
-</ds:datastoreItem>
-</file>
-
-<file path=customXml/itemProps2.xml><?xml version="1.0" encoding="utf-8"?>
 <ds:datastoreItem xmlns:ds="http://schemas.openxmlformats.org/officeDocument/2006/customXml" ds:itemID="{9EEC3793-C1BC-496C-A03C-202DFFC513D6}">
   <ds:schemaRefs>
     <ds:schemaRef ds:uri="http://schemas.microsoft.com/office/2006/metadata/contentType"/>
@@ -38574,6 +38547,25 @@
 </ds:datastoreItem>
 </file>
 
+<file path=customXml/itemProps2.xml><?xml version="1.0" encoding="utf-8"?>
+<ds:datastoreItem xmlns:ds="http://schemas.openxmlformats.org/officeDocument/2006/customXml" ds:itemID="{D1CEDABF-7176-4A42-8EF9-E5D4DD31FF6C}">
+  <ds:schemaRefs>
+    <ds:schemaRef ds:uri="http://schemas.microsoft.com/office/infopath/2007/PartnerControls"/>
+    <ds:schemaRef ds:uri="http://purl.org/dc/terms/"/>
+    <ds:schemaRef ds:uri="http://schemas.microsoft.com/office/2006/metadata/properties"/>
+    <ds:schemaRef ds:uri="http://schemas.microsoft.com/office/2006/documentManagement/types"/>
+    <ds:schemaRef ds:uri="http://purl.org/dc/dcmitype/"/>
+    <ds:schemaRef ds:uri="http://schemas.openxmlformats.org/package/2006/metadata/core-properties"/>
+    <ds:schemaRef ds:uri="http://www.w3.org/XML/1998/namespace"/>
+    <ds:schemaRef ds:uri="230e9df3-be65-4c73-a93b-d1236ebd677e"/>
+    <ds:schemaRef ds:uri="http://purl.org/dc/elements/1.1/"/>
+    <ds:schemaRef ds:uri="16c05727-aa75-4e4a-9b5f-8a80a1165891"/>
+    <ds:schemaRef ds:uri="71af3243-3dd4-4a8d-8c0d-dd76da1f02a5"/>
+    <ds:schemaRef ds:uri="http://schemas.microsoft.com/sharepoint/v3"/>
+  </ds:schemaRefs>
+</ds:datastoreItem>
+</file>
+
 <file path=customXml/itemProps3.xml><?xml version="1.0" encoding="utf-8"?>
 <ds:datastoreItem xmlns:ds="http://schemas.openxmlformats.org/officeDocument/2006/customXml" ds:itemID="{D3301439-688F-4D19-B908-B48B62C56078}">
   <ds:schemaRefs>

</xml_diff>